<commit_message>
Rajout du admin-dashboard et qlq modification dans agent-dashboard
</commit_message>
<xml_diff>
--- a/Sources/Conception et developpement d'une application de gestion d'assurance automobile - soutenance.pptx
+++ b/Sources/Conception et developpement d'une application de gestion d'assurance automobile - soutenance.pptx
@@ -5,7 +5,7 @@
     <p:sldMasterId id="2147483648" r:id="rId1"/>
   </p:sldMasterIdLst>
   <p:notesMasterIdLst>
-    <p:notesMasterId r:id="rId26"/>
+    <p:notesMasterId r:id="rId27"/>
   </p:notesMasterIdLst>
   <p:sldIdLst>
     <p:sldId id="275" r:id="rId2"/>
@@ -20,18 +20,19 @@
     <p:sldId id="263" r:id="rId11"/>
     <p:sldId id="264" r:id="rId12"/>
     <p:sldId id="265" r:id="rId13"/>
-    <p:sldId id="266" r:id="rId14"/>
-    <p:sldId id="267" r:id="rId15"/>
-    <p:sldId id="283" r:id="rId16"/>
-    <p:sldId id="268" r:id="rId17"/>
-    <p:sldId id="280" r:id="rId18"/>
-    <p:sldId id="269" r:id="rId19"/>
-    <p:sldId id="270" r:id="rId20"/>
-    <p:sldId id="271" r:id="rId21"/>
-    <p:sldId id="282" r:id="rId22"/>
-    <p:sldId id="273" r:id="rId23"/>
-    <p:sldId id="284" r:id="rId24"/>
-    <p:sldId id="281" r:id="rId25"/>
+    <p:sldId id="286" r:id="rId14"/>
+    <p:sldId id="266" r:id="rId15"/>
+    <p:sldId id="267" r:id="rId16"/>
+    <p:sldId id="283" r:id="rId17"/>
+    <p:sldId id="268" r:id="rId18"/>
+    <p:sldId id="280" r:id="rId19"/>
+    <p:sldId id="269" r:id="rId20"/>
+    <p:sldId id="270" r:id="rId21"/>
+    <p:sldId id="271" r:id="rId22"/>
+    <p:sldId id="282" r:id="rId23"/>
+    <p:sldId id="273" r:id="rId24"/>
+    <p:sldId id="284" r:id="rId25"/>
+    <p:sldId id="281" r:id="rId26"/>
   </p:sldIdLst>
   <p:sldSz cx="12192000" cy="6858000"/>
   <p:notesSz cx="6858000" cy="12192000"/>
@@ -148,6 +149,7 @@
             <p14:sldId id="263"/>
             <p14:sldId id="264"/>
             <p14:sldId id="265"/>
+            <p14:sldId id="286"/>
           </p14:sldIdLst>
         </p14:section>
         <p14:section name="Partie 2" id="{B1B7BF0A-BC74-CF3C-6884-14064C33E22B}">
@@ -8336,7 +8338,7 @@
           <a:p>
             <a:r>
               <a:rPr lang="" dirty="0"/>
-              <a:t>Suite à l'analyse menée sur le terrain, nous avons dressé un bilan critique de l'existant. Ce slide résume les dysfonctionnements majeurs qui justifient notre projet, ainsi que les forces à préserver.</a:t>
+              <a:t>Suite à l'analyse menée sur le terrain, j’ai dressé un bilan critique de l'existant. Ce slide résume les dysfonctionnements majeurs qui justifient notre projet, ainsi que les forces à préserver.</a:t>
             </a:r>
           </a:p>
           <a:p>
@@ -8450,10 +8452,6 @@
           <a:lstStyle/>
           <a:p>
             <a:r>
-              <a:rPr lang="" dirty="0"/>
-              <a:t>Pour la comparaisons des solutions, sur le plan financier et logistique, l'Application Web l'emporte largement. Son </a:t>
-            </a:r>
-            <a:r>
               <a:rPr lang="" sz="1200" b="1" u="none" strike="noStrike" kern="1200" dirty="0">
                 <a:solidFill>
                   <a:schemeClr val="tx1"/>
@@ -8463,11 +8461,20 @@
                 <a:ea typeface="+mn-ea"/>
                 <a:cs typeface="+mn-cs"/>
               </a:rPr>
-              <a:t>coût initial</a:t>
+              <a:t>J'ai synthétisé ici une comparaison entre les deux solutions envisagées</a:t>
             </a:r>
             <a:r>
               <a:rPr lang="" dirty="0"/>
-              <a:t> est modéré puisque nous exploitons une stack open-source. Le </a:t>
+              <a:t> pour guider notre prise de décision.</a:t>
+            </a:r>
+          </a:p>
+          <a:p>
+            <a:endParaRPr lang="" dirty="0"/>
+          </a:p>
+          <a:p>
+            <a:r>
+              <a:rPr lang="" dirty="0"/>
+              <a:t>Pour la comparaisons des solutions, sur le plan financier et logistique, l'Application Web l'emporte largement. Son </a:t>
             </a:r>
             <a:r>
               <a:rPr lang="" sz="1200" b="1" u="none" strike="noStrike" kern="1200" dirty="0">
@@ -8479,20 +8486,11 @@
                 <a:ea typeface="+mn-ea"/>
                 <a:cs typeface="+mn-cs"/>
               </a:rPr>
-              <a:t>matériel nécessaire</a:t>
+              <a:t>coût initial</a:t>
             </a:r>
             <a:r>
               <a:rPr lang="" dirty="0"/>
-              <a:t> se limite au parc informatique existant : un simple navigateur web suffit pour y accéder, sans aucune installation locale. À l'inverse, le Logiciel Desktop exige un déploiement lourd, machine par machine, ce qui complique l'harmonisation des versions au sein de l'agence.</a:t>
-            </a:r>
-          </a:p>
-          <a:p>
-            <a:endParaRPr lang="" dirty="0"/>
-          </a:p>
-          <a:p>
-            <a:r>
-              <a:rPr lang="" dirty="0"/>
-              <a:t>Ensuite, concernant l'aspect fonctionnel et humain, l'assurance automobile impose un suivi strict des échéances. L'application Web permet une </a:t>
+              <a:t> est modéré puisque j’ai exploité une stack open-source. Le </a:t>
             </a:r>
             <a:r>
               <a:rPr lang="" sz="1200" b="1" u="none" strike="noStrike" kern="1200" dirty="0">
@@ -8504,11 +8502,20 @@
                 <a:ea typeface="+mn-ea"/>
                 <a:cs typeface="+mn-cs"/>
               </a:rPr>
-              <a:t>gestion des alertes</a:t>
+              <a:t>matériel nécessaire</a:t>
             </a:r>
             <a:r>
               <a:rPr lang="" dirty="0"/>
-              <a:t> centralisée et dynamique, capable de déclencher des tâches de fond automatisées (comme l'envoi autonome d'e-mails de relance aux clients). Côté </a:t>
+              <a:t> se limite au parc informatique existant : un simple navigateur web suffit pour y accéder, sans aucune installation locale. À l'inverse, le Logiciel Desktop exige un déploiement lourd, machine par machine, ce qui complique l'harmonisation des versions au sein de l'agence.</a:t>
+            </a:r>
+          </a:p>
+          <a:p>
+            <a:endParaRPr lang="" dirty="0"/>
+          </a:p>
+          <a:p>
+            <a:r>
+              <a:rPr lang="" dirty="0"/>
+              <a:t>Ensuite, concernant l'aspect fonctionnel et humain, l'assurance automobile impose un suivi strict des échéances. L'application Web permet une </a:t>
             </a:r>
             <a:r>
               <a:rPr lang="" sz="1200" b="1" u="none" strike="noStrike" kern="1200" dirty="0">
@@ -8520,6 +8527,22 @@
                 <a:ea typeface="+mn-ea"/>
                 <a:cs typeface="+mn-cs"/>
               </a:rPr>
+              <a:t>gestion des alertes</a:t>
+            </a:r>
+            <a:r>
+              <a:rPr lang="" dirty="0"/>
+              <a:t> centralisée et dynamique, capable de déclencher des tâches de fond automatisées. Côté </a:t>
+            </a:r>
+            <a:r>
+              <a:rPr lang="" sz="1200" b="1" u="none" strike="noStrike" kern="1200" dirty="0">
+                <a:solidFill>
+                  <a:schemeClr val="tx1"/>
+                </a:solidFill>
+                <a:effectLst/>
+                <a:latin typeface="+mn-lt"/>
+                <a:ea typeface="+mn-ea"/>
+                <a:cs typeface="+mn-cs"/>
+              </a:rPr>
               <a:t>charges humaines</a:t>
             </a:r>
             <a:r>
@@ -8533,7 +8556,7 @@
           <a:p>
             <a:r>
               <a:rPr lang="" dirty="0"/>
-              <a:t>C’est l’ensemble de ces arguments technico-économiques qui nous a naturellement conduits à retenir la </a:t>
+              <a:t>C’est l’ensemble de ces arguments technico-économiques qui ma naturellement conduits à retenir la </a:t>
             </a:r>
             <a:r>
               <a:rPr lang="" sz="1200" b="1" u="none" strike="noStrike" kern="1200" dirty="0">
@@ -8637,7 +8660,7 @@
           <a:p>
             <a:r>
               <a:rPr lang="" dirty="0"/>
-              <a:t>Au terme de notre étude comparative, la solution d'une application web sur-mesure s'est imposée comme le choix technologique le plus stratégique pour AUXIMAD. Ce slide présente les raisons de ce choix ainsi que notre écosystème technique.</a:t>
+              <a:t>Au terme de l’étude comparative, la solution d'une application web sur-mesure s'est imposée comme le choix technologique le plus stratégique pour AUXIMAD. Ce slide présente les raisons de ce choix ainsi que notre écosystème technique.</a:t>
             </a:r>
           </a:p>
           <a:p>
@@ -8703,7 +8726,7 @@
           <a:p>
             <a:r>
               <a:rPr lang="" dirty="0"/>
-              <a:t>Deuxièmement, pour concrétiser cette solution, nous avons arrêté une pile technologique moderne et robuste.</a:t>
+              <a:t>Deuxièmement, pour concrétiser cette solution, je me suis arrêté sur une pile technologique moderne et robuste.</a:t>
             </a:r>
           </a:p>
           <a:p>
@@ -8713,7 +8736,7 @@
             </a:pPr>
             <a:r>
               <a:rPr lang="" dirty="0"/>
-              <a:t>Pour la couche de présentation (le Frontend), nous utilisons </a:t>
+              <a:t>Pour la couche de présentation (le Frontend), j’ai utilisé </a:t>
             </a:r>
             <a:r>
               <a:rPr lang="" sz="1200" b="1" u="none" strike="noStrike" kern="1200" dirty="0">
@@ -8868,7 +8891,7 @@
       </p:grpSpPr>
       <p:sp>
         <p:nvSpPr>
-          <p:cNvPr id="2" name="Slide Image Placeholder 1"/>
+          <p:cNvPr id="2" name="Espace réservé de l'image des diapositives 1"/>
           <p:cNvSpPr>
             <a:spLocks noGrp="1" noRot="1" noChangeAspect="1"/>
           </p:cNvSpPr>
@@ -8876,11 +8899,25 @@
             <p:ph type="sldImg"/>
           </p:nvPr>
         </p:nvSpPr>
-        <p:spPr/>
-      </p:sp>
-      <p:sp>
-        <p:nvSpPr>
-          <p:cNvPr id="3" name="Notes Placeholder 2"/>
+        <p:spPr>
+          <a:xfrm>
+            <a:off x="-228600" y="1524000"/>
+            <a:ext cx="7315200" cy="4114800"/>
+          </a:xfrm>
+          <a:prstGeom prst="rect">
+            <a:avLst/>
+          </a:prstGeom>
+          <a:noFill/>
+          <a:ln w="12700">
+            <a:solidFill>
+              <a:prstClr val="black"/>
+            </a:solidFill>
+          </a:ln>
+        </p:spPr>
+      </p:sp>
+      <p:sp>
+        <p:nvSpPr>
+          <p:cNvPr id="3" name="Espace réservé des notes 2"/>
           <p:cNvSpPr>
             <a:spLocks noGrp="1"/>
           </p:cNvSpPr>
@@ -8888,45 +8925,92 @@
             <p:ph type="body" idx="1"/>
           </p:nvPr>
         </p:nvSpPr>
-        <p:spPr/>
+        <p:spPr>
+          <a:xfrm>
+            <a:off x="685800" y="5867400"/>
+            <a:ext cx="5486400" cy="4800600"/>
+          </a:xfrm>
+          <a:prstGeom prst="rect">
+            <a:avLst/>
+          </a:prstGeom>
+        </p:spPr>
         <p:txBody>
           <a:bodyPr/>
           <a:lstStyle/>
           <a:p>
+            <a:pPr rtl="0"/>
             <a:r>
               <a:rPr lang="" dirty="0"/>
-              <a:t>Nous abordons à présent la deuxième partie de notre présentation, dédiée à l’Étude détaillée et à la modélisation UML de notre système.</a:t>
-            </a:r>
-          </a:p>
-        </p:txBody>
-      </p:sp>
-      <p:sp>
-        <p:nvSpPr>
-          <p:cNvPr id="4" name="Slide Number Placeholder 3"/>
-          <p:cNvSpPr>
-            <a:spLocks noGrp="1"/>
-          </p:cNvSpPr>
-          <p:nvPr>
-            <p:ph type="sldNum" sz="quarter" idx="10"/>
-          </p:nvPr>
-        </p:nvSpPr>
-        <p:spPr/>
-        <p:txBody>
-          <a:bodyPr/>
-          <a:lstStyle/>
-          <a:p>
-            <a:fld id="{F7021451-1387-4CA6-816F-3879F97B5CBC}" type="slidenum">
-              <a:rPr lang="en-US"/>
-              <a:t>13</a:t>
-            </a:fld>
-            <a:endParaRPr lang="en-US"/>
+              <a:t>Ce diagramme de Gantt présente le déroulement de mon projet sur 9 semaines, du 13 août au 13 octobre 2026. Il suit les grandes étapes de mon mémoire.</a:t>
+            </a:r>
+          </a:p>
+          <a:p>
+            <a:pPr rtl="0"/>
+            <a:endParaRPr lang="" dirty="0"/>
+          </a:p>
+          <a:p>
+            <a:pPr rtl="0"/>
+            <a:r>
+              <a:rPr lang="" dirty="0"/>
+              <a:t>Le projet a commencé par l’analyse préalable : la découverte de la société et de l’existant, puis l’étude préalable avec le diagnostic, le dossier des choix et le choix de la solution, et enfin le cahier des charges de la solution retenue. Ces trois tâches se chevauchent légèrement, ce qui m’a permis d’avancer sans attendre la fin de chacune.</a:t>
+            </a:r>
+          </a:p>
+          <a:p>
+            <a:pPr rtl="0"/>
+            <a:endParaRPr lang="" dirty="0"/>
+          </a:p>
+          <a:p>
+            <a:pPr rtl="0"/>
+            <a:r>
+              <a:rPr lang="" dirty="0"/>
+              <a:t>Vient ensuite la conception UML, avec les diagrammes de cas d’utilisation, de séquence, d’activité et de classes. Le développement du backend a démarré en parallèle, dès que les bases de la conception étaient posées.</a:t>
+            </a:r>
+          </a:p>
+          <a:p>
+            <a:pPr rtl="0"/>
+            <a:r>
+              <a:rPr lang="" dirty="0"/>
+              <a:t>La phase de réalisation a été la plus longue du projet. Le backend s’est étendu jusqu’à début octobre, et le frontend a démarré à mi-parcours avant de se terminer autour du 9 octobre. Le développement m’a pris plus de temps que prévu, ce qui a un peu réduit la marge pour la suite.</a:t>
+            </a:r>
+          </a:p>
+          <a:p>
+            <a:pPr rtl="0"/>
+            <a:endParaRPr lang="" dirty="0"/>
+          </a:p>
+          <a:p>
+            <a:pPr rtl="0"/>
+            <a:r>
+              <a:rPr lang="" dirty="0"/>
+              <a:t>Les tests et corrections se sont donc déroulés en fin de projet, en même temps que le manuel utilisateur.</a:t>
+            </a:r>
+          </a:p>
+          <a:p>
+            <a:pPr rtl="0"/>
+            <a:r>
+              <a:rPr lang="" dirty="0"/>
+              <a:t>Enfin, la rédaction du mémoire s’étend sur presque toute la durée du projet. Je l’ai écrite au fil de l’avancement, et la relecture et la finalisation occupent le dernier jour.</a:t>
+            </a:r>
+          </a:p>
+          <a:p>
+            <a:pPr rtl="0"/>
+            <a:endParaRPr lang="" dirty="0"/>
+          </a:p>
+          <a:p>
+            <a:pPr rtl="0"/>
+            <a:r>
+              <a:rPr lang="" dirty="0"/>
+              <a:t>En résumé, le projet est organisé en quatre grandes phases : analyse, conception, réalisation et rédaction, avec un développement qui a été le gros du travail.</a:t>
+            </a:r>
+          </a:p>
+          <a:p>
+            <a:endParaRPr lang="LID4096" dirty="0"/>
           </a:p>
         </p:txBody>
       </p:sp>
     </p:spTree>
     <p:extLst>
       <p:ext uri="{BB962C8B-B14F-4D97-AF65-F5344CB8AC3E}">
-        <p14:creationId xmlns:p14="http://schemas.microsoft.com/office/powerpoint/2010/main" val="1024086991"/>
+        <p14:creationId xmlns:p14="http://schemas.microsoft.com/office/powerpoint/2010/main" val="1119131637"/>
       </p:ext>
     </p:extLst>
   </p:cSld>
@@ -8982,116 +9066,8 @@
           <a:p>
             <a:r>
               <a:rPr lang="" dirty="0"/>
-              <a:t>Pour garantir la robustesse et la pérennité de l'application </a:t>
-            </a:r>
-            <a:r>
-              <a:rPr lang="" sz="1200" b="1" u="none" strike="noStrike" kern="1200" dirty="0">
-                <a:solidFill>
-                  <a:schemeClr val="tx1"/>
-                </a:solidFill>
-                <a:effectLst/>
-                <a:latin typeface="+mn-lt"/>
-                <a:ea typeface="+mn-ea"/>
-                <a:cs typeface="+mn-cs"/>
-              </a:rPr>
-              <a:t>AUXIDRIVE</a:t>
-            </a:r>
-            <a:r>
-              <a:rPr lang="" dirty="0"/>
-              <a:t>, nous avons adopté une démarche orientée objet à l’aide du langage de modélisation standardisé UML. Cette étape essentielle nous a permis de traduire toutes les règles complexes du secteur de l'assurance automobile en modèles logiques rigoureux avant d'attaquer la phase de codage.</a:t>
-            </a:r>
-          </a:p>
-          <a:p>
-            <a:endParaRPr lang="" dirty="0"/>
-          </a:p>
-          <a:p>
-            <a:r>
-              <a:rPr lang="" dirty="0"/>
-              <a:t>Afin de structurer au mieux le système, nous avons conçu une suite complète de diagrammes. Nous avons d'abord isolé les droits de chaque utilisateur avec le </a:t>
-            </a:r>
-            <a:r>
-              <a:rPr lang="" sz="1200" b="1" u="none" strike="noStrike" kern="1200" dirty="0">
-                <a:solidFill>
-                  <a:schemeClr val="tx1"/>
-                </a:solidFill>
-                <a:effectLst/>
-                <a:latin typeface="+mn-lt"/>
-                <a:ea typeface="+mn-ea"/>
-                <a:cs typeface="+mn-cs"/>
-              </a:rPr>
-              <a:t>diagramme de cas d'utilisation</a:t>
-            </a:r>
-            <a:r>
-              <a:rPr lang="" dirty="0"/>
-              <a:t>, modélisé la chronologie des processus critiques comme l'inscription ou la souscription de flotte avec les </a:t>
-            </a:r>
-            <a:r>
-              <a:rPr lang="" sz="1200" b="1" u="none" strike="noStrike" kern="1200" dirty="0">
-                <a:solidFill>
-                  <a:schemeClr val="tx1"/>
-                </a:solidFill>
-                <a:effectLst/>
-                <a:latin typeface="+mn-lt"/>
-                <a:ea typeface="+mn-ea"/>
-                <a:cs typeface="+mn-cs"/>
-              </a:rPr>
-              <a:t>diagrammes de séquence</a:t>
-            </a:r>
-            <a:r>
-              <a:rPr lang="" dirty="0"/>
-              <a:t>, et posé la structure de notre base de données grâce au </a:t>
-            </a:r>
-            <a:r>
-              <a:rPr lang="" sz="1200" b="1" u="none" strike="noStrike" kern="1200" dirty="0">
-                <a:solidFill>
-                  <a:schemeClr val="tx1"/>
-                </a:solidFill>
-                <a:effectLst/>
-                <a:latin typeface="+mn-lt"/>
-                <a:ea typeface="+mn-ea"/>
-                <a:cs typeface="+mn-cs"/>
-              </a:rPr>
-              <a:t>diagramme de classes</a:t>
-            </a:r>
-            <a:r>
-              <a:rPr lang="" dirty="0"/>
-              <a:t>.</a:t>
-            </a:r>
-          </a:p>
-          <a:p>
-            <a:endParaRPr lang="" dirty="0"/>
-          </a:p>
-          <a:p>
-            <a:r>
-              <a:rPr lang="" dirty="0"/>
-              <a:t>Afin d'optimiser le temps imparti pour cette présentation orale et d'aller directement à l'essentiel de notre réalisation, </a:t>
-            </a:r>
-            <a:r>
-              <a:rPr lang="" sz="1200" b="1" u="none" strike="noStrike" kern="1200" dirty="0">
-                <a:solidFill>
-                  <a:schemeClr val="tx1"/>
-                </a:solidFill>
-                <a:effectLst/>
-                <a:latin typeface="+mn-lt"/>
-                <a:ea typeface="+mn-ea"/>
-                <a:cs typeface="+mn-cs"/>
-              </a:rPr>
-              <a:t>l'intégralité des visuels et l'analyse détaillée étape par étape de ces diagrammes UML sont consignées dans notre mémoire à partir de la page 24</a:t>
-            </a:r>
-            <a:r>
-              <a:rPr lang="" dirty="0"/>
-              <a:t>. Je vous invite à vous y référer pour en examiner les spécificités techniques.</a:t>
-            </a:r>
-          </a:p>
-          <a:p>
-            <a:endParaRPr lang="" dirty="0"/>
-          </a:p>
-          <a:p>
-            <a:r>
-              <a:rPr lang="" dirty="0"/>
-              <a:t>Sans plus attendre, je vous propose de basculer vers la troisième grande partie de notre exposé, dédiée à la réalisation technique et concrète de l'application.</a:t>
-            </a:r>
-            <a:endParaRPr lang="en-US" dirty="0"/>
+              <a:t>Nous abordons à présent la deuxième partie de notre présentation, dédiée à l’Étude détaillée et à la modélisation UML de notre système.</a:t>
+            </a:r>
           </a:p>
         </p:txBody>
       </p:sp>
@@ -9132,6 +9108,201 @@
 </file>
 
 <file path=ppt/notesSlides/notesSlide15.xml><?xml version="1.0" encoding="utf-8"?>
+<p:notes xmlns:a="http://schemas.openxmlformats.org/drawingml/2006/main" xmlns:r="http://schemas.openxmlformats.org/officeDocument/2006/relationships" xmlns:p="http://schemas.openxmlformats.org/presentationml/2006/main">
+  <p:cSld>
+    <p:spTree>
+      <p:nvGrpSpPr>
+        <p:cNvPr id="1" name=""/>
+        <p:cNvGrpSpPr/>
+        <p:nvPr/>
+      </p:nvGrpSpPr>
+      <p:grpSpPr>
+        <a:xfrm>
+          <a:off x="0" y="0"/>
+          <a:ext cx="0" cy="0"/>
+          <a:chOff x="0" y="0"/>
+          <a:chExt cx="0" cy="0"/>
+        </a:xfrm>
+      </p:grpSpPr>
+      <p:sp>
+        <p:nvSpPr>
+          <p:cNvPr id="2" name="Slide Image Placeholder 1"/>
+          <p:cNvSpPr>
+            <a:spLocks noGrp="1" noRot="1" noChangeAspect="1"/>
+          </p:cNvSpPr>
+          <p:nvPr>
+            <p:ph type="sldImg"/>
+          </p:nvPr>
+        </p:nvSpPr>
+        <p:spPr/>
+      </p:sp>
+      <p:sp>
+        <p:nvSpPr>
+          <p:cNvPr id="3" name="Notes Placeholder 2"/>
+          <p:cNvSpPr>
+            <a:spLocks noGrp="1"/>
+          </p:cNvSpPr>
+          <p:nvPr>
+            <p:ph type="body" idx="1"/>
+          </p:nvPr>
+        </p:nvSpPr>
+        <p:spPr/>
+        <p:txBody>
+          <a:bodyPr/>
+          <a:lstStyle/>
+          <a:p>
+            <a:r>
+              <a:rPr lang="" dirty="0"/>
+              <a:t>Pour garantir la robustesse et la pérennité de l'application </a:t>
+            </a:r>
+            <a:r>
+              <a:rPr lang="" sz="1200" b="1" u="none" strike="noStrike" kern="1200" dirty="0">
+                <a:solidFill>
+                  <a:schemeClr val="tx1"/>
+                </a:solidFill>
+                <a:effectLst/>
+                <a:latin typeface="+mn-lt"/>
+                <a:ea typeface="+mn-ea"/>
+                <a:cs typeface="+mn-cs"/>
+              </a:rPr>
+              <a:t>AUXIDRIVE</a:t>
+            </a:r>
+            <a:r>
+              <a:rPr lang="" dirty="0"/>
+              <a:t>, j’ai adopté une démarche orientée objet à l’aide du langage de modélisation standardisé UML. Cette étape essentielle m’a permis de traduire toutes les règles complexes du secteur de l'assurance automobile en modèles logiques rigoureux avant d'attaquer la phase de codage.</a:t>
+            </a:r>
+          </a:p>
+          <a:p>
+            <a:endParaRPr lang="" dirty="0"/>
+          </a:p>
+          <a:p>
+            <a:r>
+              <a:rPr lang="" dirty="0"/>
+              <a:t>Afin de structurer au mieux le système, j’ai conçu une suite complète de diagrammes. J’ai d'abord isolé les droits de chaque utilisateur avec le </a:t>
+            </a:r>
+            <a:r>
+              <a:rPr lang="" sz="1200" b="1" u="none" strike="noStrike" kern="1200" dirty="0">
+                <a:solidFill>
+                  <a:schemeClr val="tx1"/>
+                </a:solidFill>
+                <a:effectLst/>
+                <a:latin typeface="+mn-lt"/>
+                <a:ea typeface="+mn-ea"/>
+                <a:cs typeface="+mn-cs"/>
+              </a:rPr>
+              <a:t>diagramme de cas d'utilisation</a:t>
+            </a:r>
+            <a:r>
+              <a:rPr lang="" dirty="0"/>
+              <a:t>, modélisé la chronologie des processus critiques comme l'inscription ou la souscription de flotte avec les </a:t>
+            </a:r>
+            <a:r>
+              <a:rPr lang="" sz="1200" b="1" u="none" strike="noStrike" kern="1200" dirty="0">
+                <a:solidFill>
+                  <a:schemeClr val="tx1"/>
+                </a:solidFill>
+                <a:effectLst/>
+                <a:latin typeface="+mn-lt"/>
+                <a:ea typeface="+mn-ea"/>
+                <a:cs typeface="+mn-cs"/>
+              </a:rPr>
+              <a:t>diagrammes de séquence</a:t>
+            </a:r>
+            <a:r>
+              <a:rPr lang="" dirty="0"/>
+              <a:t>, et posé la structure de notre base de données grâce au </a:t>
+            </a:r>
+            <a:r>
+              <a:rPr lang="" sz="1200" b="1" u="none" strike="noStrike" kern="1200" dirty="0">
+                <a:solidFill>
+                  <a:schemeClr val="tx1"/>
+                </a:solidFill>
+                <a:effectLst/>
+                <a:latin typeface="+mn-lt"/>
+                <a:ea typeface="+mn-ea"/>
+                <a:cs typeface="+mn-cs"/>
+              </a:rPr>
+              <a:t>diagramme de classes</a:t>
+            </a:r>
+            <a:r>
+              <a:rPr lang="" dirty="0"/>
+              <a:t>.</a:t>
+            </a:r>
+          </a:p>
+          <a:p>
+            <a:endParaRPr lang="" dirty="0"/>
+          </a:p>
+          <a:p>
+            <a:r>
+              <a:rPr lang="" dirty="0"/>
+              <a:t>Afin d'optimiser le temps imparti pour cette présentation orale et d'aller directement à l'essentiel de notre réalisation, </a:t>
+            </a:r>
+            <a:r>
+              <a:rPr lang="" sz="1200" b="1" u="none" strike="noStrike" kern="1200" dirty="0">
+                <a:solidFill>
+                  <a:schemeClr val="tx1"/>
+                </a:solidFill>
+                <a:effectLst/>
+                <a:latin typeface="+mn-lt"/>
+                <a:ea typeface="+mn-ea"/>
+                <a:cs typeface="+mn-cs"/>
+              </a:rPr>
+              <a:t>l'intégralité des visuels et l'analyse détaillée étape par étape de ces diagrammes UML sont consignées dans notre mémoire</a:t>
+            </a:r>
+            <a:r>
+              <a:rPr lang="" dirty="0"/>
+              <a:t>. Je vous invite à vous y référer pour en examiner les spécificités techniques.</a:t>
+            </a:r>
+          </a:p>
+          <a:p>
+            <a:endParaRPr lang="" dirty="0"/>
+          </a:p>
+          <a:p>
+            <a:r>
+              <a:rPr lang="" dirty="0"/>
+              <a:t>Sans plus attendre, je vous propose de basculer vers la troisième grande partie de notre exposé, dédiée à la réalisation technique et concrète de l'application.</a:t>
+            </a:r>
+            <a:endParaRPr lang="en-US" dirty="0"/>
+          </a:p>
+        </p:txBody>
+      </p:sp>
+      <p:sp>
+        <p:nvSpPr>
+          <p:cNvPr id="4" name="Slide Number Placeholder 3"/>
+          <p:cNvSpPr>
+            <a:spLocks noGrp="1"/>
+          </p:cNvSpPr>
+          <p:nvPr>
+            <p:ph type="sldNum" sz="quarter" idx="10"/>
+          </p:nvPr>
+        </p:nvSpPr>
+        <p:spPr/>
+        <p:txBody>
+          <a:bodyPr/>
+          <a:lstStyle/>
+          <a:p>
+            <a:fld id="{F7021451-1387-4CA6-816F-3879F97B5CBC}" type="slidenum">
+              <a:rPr lang="en-US"/>
+              <a:t>15</a:t>
+            </a:fld>
+            <a:endParaRPr lang="en-US"/>
+          </a:p>
+        </p:txBody>
+      </p:sp>
+    </p:spTree>
+    <p:extLst>
+      <p:ext uri="{BB962C8B-B14F-4D97-AF65-F5344CB8AC3E}">
+        <p14:creationId xmlns:p14="http://schemas.microsoft.com/office/powerpoint/2010/main" val="1024086991"/>
+      </p:ext>
+    </p:extLst>
+  </p:cSld>
+  <p:clrMapOvr>
+    <a:masterClrMapping/>
+  </p:clrMapOvr>
+</p:notes>
+</file>
+
+<file path=ppt/notesSlides/notesSlide16.xml><?xml version="1.0" encoding="utf-8"?>
 <p:notes xmlns:a="http://schemas.openxmlformats.org/drawingml/2006/main" xmlns:r="http://schemas.openxmlformats.org/officeDocument/2006/relationships" xmlns:p="http://schemas.openxmlformats.org/presentationml/2006/main">
   <p:cSld>
     <p:spTree>
@@ -9207,11 +9378,11 @@
                 <a:ea typeface="+mn-ea"/>
                 <a:cs typeface="+mn-cs"/>
               </a:rPr>
-              <a:t>AUXIASSUR</a:t>
+              <a:t>AUXIDRIVE</a:t>
             </a:r>
             <a:r>
               <a:rPr lang="" dirty="0"/>
-              <a:t>, nous avons adopté une démarche orientée objet à l’aide du langage de modélisation standardisé UML. Cette étape essentielle nous a permis de traduire toutes les règles complexes du secteur de l'assurance automobile en modèles logiques rigoureux avant d'attaquer la phase de codage.</a:t>
+              <a:t>, j’ai adopté une démarche orientée objet à l’aide du langage de modélisation standardisé UML. Cette étape essentielle m’a permis de traduire toutes les règles complexes du secteur de l'assurance automobile en modèles logiques rigoureux avant d'attaquer la phase de codage.</a:t>
             </a:r>
           </a:p>
           <a:p>
@@ -9220,7 +9391,7 @@
           <a:p>
             <a:r>
               <a:rPr lang="" dirty="0"/>
-              <a:t>Afin de structurer au mieux le système, nous avons conçu une suite complète de diagrammes. Nous avons d'abord isolé les droits de chaque utilisateur avec le </a:t>
+              <a:t>Afin de structurer au mieux le système, j’ai conçu une suite complète de diagrammes. J’ai d'abord isolé les droits de chaque utilisateur avec le </a:t>
             </a:r>
             <a:r>
               <a:rPr lang="" sz="1200" b="1" u="none" strike="noStrike" kern="1200" dirty="0">
@@ -9289,7 +9460,7 @@
                 <a:ea typeface="+mn-ea"/>
                 <a:cs typeface="+mn-cs"/>
               </a:rPr>
-              <a:t>l'intégralité des visuels et l'analyse détaillée étape par étape de ces diagrammes UML sont consignées dans notre mémoire à partir de la page 24</a:t>
+              <a:t>l'intégralité des visuels et l'analyse détaillée étape par étape de ces diagrammes UML sont consignées dans notre mémoire</a:t>
             </a:r>
             <a:r>
               <a:rPr lang="" dirty="0"/>
@@ -9331,7 +9502,7 @@
           <a:p>
             <a:fld id="{F7021451-1387-4CA6-816F-3879F97B5CBC}" type="slidenum">
               <a:rPr lang="en-US"/>
-              <a:t>15</a:t>
+              <a:t>16</a:t>
             </a:fld>
             <a:endParaRPr lang="en-US"/>
           </a:p>
@@ -9350,7 +9521,7 @@
 </p:notes>
 </file>
 
-<file path=ppt/notesSlides/notesSlide16.xml><?xml version="1.0" encoding="utf-8"?>
+<file path=ppt/notesSlides/notesSlide17.xml><?xml version="1.0" encoding="utf-8"?>
 <p:notes xmlns:a="http://schemas.openxmlformats.org/drawingml/2006/main" xmlns:r="http://schemas.openxmlformats.org/officeDocument/2006/relationships" xmlns:p="http://schemas.openxmlformats.org/presentationml/2006/main">
   <p:cSld>
     <p:spTree>
@@ -9415,7 +9586,7 @@
           <a:p>
             <a:fld id="{F7021451-1387-4CA6-816F-3879F97B5CBC}" type="slidenum">
               <a:rPr lang="en-US"/>
-              <a:t>16</a:t>
+              <a:t>17</a:t>
             </a:fld>
             <a:endParaRPr lang="en-US"/>
           </a:p>
@@ -9434,7 +9605,7 @@
 </p:notes>
 </file>
 
-<file path=ppt/notesSlides/notesSlide17.xml><?xml version="1.0" encoding="utf-8"?>
+<file path=ppt/notesSlides/notesSlide18.xml><?xml version="1.0" encoding="utf-8"?>
 <p:notes xmlns:a="http://schemas.openxmlformats.org/drawingml/2006/main" xmlns:r="http://schemas.openxmlformats.org/officeDocument/2006/relationships" xmlns:p="http://schemas.openxmlformats.org/presentationml/2006/main">
   <p:cSld>
     <p:spTree>
@@ -9523,7 +9694,7 @@
           <a:p>
             <a:fld id="{F7021451-1387-4CA6-816F-3879F97B5CBC}" type="slidenum">
               <a:rPr lang="en-US"/>
-              <a:t>17</a:t>
+              <a:t>18</a:t>
             </a:fld>
             <a:endParaRPr lang="en-US"/>
           </a:p>
@@ -9533,90 +9704,6 @@
     <p:extLst>
       <p:ext uri="{BB962C8B-B14F-4D97-AF65-F5344CB8AC3E}">
         <p14:creationId xmlns:p14="http://schemas.microsoft.com/office/powerpoint/2010/main" val="1239046805"/>
-      </p:ext>
-    </p:extLst>
-  </p:cSld>
-  <p:clrMapOvr>
-    <a:masterClrMapping/>
-  </p:clrMapOvr>
-</p:notes>
-</file>
-
-<file path=ppt/notesSlides/notesSlide18.xml><?xml version="1.0" encoding="utf-8"?>
-<p:notes xmlns:a="http://schemas.openxmlformats.org/drawingml/2006/main" xmlns:r="http://schemas.openxmlformats.org/officeDocument/2006/relationships" xmlns:p="http://schemas.openxmlformats.org/presentationml/2006/main">
-  <p:cSld>
-    <p:spTree>
-      <p:nvGrpSpPr>
-        <p:cNvPr id="1" name=""/>
-        <p:cNvGrpSpPr/>
-        <p:nvPr/>
-      </p:nvGrpSpPr>
-      <p:grpSpPr>
-        <a:xfrm>
-          <a:off x="0" y="0"/>
-          <a:ext cx="0" cy="0"/>
-          <a:chOff x="0" y="0"/>
-          <a:chExt cx="0" cy="0"/>
-        </a:xfrm>
-      </p:grpSpPr>
-      <p:sp>
-        <p:nvSpPr>
-          <p:cNvPr id="2" name="Slide Image Placeholder 1"/>
-          <p:cNvSpPr>
-            <a:spLocks noGrp="1" noRot="1" noChangeAspect="1"/>
-          </p:cNvSpPr>
-          <p:nvPr>
-            <p:ph type="sldImg"/>
-          </p:nvPr>
-        </p:nvSpPr>
-        <p:spPr/>
-      </p:sp>
-      <p:sp>
-        <p:nvSpPr>
-          <p:cNvPr id="3" name="Notes Placeholder 2"/>
-          <p:cNvSpPr>
-            <a:spLocks noGrp="1"/>
-          </p:cNvSpPr>
-          <p:nvPr>
-            <p:ph type="body" idx="1"/>
-          </p:nvPr>
-        </p:nvSpPr>
-        <p:spPr/>
-        <p:txBody>
-          <a:bodyPr/>
-          <a:lstStyle/>
-          <a:p>
-            <a:endParaRPr lang="en-US" dirty="0"/>
-          </a:p>
-        </p:txBody>
-      </p:sp>
-      <p:sp>
-        <p:nvSpPr>
-          <p:cNvPr id="4" name="Slide Number Placeholder 3"/>
-          <p:cNvSpPr>
-            <a:spLocks noGrp="1"/>
-          </p:cNvSpPr>
-          <p:nvPr>
-            <p:ph type="sldNum" sz="quarter" idx="10"/>
-          </p:nvPr>
-        </p:nvSpPr>
-        <p:spPr/>
-        <p:txBody>
-          <a:bodyPr/>
-          <a:lstStyle/>
-          <a:p>
-            <a:fld id="{F7021451-1387-4CA6-816F-3879F97B5CBC}" type="slidenum">
-              <a:rPr lang="en-US"/>
-              <a:t>18</a:t>
-            </a:fld>
-            <a:endParaRPr lang="en-US"/>
-          </a:p>
-        </p:txBody>
-      </p:sp>
-    </p:spTree>
-    <p:extLst>
-      <p:ext uri="{BB962C8B-B14F-4D97-AF65-F5344CB8AC3E}">
-        <p14:creationId xmlns:p14="http://schemas.microsoft.com/office/powerpoint/2010/main" val="1024086991"/>
       </p:ext>
     </p:extLst>
   </p:cSld>
@@ -9769,11 +9856,11 @@
                 <a:ea typeface="+mn-ea"/>
                 <a:cs typeface="+mn-cs"/>
               </a:rPr>
-              <a:t>AUXIASSUR</a:t>
+              <a:t>AUXIASSUR, </a:t>
             </a:r>
             <a:r>
               <a:rPr lang="" dirty="0"/>
-              <a:t> (qui opère en tant qu’Agent Général de la compagnie d'assurance ARO), l'assurance automobile représente une activité hautement stratégique couvrant la souscription, le suivi des renouvellements, la facturation et l'instruction des sinistres.</a:t>
+              <a:t>l'assurance automobile représente une activité hautement stratégique couvrant la souscription, le suivi des renouvellements, la facturation et l'instruction des sinistres.</a:t>
             </a:r>
           </a:p>
           <a:p>
@@ -9784,7 +9871,7 @@
             <a:pPr rtl="0"/>
             <a:r>
               <a:rPr lang="" dirty="0"/>
-              <a:t>Nous avons constaté que la gestion de ces opérations reposait encore en grande partie sur des supports physiques, des saisies manuelles et une combinaison fragmentée d’outils hétérogènes comme le progiciel </a:t>
+              <a:t>J’ai constaté que la gestion de ces opérations reposait encore en grande partie sur des supports physiques, des saisies manuelles et une combinaison fragmentée d’outils hétérogènes comme le progiciel </a:t>
             </a:r>
             <a:r>
               <a:rPr lang="" sz="1200" b="1" u="none" strike="noStrike" kern="1200" dirty="0">
@@ -9932,6 +10019,90 @@
           <a:bodyPr/>
           <a:lstStyle/>
           <a:p>
+            <a:endParaRPr lang="en-US" dirty="0"/>
+          </a:p>
+        </p:txBody>
+      </p:sp>
+      <p:sp>
+        <p:nvSpPr>
+          <p:cNvPr id="4" name="Slide Number Placeholder 3"/>
+          <p:cNvSpPr>
+            <a:spLocks noGrp="1"/>
+          </p:cNvSpPr>
+          <p:nvPr>
+            <p:ph type="sldNum" sz="quarter" idx="10"/>
+          </p:nvPr>
+        </p:nvSpPr>
+        <p:spPr/>
+        <p:txBody>
+          <a:bodyPr/>
+          <a:lstStyle/>
+          <a:p>
+            <a:fld id="{F7021451-1387-4CA6-816F-3879F97B5CBC}" type="slidenum">
+              <a:rPr lang="en-US"/>
+              <a:t>20</a:t>
+            </a:fld>
+            <a:endParaRPr lang="en-US"/>
+          </a:p>
+        </p:txBody>
+      </p:sp>
+    </p:spTree>
+    <p:extLst>
+      <p:ext uri="{BB962C8B-B14F-4D97-AF65-F5344CB8AC3E}">
+        <p14:creationId xmlns:p14="http://schemas.microsoft.com/office/powerpoint/2010/main" val="1024086991"/>
+      </p:ext>
+    </p:extLst>
+  </p:cSld>
+  <p:clrMapOvr>
+    <a:masterClrMapping/>
+  </p:clrMapOvr>
+</p:notes>
+</file>
+
+<file path=ppt/notesSlides/notesSlide21.xml><?xml version="1.0" encoding="utf-8"?>
+<p:notes xmlns:a="http://schemas.openxmlformats.org/drawingml/2006/main" xmlns:r="http://schemas.openxmlformats.org/officeDocument/2006/relationships" xmlns:p="http://schemas.openxmlformats.org/presentationml/2006/main">
+  <p:cSld>
+    <p:spTree>
+      <p:nvGrpSpPr>
+        <p:cNvPr id="1" name=""/>
+        <p:cNvGrpSpPr/>
+        <p:nvPr/>
+      </p:nvGrpSpPr>
+      <p:grpSpPr>
+        <a:xfrm>
+          <a:off x="0" y="0"/>
+          <a:ext cx="0" cy="0"/>
+          <a:chOff x="0" y="0"/>
+          <a:chExt cx="0" cy="0"/>
+        </a:xfrm>
+      </p:grpSpPr>
+      <p:sp>
+        <p:nvSpPr>
+          <p:cNvPr id="2" name="Slide Image Placeholder 1"/>
+          <p:cNvSpPr>
+            <a:spLocks noGrp="1" noRot="1" noChangeAspect="1"/>
+          </p:cNvSpPr>
+          <p:nvPr>
+            <p:ph type="sldImg"/>
+          </p:nvPr>
+        </p:nvSpPr>
+        <p:spPr/>
+      </p:sp>
+      <p:sp>
+        <p:nvSpPr>
+          <p:cNvPr id="3" name="Notes Placeholder 2"/>
+          <p:cNvSpPr>
+            <a:spLocks noGrp="1"/>
+          </p:cNvSpPr>
+          <p:nvPr>
+            <p:ph type="body" idx="1"/>
+          </p:nvPr>
+        </p:nvSpPr>
+        <p:spPr/>
+        <p:txBody>
+          <a:bodyPr/>
+          <a:lstStyle/>
+          <a:p>
             <a:pPr marL="0" marR="0" lvl="0" indent="0" algn="l" defTabSz="914400" rtl="0" eaLnBrk="1" fontAlgn="auto" latinLnBrk="0" hangingPunct="1">
               <a:lnSpc>
                 <a:spcPct val="100000"/>
@@ -9976,7 +10147,7 @@
           <a:p>
             <a:fld id="{F7021451-1387-4CA6-816F-3879F97B5CBC}" type="slidenum">
               <a:rPr lang="en-US"/>
-              <a:t>20</a:t>
+              <a:t>21</a:t>
             </a:fld>
             <a:endParaRPr lang="en-US"/>
           </a:p>
@@ -9995,7 +10166,7 @@
 </p:notes>
 </file>
 
-<file path=ppt/notesSlides/notesSlide21.xml><?xml version="1.0" encoding="utf-8"?>
+<file path=ppt/notesSlides/notesSlide22.xml><?xml version="1.0" encoding="utf-8"?>
 <p:notes xmlns:a="http://schemas.openxmlformats.org/drawingml/2006/main" xmlns:r="http://schemas.openxmlformats.org/officeDocument/2006/relationships" xmlns:p="http://schemas.openxmlformats.org/presentationml/2006/main">
   <p:cSld>
     <p:spTree>
@@ -10084,7 +10255,7 @@
           <a:p>
             <a:fld id="{F7021451-1387-4CA6-816F-3879F97B5CBC}" type="slidenum">
               <a:rPr lang="en-US"/>
-              <a:t>21</a:t>
+              <a:t>22</a:t>
             </a:fld>
             <a:endParaRPr lang="en-US"/>
           </a:p>
@@ -10103,7 +10274,7 @@
 </p:notes>
 </file>
 
-<file path=ppt/notesSlides/notesSlide22.xml><?xml version="1.0" encoding="utf-8"?>
+<file path=ppt/notesSlides/notesSlide23.xml><?xml version="1.0" encoding="utf-8"?>
 <p:notes xmlns:a="http://schemas.openxmlformats.org/drawingml/2006/main" xmlns:r="http://schemas.openxmlformats.org/officeDocument/2006/relationships" xmlns:p="http://schemas.openxmlformats.org/presentationml/2006/main">
   <p:cSld>
     <p:spTree>
@@ -10165,7 +10336,7 @@
             </a:r>
             <a:r>
               <a:rPr lang="" dirty="0"/>
-              <a:t> que nous avons conçue et développée répond avec précision aux exigences du cahier des charges initial. Elle offre une transition numérique concrète pour l'entreprise en éliminant les tâches manuelles redondantes, les risques d'erreurs de saisie et la dépendance critique aux outils bureautiques fragmentés comme Excel. </a:t>
+              <a:t> que j’ai conçue et développée répond avec précision aux exigences du cahier des charges initial. Elle offre une transition numérique concrète pour l'entreprise en éliminant les tâches manuelles redondantes, les risques d'erreurs de saisie et la dépendance critique aux outils bureautiques fragmentés comme Excel. </a:t>
             </a:r>
           </a:p>
           <a:p>
@@ -10174,7 +10345,7 @@
           <a:p>
             <a:r>
               <a:rPr lang="" dirty="0"/>
-              <a:t>Comme tout projet logiciel, cette plateforme reste évolutive. Parmi les perspectives à court terme, nous prévoyons de finaliser la gestion fine du mode déconnecté pour garantir une continuité parfaite du service en cas de panne réseau. Nous devons également valider auprès de la direction de production les formules exactes liées aux codes de taxes spécifiques de l'assurance automobile. À plus long terme, l'intégration d'un module de paiement en ligne via les solutions locales de Mobile Money constituera un atout stratégique majeur.</a:t>
+              <a:t>Comme tout projet logiciel, cette plateforme reste évolutive. Parmi les perspectives à court terme, Je prévois de finaliser la gestion fine du mode déconnecté pour garantir une continuité parfaite du service en cas de panne réseau. Je dois également valider auprès de la direction de production les formules exactes liées aux codes de taxes spécifiques de l'assurance automobile. À plus long terme, l'intégration d'un module de paiement en ligne via les solutions locales de Mobile Money constituera un atout stratégique majeur.</a:t>
             </a:r>
           </a:p>
           <a:p>
@@ -10237,7 +10408,7 @@
           <a:p>
             <a:fld id="{F7021451-1387-4CA6-816F-3879F97B5CBC}" type="slidenum">
               <a:rPr lang="en-US"/>
-              <a:t>22</a:t>
+              <a:t>23</a:t>
             </a:fld>
             <a:endParaRPr lang="en-US"/>
           </a:p>
@@ -10256,7 +10427,7 @@
 </p:notes>
 </file>
 
-<file path=ppt/notesSlides/notesSlide23.xml><?xml version="1.0" encoding="utf-8"?>
+<file path=ppt/notesSlides/notesSlide24.xml><?xml version="1.0" encoding="utf-8"?>
 <p:notes xmlns:a="http://schemas.openxmlformats.org/drawingml/2006/main" xmlns:r="http://schemas.openxmlformats.org/officeDocument/2006/relationships" xmlns:p="http://schemas.openxmlformats.org/presentationml/2006/main">
   <p:cSld>
     <p:spTree>
@@ -10336,7 +10507,7 @@
             </a:r>
             <a:r>
               <a:rPr lang="" dirty="0"/>
-              <a:t> que nous avons conçue et développée répond avec précision aux exigences du cahier des charges initial. Elle offre une transition numérique concrète pour l'entreprise en éliminant les tâches manuelles redondantes, les risques d'erreurs de saisie et la dépendance critique aux outils bureautiques fragmentés comme Excel. </a:t>
+              <a:t> que j’ai conçue et développée répond avec précision aux exigences du cahier des charges initial. Elle offre une transition numérique concrète pour l'entreprise en éliminant les tâches manuelles redondantes, les risques d'erreurs de saisie et la dépendance critique aux outils bureautiques fragmentés comme Excel. </a:t>
             </a:r>
           </a:p>
           <a:p>
@@ -10345,7 +10516,7 @@
           <a:p>
             <a:r>
               <a:rPr lang="" dirty="0"/>
-              <a:t>Comme tout projet logiciel, cette plateforme reste évolutive. Parmi les perspectives à court terme, nous prévoyons de finaliser la gestion fine du mode déconnecté pour garantir une continuité parfaite du service en cas de panne réseau. Nous devons également valider auprès de la direction de production les formules exactes liées aux codes de taxes spécifiques de l'assurance automobile. À plus long terme, l'intégration d'un module de paiement en ligne via les solutions locales de Mobile Money constituera un atout stratégique majeur.</a:t>
+              <a:t>Comme tout projet logiciel, cette plateforme reste évolutive. Parmi les perspectives à court terme, Je prévois de finaliser la gestion fine du mode déconnecté pour garantir une continuité parfaite du service en cas de panne réseau. Je dois également valider auprès de la direction de production les formules exactes liées aux codes de taxes spécifiques de l'assurance automobile. À plus long terme, l'intégration d'un module de paiement en ligne via les solutions locales de Mobile Money constituera un atout stratégique majeur.</a:t>
             </a:r>
           </a:p>
           <a:p>
@@ -10414,7 +10585,7 @@
           <a:p>
             <a:fld id="{F7021451-1387-4CA6-816F-3879F97B5CBC}" type="slidenum">
               <a:rPr lang="en-US"/>
-              <a:t>23</a:t>
+              <a:t>24</a:t>
             </a:fld>
             <a:endParaRPr lang="en-US"/>
           </a:p>
@@ -10433,7 +10604,7 @@
 </p:notes>
 </file>
 
-<file path=ppt/notesSlides/notesSlide24.xml><?xml version="1.0" encoding="utf-8"?>
+<file path=ppt/notesSlides/notesSlide25.xml><?xml version="1.0" encoding="utf-8"?>
 <p:notes xmlns:a="http://schemas.openxmlformats.org/drawingml/2006/main" xmlns:r="http://schemas.openxmlformats.org/officeDocument/2006/relationships" xmlns:p="http://schemas.openxmlformats.org/presentationml/2006/main">
   <p:cSld>
     <p:spTree>
@@ -10548,7 +10719,7 @@
           <a:p>
             <a:fld id="{F7021451-1387-4CA6-816F-3879F97B5CBC}" type="slidenum">
               <a:rPr lang="en-US"/>
-              <a:t>24</a:t>
+              <a:t>25</a:t>
             </a:fld>
             <a:endParaRPr lang="en-US"/>
           </a:p>
@@ -11447,7 +11618,7 @@
           <a:p>
             <a:r>
               <a:rPr lang="" dirty="0"/>
-              <a:t>Comme vous pouvez le voir sur ce slide, l’objectif général est de concevoir et déployer une plateforme unique capable de piloter l'intégralité du cycle de vie des contrats d'assurance automobile. De manière spécifique, nous ciblons la centralisation des données pour mettre fin à la dispersion actuelle. Nous visons également l'automatisation complète des calculs métiers complexes : le système doit calculer instantanément les primes nettes et globales selon les profils, gérer l'application automatique des remises de flottes à partir de 5 véhicules, et mettre à jour le coefficient de bonus-malus dès la clôture d'un sinistre. Enfin, il s'agit d'intégrer un volet décisionnel pour fournir un tableau de bord statistique complet à la direction.</a:t>
+              <a:t>Comme vous pouvez le voir sur ce slide, l’objectif général est de concevoir et déployer une plateforme unique capable de piloter l'intégralité du cycle de vie des contrats d'assurance automobile. De manière spécifique, j’ai cibler la centralisation des données pour mettre fin à la dispersion actuelle. J’ai viser également l'automatisation complète des calculs métiers complexes : le système doit calculer instantanément les primes nettes et globales selon les profils, gérer l'application automatique des remises de flottes à partir de 5 véhicules, et mettre à jour le coefficient de bonus-malus dès la clôture d'un sinistre. Enfin, il s'agit d'intégrer un volet décisionnel pour fournir un tableau de bord statistique complet à la direction.</a:t>
             </a:r>
           </a:p>
           <a:p>
@@ -11562,7 +11733,7 @@
           <a:p>
             <a:r>
               <a:rPr lang="" dirty="0"/>
-              <a:t>Pour concevoir une solution adaptée, nous avons analysé le fonctionnement quotidien du service de production automobile d'AUXIASSUR. Ce service gère deux grands types d’opérations : le traitement des "affaires nouvelles" et la reconduction des contrats, appelés renouvellements. Trois profils collaborent de façon séquentielle : le chargé de production qui instruit le dossier, le Directeur d’agence qui valide, et enfin le caissier qui gère le règlement physique des primes.</a:t>
+              <a:t>Pour concevoir une solution adaptée, j’ai analysé le fonctionnement quotidien du service de production automobile d'AUXIASSUR. Ce service gère deux grands types d’opérations : le traitement des "affaires nouvelles" et la reconduction des contrats, appelés renouvellements. Trois profils collaborent de façon séquentielle : le chargé de production qui instruit le dossier, le Directeur d’agence qui valide, et enfin le caissier qui gère le règlement physique des primes.</a:t>
             </a:r>
           </a:p>
           <a:p>
@@ -11780,7 +11951,7 @@
           </a:prstGeom>
           <a:extLst>
             <a:ext uri="{C572A759-6A51-4108-AA02-DFA0A04FC94B}">
-              <ma14:wrappingTextBoxFlag xmlns="" xmlns:ma14="http://schemas.microsoft.com/office/mac/drawingml/2011/main" val="0"/>
+              <ma14:wrappingTextBoxFlag xmlns:ma14="http://schemas.microsoft.com/office/mac/drawingml/2011/main" xmlns="" val="0"/>
             </a:ext>
           </a:extLst>
         </p:spPr>
@@ -12192,7 +12363,7 @@
           <a:p>
             <a:fld id="{CA02FB80-71B9-47BF-852E-5AF5189041F3}" type="datetimeFigureOut">
               <a:rPr lang="LID4096" smtClean="0"/>
-              <a:t>10/08/2026</a:t>
+              <a:t>10/11/2026</a:t>
             </a:fld>
             <a:endParaRPr lang="LID4096"/>
           </a:p>
@@ -12307,7 +12478,7 @@
           </a:prstGeom>
           <a:extLst>
             <a:ext uri="{C572A759-6A51-4108-AA02-DFA0A04FC94B}">
-              <ma14:wrappingTextBoxFlag xmlns="" xmlns:ma14="http://schemas.microsoft.com/office/mac/drawingml/2011/main" val="0"/>
+              <ma14:wrappingTextBoxFlag xmlns:ma14="http://schemas.microsoft.com/office/mac/drawingml/2011/main" xmlns="" val="0"/>
             </a:ext>
           </a:extLst>
         </p:spPr>
@@ -13390,7 +13561,7 @@
           </a:prstGeom>
           <a:extLst>
             <a:ext uri="{C572A759-6A51-4108-AA02-DFA0A04FC94B}">
-              <ma14:wrappingTextBoxFlag xmlns="" xmlns:ma14="http://schemas.microsoft.com/office/mac/drawingml/2011/main" val="0"/>
+              <ma14:wrappingTextBoxFlag xmlns:ma14="http://schemas.microsoft.com/office/mac/drawingml/2011/main" xmlns="" val="0"/>
             </a:ext>
           </a:extLst>
         </p:spPr>
@@ -14357,7 +14528,7 @@
           </a:prstGeom>
           <a:extLst>
             <a:ext uri="{C572A759-6A51-4108-AA02-DFA0A04FC94B}">
-              <ma14:wrappingTextBoxFlag xmlns="" xmlns:ma14="http://schemas.microsoft.com/office/mac/drawingml/2011/main" val="0"/>
+              <ma14:wrappingTextBoxFlag xmlns:ma14="http://schemas.microsoft.com/office/mac/drawingml/2011/main" xmlns="" val="0"/>
             </a:ext>
           </a:extLst>
         </p:spPr>
@@ -14374,11 +14545,11 @@
           </a:lstStyle>
           <a:p>
             <a:pPr algn="r"/>
-            <a:fld id="{F7021451-1387-4CA6-816F-3879F97B5CBC}" type="slidenum">
-              <a:rPr lang="en-US" b="0"/>
-              <a:t>10</a:t>
-            </a:fld>
-            <a:endParaRPr lang="en-US"/>
+            <a:r>
+              <a:rPr lang="en-US" b="0" dirty="0"/>
+              <a:t>9</a:t>
+            </a:r>
+            <a:endParaRPr lang="en-US" dirty="0"/>
           </a:p>
         </p:txBody>
       </p:sp>
@@ -14583,7 +14754,7 @@
           </a:prstGeom>
           <a:extLst>
             <a:ext uri="{C572A759-6A51-4108-AA02-DFA0A04FC94B}">
-              <ma14:wrappingTextBoxFlag xmlns="" xmlns:ma14="http://schemas.microsoft.com/office/mac/drawingml/2011/main" val="0"/>
+              <ma14:wrappingTextBoxFlag xmlns:ma14="http://schemas.microsoft.com/office/mac/drawingml/2011/main" xmlns="" val="0"/>
             </a:ext>
           </a:extLst>
         </p:spPr>
@@ -14600,11 +14771,11 @@
           </a:lstStyle>
           <a:p>
             <a:pPr algn="r"/>
-            <a:fld id="{F7021451-1387-4CA6-816F-3879F97B5CBC}" type="slidenum">
-              <a:rPr lang="en-US" b="0"/>
-              <a:t>11</a:t>
-            </a:fld>
-            <a:endParaRPr lang="en-US"/>
+            <a:r>
+              <a:rPr lang="en-US" b="0" dirty="0"/>
+              <a:t>10</a:t>
+            </a:r>
+            <a:endParaRPr lang="en-US" dirty="0"/>
           </a:p>
         </p:txBody>
       </p:sp>
@@ -16284,7 +16455,7 @@
           </a:prstGeom>
           <a:extLst>
             <a:ext uri="{C572A759-6A51-4108-AA02-DFA0A04FC94B}">
-              <ma14:wrappingTextBoxFlag xmlns="" xmlns:ma14="http://schemas.microsoft.com/office/mac/drawingml/2011/main" val="0"/>
+              <ma14:wrappingTextBoxFlag xmlns:ma14="http://schemas.microsoft.com/office/mac/drawingml/2011/main" xmlns="" val="0"/>
             </a:ext>
           </a:extLst>
         </p:spPr>
@@ -16301,10 +16472,10 @@
           </a:lstStyle>
           <a:p>
             <a:pPr algn="r"/>
-            <a:fld id="{F7021451-1387-4CA6-816F-3879F97B5CBC}" type="slidenum">
-              <a:rPr lang="en-US" b="0"/>
-              <a:t>12</a:t>
-            </a:fld>
+            <a:r>
+              <a:rPr lang="en-US" b="0" dirty="0"/>
+              <a:t>11</a:t>
+            </a:r>
             <a:endParaRPr lang="en-US" dirty="0"/>
           </a:p>
         </p:txBody>
@@ -16331,6 +16502,269 @@
 
 <file path=ppt/slides/slide13.xml><?xml version="1.0" encoding="utf-8"?>
 <p:sld xmlns:a="http://schemas.openxmlformats.org/drawingml/2006/main" xmlns:r="http://schemas.openxmlformats.org/officeDocument/2006/relationships" xmlns:p="http://schemas.openxmlformats.org/presentationml/2006/main">
+  <p:cSld>
+    <p:spTree>
+      <p:nvGrpSpPr>
+        <p:cNvPr id="1" name=""/>
+        <p:cNvGrpSpPr/>
+        <p:nvPr/>
+      </p:nvGrpSpPr>
+      <p:grpSpPr>
+        <a:xfrm>
+          <a:off x="0" y="0"/>
+          <a:ext cx="0" cy="0"/>
+          <a:chOff x="0" y="0"/>
+          <a:chExt cx="0" cy="0"/>
+        </a:xfrm>
+      </p:grpSpPr>
+      <p:sp>
+        <p:nvSpPr>
+          <p:cNvPr id="5" name="Text 0">
+            <a:extLst>
+              <a:ext uri="{FF2B5EF4-FFF2-40B4-BE49-F238E27FC236}">
+                <a16:creationId xmlns:a16="http://schemas.microsoft.com/office/drawing/2014/main" id="{FBC07502-C194-51ED-FAF6-D9925C60A060}"/>
+              </a:ext>
+            </a:extLst>
+          </p:cNvPr>
+          <p:cNvSpPr>
+            <a:spLocks noGrp="1"/>
+          </p:cNvSpPr>
+          <p:nvPr>
+            <p:ph type="title" idx="100" hasCustomPrompt="1"/>
+          </p:nvPr>
+        </p:nvSpPr>
+        <p:spPr>
+          <a:xfrm>
+            <a:off x="548640" y="365760"/>
+            <a:ext cx="11064240" cy="914400"/>
+          </a:xfrm>
+          <a:prstGeom prst="rect">
+            <a:avLst/>
+          </a:prstGeom>
+          <a:noFill/>
+          <a:ln/>
+        </p:spPr>
+        <p:txBody>
+          <a:bodyPr wrap="square" lIns="0" tIns="0" rIns="0" bIns="0" rtlCol="0" anchor="ctr"/>
+          <a:lstStyle/>
+          <a:p>
+            <a:pPr marL="0" indent="0" algn="l">
+              <a:buNone/>
+            </a:pPr>
+            <a:r>
+              <a:rPr lang="en-US" sz="3400" b="1" dirty="0">
+                <a:solidFill>
+                  <a:schemeClr val="tx2"/>
+                </a:solidFill>
+              </a:rPr>
+              <a:t>Planning du </a:t>
+            </a:r>
+            <a:r>
+              <a:rPr lang="en-US" sz="3400" b="1" dirty="0" err="1">
+                <a:solidFill>
+                  <a:schemeClr val="tx2"/>
+                </a:solidFill>
+              </a:rPr>
+              <a:t>projet</a:t>
+            </a:r>
+            <a:endParaRPr lang="en-US" sz="3400" dirty="0"/>
+          </a:p>
+        </p:txBody>
+      </p:sp>
+      <p:pic>
+        <p:nvPicPr>
+          <p:cNvPr id="7" name="Image 6">
+            <a:extLst>
+              <a:ext uri="{FF2B5EF4-FFF2-40B4-BE49-F238E27FC236}">
+                <a16:creationId xmlns:a16="http://schemas.microsoft.com/office/drawing/2014/main" id="{4CB2F6BE-A3DE-AB6F-1ACF-4AB2FB045022}"/>
+              </a:ext>
+            </a:extLst>
+          </p:cNvPr>
+          <p:cNvPicPr>
+            <a:picLocks noChangeAspect="1"/>
+          </p:cNvPicPr>
+          <p:nvPr/>
+        </p:nvPicPr>
+        <p:blipFill>
+          <a:blip r:embed="rId3"/>
+          <a:stretch>
+            <a:fillRect/>
+          </a:stretch>
+        </p:blipFill>
+        <p:spPr>
+          <a:xfrm>
+            <a:off x="0" y="1554480"/>
+            <a:ext cx="12192000" cy="4572000"/>
+          </a:xfrm>
+          <a:prstGeom prst="rect">
+            <a:avLst/>
+          </a:prstGeom>
+        </p:spPr>
+      </p:pic>
+      <p:sp>
+        <p:nvSpPr>
+          <p:cNvPr id="6" name="Slide Number Placeholder 0">
+            <a:extLst>
+              <a:ext uri="{FF2B5EF4-FFF2-40B4-BE49-F238E27FC236}">
+                <a16:creationId xmlns:a16="http://schemas.microsoft.com/office/drawing/2014/main" id="{FFE593C0-2571-2206-5EDD-8169B0A16BEC}"/>
+              </a:ext>
+            </a:extLst>
+          </p:cNvPr>
+          <p:cNvSpPr txBox="1">
+            <a:spLocks/>
+          </p:cNvSpPr>
+          <p:nvPr/>
+        </p:nvSpPr>
+        <p:spPr>
+          <a:xfrm>
+            <a:off x="10972800" y="6400800"/>
+            <a:ext cx="640080" cy="274320"/>
+          </a:xfrm>
+          <a:prstGeom prst="rect">
+            <a:avLst/>
+          </a:prstGeom>
+          <a:extLst>
+            <a:ext uri="{C572A759-6A51-4108-AA02-DFA0A04FC94B}">
+              <ma14:wrappingTextBoxFlag xmlns="" xmlns:ma14="http://schemas.microsoft.com/office/mac/drawingml/2011/main" val="0"/>
+            </a:ext>
+          </a:extLst>
+        </p:spPr>
+        <p:txBody>
+          <a:bodyPr/>
+          <a:lstStyle>
+            <a:lvl1pPr marL="0" algn="l" defTabSz="914400" rtl="0" eaLnBrk="1" latinLnBrk="0" hangingPunct="1">
+              <a:defRPr sz="1100" kern="1200">
+                <a:solidFill>
+                  <a:schemeClr val="tx1"/>
+                </a:solidFill>
+                <a:latin typeface="+mn-lt"/>
+                <a:ea typeface="+mn-ea"/>
+                <a:cs typeface="+mn-cs"/>
+              </a:defRPr>
+            </a:lvl1pPr>
+            <a:lvl2pPr marL="457200" algn="l" defTabSz="914400" rtl="0" eaLnBrk="1" latinLnBrk="0" hangingPunct="1">
+              <a:defRPr sz="1800" kern="1200">
+                <a:solidFill>
+                  <a:schemeClr val="tx1"/>
+                </a:solidFill>
+                <a:latin typeface="+mn-lt"/>
+                <a:ea typeface="+mn-ea"/>
+                <a:cs typeface="+mn-cs"/>
+              </a:defRPr>
+            </a:lvl2pPr>
+            <a:lvl3pPr marL="914400" algn="l" defTabSz="914400" rtl="0" eaLnBrk="1" latinLnBrk="0" hangingPunct="1">
+              <a:defRPr sz="1800" kern="1200">
+                <a:solidFill>
+                  <a:schemeClr val="tx1"/>
+                </a:solidFill>
+                <a:latin typeface="+mn-lt"/>
+                <a:ea typeface="+mn-ea"/>
+                <a:cs typeface="+mn-cs"/>
+              </a:defRPr>
+            </a:lvl3pPr>
+            <a:lvl4pPr marL="1371600" algn="l" defTabSz="914400" rtl="0" eaLnBrk="1" latinLnBrk="0" hangingPunct="1">
+              <a:defRPr sz="1800" kern="1200">
+                <a:solidFill>
+                  <a:schemeClr val="tx1"/>
+                </a:solidFill>
+                <a:latin typeface="+mn-lt"/>
+                <a:ea typeface="+mn-ea"/>
+                <a:cs typeface="+mn-cs"/>
+              </a:defRPr>
+            </a:lvl4pPr>
+            <a:lvl5pPr marL="1828800" algn="l" defTabSz="914400" rtl="0" eaLnBrk="1" latinLnBrk="0" hangingPunct="1">
+              <a:defRPr sz="1800" kern="1200">
+                <a:solidFill>
+                  <a:schemeClr val="tx1"/>
+                </a:solidFill>
+                <a:latin typeface="+mn-lt"/>
+                <a:ea typeface="+mn-ea"/>
+                <a:cs typeface="+mn-cs"/>
+              </a:defRPr>
+            </a:lvl5pPr>
+            <a:lvl6pPr marL="2286000" algn="l" defTabSz="914400" rtl="0" eaLnBrk="1" latinLnBrk="0" hangingPunct="1">
+              <a:defRPr sz="1800" kern="1200">
+                <a:solidFill>
+                  <a:schemeClr val="tx1"/>
+                </a:solidFill>
+                <a:latin typeface="+mn-lt"/>
+                <a:ea typeface="+mn-ea"/>
+                <a:cs typeface="+mn-cs"/>
+              </a:defRPr>
+            </a:lvl6pPr>
+            <a:lvl7pPr marL="2743200" algn="l" defTabSz="914400" rtl="0" eaLnBrk="1" latinLnBrk="0" hangingPunct="1">
+              <a:defRPr sz="1800" kern="1200">
+                <a:solidFill>
+                  <a:schemeClr val="tx1"/>
+                </a:solidFill>
+                <a:latin typeface="+mn-lt"/>
+                <a:ea typeface="+mn-ea"/>
+                <a:cs typeface="+mn-cs"/>
+              </a:defRPr>
+            </a:lvl7pPr>
+            <a:lvl8pPr marL="3200400" algn="l" defTabSz="914400" rtl="0" eaLnBrk="1" latinLnBrk="0" hangingPunct="1">
+              <a:defRPr sz="1800" kern="1200">
+                <a:solidFill>
+                  <a:schemeClr val="tx1"/>
+                </a:solidFill>
+                <a:latin typeface="+mn-lt"/>
+                <a:ea typeface="+mn-ea"/>
+                <a:cs typeface="+mn-cs"/>
+              </a:defRPr>
+            </a:lvl8pPr>
+            <a:lvl9pPr marL="3657600" algn="l" defTabSz="914400" rtl="0" eaLnBrk="1" latinLnBrk="0" hangingPunct="1">
+              <a:defRPr sz="1800" kern="1200">
+                <a:solidFill>
+                  <a:schemeClr val="tx1"/>
+                </a:solidFill>
+                <a:latin typeface="+mn-lt"/>
+                <a:ea typeface="+mn-ea"/>
+                <a:cs typeface="+mn-cs"/>
+              </a:defRPr>
+            </a:lvl9pPr>
+          </a:lstStyle>
+          <a:p>
+            <a:pPr algn="r"/>
+            <a:r>
+              <a:rPr lang="en-US" dirty="0">
+                <a:solidFill>
+                  <a:schemeClr val="bg2">
+                    <a:lumMod val="10000"/>
+                  </a:schemeClr>
+                </a:solidFill>
+              </a:rPr>
+              <a:t>12</a:t>
+            </a:r>
+          </a:p>
+        </p:txBody>
+      </p:sp>
+    </p:spTree>
+    <p:extLst>
+      <p:ext uri="{BB962C8B-B14F-4D97-AF65-F5344CB8AC3E}">
+        <p14:creationId xmlns:p14="http://schemas.microsoft.com/office/powerpoint/2010/main" val="2884316772"/>
+      </p:ext>
+    </p:extLst>
+  </p:cSld>
+  <p:clrMapOvr>
+    <a:masterClrMapping/>
+  </p:clrMapOvr>
+  <mc:AlternateContent xmlns:mc="http://schemas.openxmlformats.org/markup-compatibility/2006" xmlns:p159="http://schemas.microsoft.com/office/powerpoint/2015/09/main">
+    <mc:Choice Requires="p159">
+      <p:transition xmlns:p14="http://schemas.microsoft.com/office/powerpoint/2010/main" spd="slow" p14:dur="2000">
+        <p159:morph option="byObject"/>
+      </p:transition>
+    </mc:Choice>
+    <mc:Fallback xmlns="">
+      <p:transition spd="slow">
+        <p:fade/>
+      </p:transition>
+    </mc:Fallback>
+  </mc:AlternateContent>
+</p:sld>
+</file>
+
+<file path=ppt/slides/slide14.xml><?xml version="1.0" encoding="utf-8"?>
+<p:sld xmlns:a="http://schemas.openxmlformats.org/drawingml/2006/main" xmlns:r="http://schemas.openxmlformats.org/officeDocument/2006/relationships" xmlns:p="http://schemas.openxmlformats.org/presentationml/2006/main">
   <p:cSld name="Slide 11">
     <p:spTree>
       <p:nvGrpSpPr>
@@ -16450,7 +16884,7 @@
           </a:prstGeom>
           <a:extLst>
             <a:ext uri="{C572A759-6A51-4108-AA02-DFA0A04FC94B}">
-              <ma14:wrappingTextBoxFlag xmlns="" xmlns:ma14="http://schemas.microsoft.com/office/mac/drawingml/2011/main" val="0"/>
+              <ma14:wrappingTextBoxFlag xmlns:ma14="http://schemas.microsoft.com/office/mac/drawingml/2011/main" xmlns="" val="0"/>
             </a:ext>
           </a:extLst>
         </p:spPr>
@@ -16550,20 +16984,14 @@
           </a:lstStyle>
           <a:p>
             <a:pPr algn="r"/>
-            <a:fld id="{F7021451-1387-4CA6-816F-3879F97B5CBC}" type="slidenum">
-              <a:rPr lang="en-US" smtClean="0">
+            <a:r>
+              <a:rPr lang="en-US" dirty="0">
                 <a:solidFill>
                   <a:schemeClr val="bg1"/>
                 </a:solidFill>
               </a:rPr>
-              <a:pPr algn="r"/>
               <a:t>13</a:t>
-            </a:fld>
-            <a:endParaRPr lang="en-US" dirty="0">
-              <a:solidFill>
-                <a:schemeClr val="bg1"/>
-              </a:solidFill>
-            </a:endParaRPr>
+            </a:r>
           </a:p>
         </p:txBody>
       </p:sp>
@@ -16587,7 +17015,7 @@
 </p:sld>
 </file>
 
-<file path=ppt/slides/slide14.xml><?xml version="1.0" encoding="utf-8"?>
+<file path=ppt/slides/slide15.xml><?xml version="1.0" encoding="utf-8"?>
 <p:sld xmlns:a="http://schemas.openxmlformats.org/drawingml/2006/main" xmlns:r="http://schemas.openxmlformats.org/officeDocument/2006/relationships" xmlns:p="http://schemas.openxmlformats.org/presentationml/2006/main">
   <p:cSld name="Slide 12">
     <p:spTree>
@@ -16969,7 +17397,7 @@
           </a:prstGeom>
           <a:extLst>
             <a:ext uri="{C572A759-6A51-4108-AA02-DFA0A04FC94B}">
-              <ma14:wrappingTextBoxFlag xmlns="" xmlns:ma14="http://schemas.microsoft.com/office/mac/drawingml/2011/main" val="0"/>
+              <ma14:wrappingTextBoxFlag xmlns:ma14="http://schemas.microsoft.com/office/mac/drawingml/2011/main" xmlns="" val="0"/>
             </a:ext>
           </a:extLst>
         </p:spPr>
@@ -16986,11 +17414,11 @@
           </a:lstStyle>
           <a:p>
             <a:pPr algn="r"/>
-            <a:fld id="{F7021451-1387-4CA6-816F-3879F97B5CBC}" type="slidenum">
-              <a:rPr lang="en-US" b="0"/>
+            <a:r>
+              <a:rPr lang="en-US" b="0" dirty="0"/>
               <a:t>14</a:t>
-            </a:fld>
-            <a:endParaRPr lang="en-US"/>
+            </a:r>
+            <a:endParaRPr lang="en-US" dirty="0"/>
           </a:p>
         </p:txBody>
       </p:sp>
@@ -17032,7 +17460,7 @@
 </p:sld>
 </file>
 
-<file path=ppt/slides/slide15.xml><?xml version="1.0" encoding="utf-8"?>
+<file path=ppt/slides/slide16.xml><?xml version="1.0" encoding="utf-8"?>
 <p:sld xmlns:a="http://schemas.openxmlformats.org/drawingml/2006/main" xmlns:r="http://schemas.openxmlformats.org/officeDocument/2006/relationships" xmlns:p="http://schemas.openxmlformats.org/presentationml/2006/main">
   <p:cSld>
     <p:spTree>
@@ -17456,7 +17884,7 @@
           </a:prstGeom>
           <a:extLst>
             <a:ext uri="{C572A759-6A51-4108-AA02-DFA0A04FC94B}">
-              <ma14:wrappingTextBoxFlag xmlns:ma14="http://schemas.microsoft.com/office/mac/drawingml/2011/main" xmlns="" val="0"/>
+              <ma14:wrappingTextBoxFlag xmlns="" xmlns:ma14="http://schemas.microsoft.com/office/mac/drawingml/2011/main" val="0"/>
             </a:ext>
           </a:extLst>
         </p:spPr>
@@ -17473,11 +17901,10 @@
           </a:lstStyle>
           <a:p>
             <a:pPr algn="r"/>
-            <a:fld id="{F7021451-1387-4CA6-816F-3879F97B5CBC}" type="slidenum">
-              <a:rPr lang="en-US" b="0"/>
-              <a:t>15</a:t>
-            </a:fld>
-            <a:endParaRPr lang="en-US"/>
+            <a:r>
+              <a:rPr lang="en-US" dirty="0"/>
+              <a:t>14</a:t>
+            </a:r>
           </a:p>
         </p:txBody>
       </p:sp>
@@ -17536,7 +17963,7 @@
 </p:sld>
 </file>
 
-<file path=ppt/slides/slide16.xml><?xml version="1.0" encoding="utf-8"?>
+<file path=ppt/slides/slide17.xml><?xml version="1.0" encoding="utf-8"?>
 <p:sld xmlns:a="http://schemas.openxmlformats.org/drawingml/2006/main" xmlns:r="http://schemas.openxmlformats.org/officeDocument/2006/relationships" xmlns:p="http://schemas.openxmlformats.org/presentationml/2006/main">
   <p:cSld name="Slide 13">
     <p:spTree>
@@ -18055,7 +18482,7 @@
           </a:prstGeom>
           <a:extLst>
             <a:ext uri="{C572A759-6A51-4108-AA02-DFA0A04FC94B}">
-              <ma14:wrappingTextBoxFlag xmlns="" xmlns:ma14="http://schemas.microsoft.com/office/mac/drawingml/2011/main" val="0"/>
+              <ma14:wrappingTextBoxFlag xmlns:ma14="http://schemas.microsoft.com/office/mac/drawingml/2011/main" xmlns="" val="0"/>
             </a:ext>
           </a:extLst>
         </p:spPr>
@@ -18072,11 +18499,11 @@
           </a:lstStyle>
           <a:p>
             <a:pPr algn="r"/>
-            <a:fld id="{F7021451-1387-4CA6-816F-3879F97B5CBC}" type="slidenum">
-              <a:rPr lang="en-US" b="0"/>
-              <a:t>16</a:t>
-            </a:fld>
-            <a:endParaRPr lang="en-US"/>
+            <a:r>
+              <a:rPr lang="en-US" b="0" dirty="0"/>
+              <a:t>15</a:t>
+            </a:r>
+            <a:endParaRPr lang="en-US" dirty="0"/>
           </a:p>
         </p:txBody>
       </p:sp>
@@ -18130,7 +18557,7 @@
 </p:sld>
 </file>
 
-<file path=ppt/slides/slide17.xml><?xml version="1.0" encoding="utf-8"?>
+<file path=ppt/slides/slide18.xml><?xml version="1.0" encoding="utf-8"?>
 <p:sld xmlns:a="http://schemas.openxmlformats.org/drawingml/2006/main" xmlns:r="http://schemas.openxmlformats.org/officeDocument/2006/relationships" xmlns:p="http://schemas.openxmlformats.org/presentationml/2006/main">
   <p:cSld>
     <p:spTree>
@@ -18751,7 +19178,7 @@
           </a:prstGeom>
           <a:extLst>
             <a:ext uri="{C572A759-6A51-4108-AA02-DFA0A04FC94B}">
-              <ma14:wrappingTextBoxFlag xmlns:ma14="http://schemas.microsoft.com/office/mac/drawingml/2011/main" xmlns="" val="0"/>
+              <ma14:wrappingTextBoxFlag xmlns="" xmlns:ma14="http://schemas.microsoft.com/office/mac/drawingml/2011/main" val="0"/>
             </a:ext>
           </a:extLst>
         </p:spPr>
@@ -18768,11 +19195,10 @@
           </a:lstStyle>
           <a:p>
             <a:pPr algn="r"/>
-            <a:fld id="{F7021451-1387-4CA6-816F-3879F97B5CBC}" type="slidenum">
-              <a:rPr lang="en-US" b="0"/>
-              <a:t>17</a:t>
-            </a:fld>
-            <a:endParaRPr lang="en-US"/>
+            <a:r>
+              <a:rPr lang="en-US" dirty="0"/>
+              <a:t>16</a:t>
+            </a:r>
           </a:p>
         </p:txBody>
       </p:sp>
@@ -18831,7 +19257,7 @@
 </p:sld>
 </file>
 
-<file path=ppt/slides/slide18.xml><?xml version="1.0" encoding="utf-8"?>
+<file path=ppt/slides/slide19.xml><?xml version="1.0" encoding="utf-8"?>
 <p:sld xmlns:a="http://schemas.openxmlformats.org/drawingml/2006/main" xmlns:r="http://schemas.openxmlformats.org/officeDocument/2006/relationships" xmlns:p="http://schemas.openxmlformats.org/presentationml/2006/main">
   <p:cSld name="Slide 14">
     <p:spTree>
@@ -19018,7 +19444,7 @@
           </a:prstGeom>
           <a:extLst>
             <a:ext uri="{C572A759-6A51-4108-AA02-DFA0A04FC94B}">
-              <ma14:wrappingTextBoxFlag xmlns="" xmlns:ma14="http://schemas.microsoft.com/office/mac/drawingml/2011/main" val="0"/>
+              <ma14:wrappingTextBoxFlag xmlns:ma14="http://schemas.microsoft.com/office/mac/drawingml/2011/main" xmlns="" val="0"/>
             </a:ext>
           </a:extLst>
         </p:spPr>
@@ -19035,11 +19461,11 @@
           </a:lstStyle>
           <a:p>
             <a:pPr algn="r"/>
-            <a:fld id="{F7021451-1387-4CA6-816F-3879F97B5CBC}" type="slidenum">
-              <a:rPr lang="en-US" b="0"/>
-              <a:t>18</a:t>
-            </a:fld>
-            <a:endParaRPr lang="en-US"/>
+            <a:r>
+              <a:rPr lang="en-US" dirty="0"/>
+              <a:t>17</a:t>
+            </a:r>
+            <a:endParaRPr lang="en-US" b="0" dirty="0"/>
           </a:p>
         </p:txBody>
       </p:sp>
@@ -19086,158 +19512,6 @@
     </mc:Choice>
     <mc:Fallback xmlns="">
       <p:transition spd="slow">
-        <p:fade/>
-      </p:transition>
-    </mc:Fallback>
-  </mc:AlternateContent>
-</p:sld>
-</file>
-
-<file path=ppt/slides/slide19.xml><?xml version="1.0" encoding="utf-8"?>
-<p:sld xmlns:a="http://schemas.openxmlformats.org/drawingml/2006/main" xmlns:r="http://schemas.openxmlformats.org/officeDocument/2006/relationships" xmlns:p="http://schemas.openxmlformats.org/presentationml/2006/main">
-  <p:cSld name="Slide 15">
-    <p:spTree>
-      <p:nvGrpSpPr>
-        <p:cNvPr id="1" name=""/>
-        <p:cNvGrpSpPr/>
-        <p:nvPr/>
-      </p:nvGrpSpPr>
-      <p:grpSpPr>
-        <a:xfrm>
-          <a:off x="0" y="0"/>
-          <a:ext cx="0" cy="0"/>
-          <a:chOff x="0" y="0"/>
-          <a:chExt cx="0" cy="0"/>
-        </a:xfrm>
-      </p:grpSpPr>
-      <p:sp>
-        <p:nvSpPr>
-          <p:cNvPr id="2" name="Text 0"/>
-          <p:cNvSpPr>
-            <a:spLocks noGrp="1"/>
-          </p:cNvSpPr>
-          <p:nvPr>
-            <p:ph type="title" idx="100" hasCustomPrompt="1"/>
-          </p:nvPr>
-        </p:nvSpPr>
-        <p:spPr>
-          <a:xfrm>
-            <a:off x="548640" y="182880"/>
-            <a:ext cx="11064240" cy="1097280"/>
-          </a:xfrm>
-          <a:prstGeom prst="rect">
-            <a:avLst/>
-          </a:prstGeom>
-          <a:noFill/>
-          <a:ln/>
-        </p:spPr>
-        <p:txBody>
-          <a:bodyPr wrap="square" lIns="0" tIns="0" rIns="0" bIns="0" rtlCol="0" anchor="ctr"/>
-          <a:lstStyle/>
-          <a:p>
-            <a:pPr marL="0" indent="0" algn="l">
-              <a:buNone/>
-            </a:pPr>
-            <a:r>
-              <a:rPr lang="en-US" sz="3400" b="1" dirty="0">
-                <a:solidFill>
-                  <a:schemeClr val="tx2"/>
-                </a:solidFill>
-              </a:rPr>
-              <a:t>Diagramme de classes</a:t>
-            </a:r>
-            <a:endParaRPr lang="en-US" sz="3400" dirty="0"/>
-          </a:p>
-        </p:txBody>
-      </p:sp>
-      <p:sp>
-        <p:nvSpPr>
-          <p:cNvPr id="25" name="Slide Number Placeholder 0"/>
-          <p:cNvSpPr>
-            <a:spLocks noGrp="1"/>
-          </p:cNvSpPr>
-          <p:nvPr>
-            <p:ph type="sldNum" sz="quarter" idx="4294967295"/>
-          </p:nvPr>
-        </p:nvSpPr>
-        <p:spPr>
-          <a:xfrm>
-            <a:off x="10972800" y="6400800"/>
-            <a:ext cx="640080" cy="274320"/>
-          </a:xfrm>
-          <a:prstGeom prst="rect">
-            <a:avLst/>
-          </a:prstGeom>
-          <a:extLst>
-            <a:ext uri="{C572A759-6A51-4108-AA02-DFA0A04FC94B}">
-              <ma14:wrappingTextBoxFlag xmlns="" xmlns:ma14="http://schemas.microsoft.com/office/mac/drawingml/2011/main" val="0"/>
-            </a:ext>
-          </a:extLst>
-        </p:spPr>
-        <p:txBody>
-          <a:bodyPr/>
-          <a:lstStyle>
-            <a:lvl1pPr>
-              <a:defRPr sz="1100">
-                <a:solidFill>
-                  <a:schemeClr val="tx1"/>
-                </a:solidFill>
-              </a:defRPr>
-            </a:lvl1pPr>
-          </a:lstStyle>
-          <a:p>
-            <a:pPr algn="r"/>
-            <a:fld id="{F7021451-1387-4CA6-816F-3879F97B5CBC}" type="slidenum">
-              <a:rPr lang="en-US" b="0"/>
-              <a:t>19</a:t>
-            </a:fld>
-            <a:endParaRPr lang="en-US"/>
-          </a:p>
-        </p:txBody>
-      </p:sp>
-      <p:pic>
-        <p:nvPicPr>
-          <p:cNvPr id="20" name="Image 19">
-            <a:extLst>
-              <a:ext uri="{FF2B5EF4-FFF2-40B4-BE49-F238E27FC236}">
-                <a16:creationId xmlns:a16="http://schemas.microsoft.com/office/drawing/2014/main" id="{EC21E696-BE67-A604-CBB7-DBD2A7BD6E47}"/>
-              </a:ext>
-            </a:extLst>
-          </p:cNvPr>
-          <p:cNvPicPr>
-            <a:picLocks noChangeAspect="1"/>
-          </p:cNvPicPr>
-          <p:nvPr/>
-        </p:nvPicPr>
-        <p:blipFill>
-          <a:blip r:embed="rId3"/>
-          <a:stretch>
-            <a:fillRect/>
-          </a:stretch>
-        </p:blipFill>
-        <p:spPr>
-          <a:xfrm>
-            <a:off x="661772" y="962526"/>
-            <a:ext cx="10951108" cy="5438274"/>
-          </a:xfrm>
-          <a:prstGeom prst="rect">
-            <a:avLst/>
-          </a:prstGeom>
-        </p:spPr>
-      </p:pic>
-    </p:spTree>
-  </p:cSld>
-  <p:clrMapOvr>
-    <a:masterClrMapping/>
-  </p:clrMapOvr>
-  <mc:AlternateContent xmlns:mc="http://schemas.openxmlformats.org/markup-compatibility/2006" xmlns:p14="http://schemas.microsoft.com/office/powerpoint/2010/main">
-    <mc:Choice Requires="p14">
-      <p:transition spd="med" p14:dur="700">
-        <p:fade/>
-      </p:transition>
-    </mc:Choice>
-    <mc:Fallback xmlns="">
-      <p:transition spd="med">
         <p:fade/>
       </p:transition>
     </mc:Fallback>
@@ -19415,7 +19689,7 @@
           </a:prstGeom>
           <a:extLst>
             <a:ext uri="{C572A759-6A51-4108-AA02-DFA0A04FC94B}">
-              <ma14:wrappingTextBoxFlag xmlns="" xmlns:ma14="http://schemas.microsoft.com/office/mac/drawingml/2011/main" val="0"/>
+              <ma14:wrappingTextBoxFlag xmlns:ma14="http://schemas.microsoft.com/office/mac/drawingml/2011/main" xmlns="" val="0"/>
             </a:ext>
           </a:extLst>
         </p:spPr>
@@ -19544,6 +19818,158 @@
 </file>
 
 <file path=ppt/slides/slide20.xml><?xml version="1.0" encoding="utf-8"?>
+<p:sld xmlns:a="http://schemas.openxmlformats.org/drawingml/2006/main" xmlns:r="http://schemas.openxmlformats.org/officeDocument/2006/relationships" xmlns:p="http://schemas.openxmlformats.org/presentationml/2006/main">
+  <p:cSld name="Slide 15">
+    <p:spTree>
+      <p:nvGrpSpPr>
+        <p:cNvPr id="1" name=""/>
+        <p:cNvGrpSpPr/>
+        <p:nvPr/>
+      </p:nvGrpSpPr>
+      <p:grpSpPr>
+        <a:xfrm>
+          <a:off x="0" y="0"/>
+          <a:ext cx="0" cy="0"/>
+          <a:chOff x="0" y="0"/>
+          <a:chExt cx="0" cy="0"/>
+        </a:xfrm>
+      </p:grpSpPr>
+      <p:sp>
+        <p:nvSpPr>
+          <p:cNvPr id="2" name="Text 0"/>
+          <p:cNvSpPr>
+            <a:spLocks noGrp="1"/>
+          </p:cNvSpPr>
+          <p:nvPr>
+            <p:ph type="title" idx="100" hasCustomPrompt="1"/>
+          </p:nvPr>
+        </p:nvSpPr>
+        <p:spPr>
+          <a:xfrm>
+            <a:off x="548640" y="182880"/>
+            <a:ext cx="11064240" cy="1097280"/>
+          </a:xfrm>
+          <a:prstGeom prst="rect">
+            <a:avLst/>
+          </a:prstGeom>
+          <a:noFill/>
+          <a:ln/>
+        </p:spPr>
+        <p:txBody>
+          <a:bodyPr wrap="square" lIns="0" tIns="0" rIns="0" bIns="0" rtlCol="0" anchor="ctr"/>
+          <a:lstStyle/>
+          <a:p>
+            <a:pPr marL="0" indent="0" algn="l">
+              <a:buNone/>
+            </a:pPr>
+            <a:r>
+              <a:rPr lang="en-US" sz="3400" b="1" dirty="0">
+                <a:solidFill>
+                  <a:schemeClr val="tx2"/>
+                </a:solidFill>
+              </a:rPr>
+              <a:t>Diagramme de classes</a:t>
+            </a:r>
+            <a:endParaRPr lang="en-US" sz="3400" dirty="0"/>
+          </a:p>
+        </p:txBody>
+      </p:sp>
+      <p:sp>
+        <p:nvSpPr>
+          <p:cNvPr id="25" name="Slide Number Placeholder 0"/>
+          <p:cNvSpPr>
+            <a:spLocks noGrp="1"/>
+          </p:cNvSpPr>
+          <p:nvPr>
+            <p:ph type="sldNum" sz="quarter" idx="4294967295"/>
+          </p:nvPr>
+        </p:nvSpPr>
+        <p:spPr>
+          <a:xfrm>
+            <a:off x="10972800" y="6400800"/>
+            <a:ext cx="640080" cy="274320"/>
+          </a:xfrm>
+          <a:prstGeom prst="rect">
+            <a:avLst/>
+          </a:prstGeom>
+          <a:extLst>
+            <a:ext uri="{C572A759-6A51-4108-AA02-DFA0A04FC94B}">
+              <ma14:wrappingTextBoxFlag xmlns:ma14="http://schemas.microsoft.com/office/mac/drawingml/2011/main" xmlns="" val="0"/>
+            </a:ext>
+          </a:extLst>
+        </p:spPr>
+        <p:txBody>
+          <a:bodyPr/>
+          <a:lstStyle>
+            <a:lvl1pPr>
+              <a:defRPr sz="1100">
+                <a:solidFill>
+                  <a:schemeClr val="tx1"/>
+                </a:solidFill>
+              </a:defRPr>
+            </a:lvl1pPr>
+          </a:lstStyle>
+          <a:p>
+            <a:pPr algn="r"/>
+            <a:r>
+              <a:rPr lang="en-US" b="0" dirty="0"/>
+              <a:t>18</a:t>
+            </a:r>
+            <a:endParaRPr lang="en-US" dirty="0"/>
+          </a:p>
+        </p:txBody>
+      </p:sp>
+      <p:pic>
+        <p:nvPicPr>
+          <p:cNvPr id="20" name="Image 19">
+            <a:extLst>
+              <a:ext uri="{FF2B5EF4-FFF2-40B4-BE49-F238E27FC236}">
+                <a16:creationId xmlns:a16="http://schemas.microsoft.com/office/drawing/2014/main" id="{EC21E696-BE67-A604-CBB7-DBD2A7BD6E47}"/>
+              </a:ext>
+            </a:extLst>
+          </p:cNvPr>
+          <p:cNvPicPr>
+            <a:picLocks noChangeAspect="1"/>
+          </p:cNvPicPr>
+          <p:nvPr/>
+        </p:nvPicPr>
+        <p:blipFill>
+          <a:blip r:embed="rId3"/>
+          <a:stretch>
+            <a:fillRect/>
+          </a:stretch>
+        </p:blipFill>
+        <p:spPr>
+          <a:xfrm>
+            <a:off x="661772" y="962526"/>
+            <a:ext cx="10951108" cy="5438274"/>
+          </a:xfrm>
+          <a:prstGeom prst="rect">
+            <a:avLst/>
+          </a:prstGeom>
+        </p:spPr>
+      </p:pic>
+    </p:spTree>
+  </p:cSld>
+  <p:clrMapOvr>
+    <a:masterClrMapping/>
+  </p:clrMapOvr>
+  <mc:AlternateContent xmlns:mc="http://schemas.openxmlformats.org/markup-compatibility/2006" xmlns:p14="http://schemas.microsoft.com/office/powerpoint/2010/main">
+    <mc:Choice Requires="p14">
+      <p:transition spd="med" p14:dur="700">
+        <p:fade/>
+      </p:transition>
+    </mc:Choice>
+    <mc:Fallback xmlns="">
+      <p:transition spd="med">
+        <p:fade/>
+      </p:transition>
+    </mc:Fallback>
+  </mc:AlternateContent>
+</p:sld>
+</file>
+
+<file path=ppt/slides/slide21.xml><?xml version="1.0" encoding="utf-8"?>
 <p:sld xmlns:a="http://schemas.openxmlformats.org/drawingml/2006/main" xmlns:r="http://schemas.openxmlformats.org/officeDocument/2006/relationships" xmlns:p="http://schemas.openxmlformats.org/presentationml/2006/main">
   <p:cSld name="Slide 16">
     <p:spTree>
@@ -19664,7 +20090,7 @@
           </a:prstGeom>
           <a:extLst>
             <a:ext uri="{C572A759-6A51-4108-AA02-DFA0A04FC94B}">
-              <ma14:wrappingTextBoxFlag xmlns="" xmlns:ma14="http://schemas.microsoft.com/office/mac/drawingml/2011/main" val="0"/>
+              <ma14:wrappingTextBoxFlag xmlns:ma14="http://schemas.microsoft.com/office/mac/drawingml/2011/main" xmlns="" val="0"/>
             </a:ext>
           </a:extLst>
         </p:spPr>
@@ -19764,20 +20190,14 @@
           </a:lstStyle>
           <a:p>
             <a:pPr algn="r"/>
-            <a:fld id="{F7021451-1387-4CA6-816F-3879F97B5CBC}" type="slidenum">
-              <a:rPr lang="en-US" smtClean="0">
+            <a:r>
+              <a:rPr lang="en-US" dirty="0">
                 <a:solidFill>
                   <a:schemeClr val="bg1"/>
                 </a:solidFill>
               </a:rPr>
-              <a:pPr algn="r"/>
-              <a:t>20</a:t>
-            </a:fld>
-            <a:endParaRPr lang="en-US" dirty="0">
-              <a:solidFill>
-                <a:schemeClr val="bg1"/>
-              </a:solidFill>
-            </a:endParaRPr>
+              <a:t>19</a:t>
+            </a:r>
           </a:p>
         </p:txBody>
       </p:sp>
@@ -19801,7 +20221,7 @@
 </p:sld>
 </file>
 
-<file path=ppt/slides/slide21.xml><?xml version="1.0" encoding="utf-8"?>
+<file path=ppt/slides/slide22.xml><?xml version="1.0" encoding="utf-8"?>
 <p:sld xmlns:a="http://schemas.openxmlformats.org/drawingml/2006/main" xmlns:r="http://schemas.openxmlformats.org/officeDocument/2006/relationships" xmlns:p="http://schemas.openxmlformats.org/presentationml/2006/main">
   <p:cSld>
     <p:spTree>
@@ -19902,7 +20322,7 @@
           </a:prstGeom>
           <a:extLst>
             <a:ext uri="{C572A759-6A51-4108-AA02-DFA0A04FC94B}">
-              <ma14:wrappingTextBoxFlag xmlns:ma14="http://schemas.microsoft.com/office/mac/drawingml/2011/main" xmlns="" val="0"/>
+              <ma14:wrappingTextBoxFlag xmlns="" xmlns:ma14="http://schemas.microsoft.com/office/mac/drawingml/2011/main" val="0"/>
             </a:ext>
           </a:extLst>
         </p:spPr>
@@ -20002,20 +20422,14 @@
           </a:lstStyle>
           <a:p>
             <a:pPr algn="r"/>
-            <a:fld id="{F7021451-1387-4CA6-816F-3879F97B5CBC}" type="slidenum">
-              <a:rPr lang="en-US" smtClean="0">
+            <a:r>
+              <a:rPr lang="en-US" dirty="0">
                 <a:solidFill>
                   <a:schemeClr val="bg1"/>
                 </a:solidFill>
               </a:rPr>
-              <a:pPr algn="r"/>
-              <a:t>21</a:t>
-            </a:fld>
-            <a:endParaRPr lang="en-US" dirty="0">
-              <a:solidFill>
-                <a:schemeClr val="bg1"/>
-              </a:solidFill>
-            </a:endParaRPr>
+              <a:t>20</a:t>
+            </a:r>
           </a:p>
         </p:txBody>
       </p:sp>
@@ -20044,7 +20458,7 @@
 </p:sld>
 </file>
 
-<file path=ppt/slides/slide22.xml><?xml version="1.0" encoding="utf-8"?>
+<file path=ppt/slides/slide23.xml><?xml version="1.0" encoding="utf-8"?>
 <p:sld xmlns:a="http://schemas.openxmlformats.org/drawingml/2006/main" xmlns:r="http://schemas.openxmlformats.org/officeDocument/2006/relationships" xmlns:p="http://schemas.openxmlformats.org/presentationml/2006/main">
   <p:cSld name="Slide 18">
     <p:spTree>
@@ -20557,7 +20971,7 @@
           </a:prstGeom>
           <a:extLst>
             <a:ext uri="{C572A759-6A51-4108-AA02-DFA0A04FC94B}">
-              <ma14:wrappingTextBoxFlag xmlns="" xmlns:ma14="http://schemas.microsoft.com/office/mac/drawingml/2011/main" val="0"/>
+              <ma14:wrappingTextBoxFlag xmlns:ma14="http://schemas.microsoft.com/office/mac/drawingml/2011/main" xmlns="" val="0"/>
             </a:ext>
           </a:extLst>
         </p:spPr>
@@ -20657,691 +21071,18 @@
           </a:lstStyle>
           <a:p>
             <a:pPr algn="r"/>
-            <a:fld id="{F7021451-1387-4CA6-816F-3879F97B5CBC}" type="slidenum">
-              <a:rPr lang="en-US" smtClean="0">
+            <a:r>
+              <a:rPr lang="en-US" dirty="0">
                 <a:solidFill>
                   <a:schemeClr val="bg1"/>
                 </a:solidFill>
               </a:rPr>
-              <a:pPr algn="r"/>
-              <a:t>22</a:t>
-            </a:fld>
-            <a:endParaRPr lang="en-US" dirty="0">
-              <a:solidFill>
-                <a:schemeClr val="bg1"/>
-              </a:solidFill>
-            </a:endParaRPr>
+              <a:t>21</a:t>
+            </a:r>
           </a:p>
         </p:txBody>
       </p:sp>
     </p:spTree>
-  </p:cSld>
-  <p:clrMapOvr>
-    <a:masterClrMapping/>
-  </p:clrMapOvr>
-  <mc:AlternateContent xmlns:mc="http://schemas.openxmlformats.org/markup-compatibility/2006" xmlns:p159="http://schemas.microsoft.com/office/powerpoint/2015/09/main">
-    <mc:Choice Requires="p159">
-      <p:transition xmlns:p14="http://schemas.microsoft.com/office/powerpoint/2010/main" spd="slow" p14:dur="2000">
-        <p159:morph option="byObject"/>
-      </p:transition>
-    </mc:Choice>
-    <mc:Fallback xmlns="">
-      <p:transition spd="slow">
-        <p:fade/>
-      </p:transition>
-    </mc:Fallback>
-  </mc:AlternateContent>
-</p:sld>
-</file>
-
-<file path=ppt/slides/slide23.xml><?xml version="1.0" encoding="utf-8"?>
-<p:sld xmlns:a="http://schemas.openxmlformats.org/drawingml/2006/main" xmlns:r="http://schemas.openxmlformats.org/officeDocument/2006/relationships" xmlns:p="http://schemas.openxmlformats.org/presentationml/2006/main">
-  <p:cSld>
-    <p:spTree>
-      <p:nvGrpSpPr>
-        <p:cNvPr id="1" name="">
-          <a:extLst>
-            <a:ext uri="{FF2B5EF4-FFF2-40B4-BE49-F238E27FC236}">
-              <a16:creationId xmlns:a16="http://schemas.microsoft.com/office/drawing/2014/main" id="{AA193BC0-D33A-D533-A8AC-AB89713C9449}"/>
-            </a:ext>
-          </a:extLst>
-        </p:cNvPr>
-        <p:cNvGrpSpPr/>
-        <p:nvPr/>
-      </p:nvGrpSpPr>
-      <p:grpSpPr>
-        <a:xfrm>
-          <a:off x="0" y="0"/>
-          <a:ext cx="0" cy="0"/>
-          <a:chOff x="0" y="0"/>
-          <a:chExt cx="0" cy="0"/>
-        </a:xfrm>
-      </p:grpSpPr>
-      <p:sp>
-        <p:nvSpPr>
-          <p:cNvPr id="2" name="Text 0">
-            <a:extLst>
-              <a:ext uri="{FF2B5EF4-FFF2-40B4-BE49-F238E27FC236}">
-                <a16:creationId xmlns:a16="http://schemas.microsoft.com/office/drawing/2014/main" id="{0067683D-E215-1688-1E7C-BBA9145CF3B8}"/>
-              </a:ext>
-            </a:extLst>
-          </p:cNvPr>
-          <p:cNvSpPr>
-            <a:spLocks noGrp="1"/>
-          </p:cNvSpPr>
-          <p:nvPr>
-            <p:ph type="title" idx="100" hasCustomPrompt="1"/>
-          </p:nvPr>
-        </p:nvSpPr>
-        <p:spPr>
-          <a:xfrm>
-            <a:off x="838200" y="311618"/>
-            <a:ext cx="10515600" cy="1097280"/>
-          </a:xfrm>
-          <a:prstGeom prst="rect">
-            <a:avLst/>
-          </a:prstGeom>
-          <a:noFill/>
-          <a:ln/>
-        </p:spPr>
-        <p:txBody>
-          <a:bodyPr wrap="square" lIns="0" tIns="0" rIns="0" bIns="0" rtlCol="0" anchor="ctr"/>
-          <a:lstStyle/>
-          <a:p>
-            <a:pPr marL="0" indent="0" algn="ctr">
-              <a:buNone/>
-            </a:pPr>
-            <a:r>
-              <a:rPr lang="en-US" sz="4400" b="1" dirty="0">
-                <a:solidFill>
-                  <a:schemeClr val="bg1"/>
-                </a:solidFill>
-              </a:rPr>
-              <a:t>Conclusion</a:t>
-            </a:r>
-            <a:endParaRPr lang="en-US" sz="4400" dirty="0"/>
-          </a:p>
-        </p:txBody>
-      </p:sp>
-      <p:sp>
-        <p:nvSpPr>
-          <p:cNvPr id="9" name="Card Accès immédiat">
-            <a:extLst>
-              <a:ext uri="{FF2B5EF4-FFF2-40B4-BE49-F238E27FC236}">
-                <a16:creationId xmlns:a16="http://schemas.microsoft.com/office/drawing/2014/main" id="{1B55DE4A-7FFB-B352-67B0-3959F6B6C726}"/>
-              </a:ext>
-            </a:extLst>
-          </p:cNvPr>
-          <p:cNvSpPr/>
-          <p:nvPr/>
-        </p:nvSpPr>
-        <p:spPr>
-          <a:xfrm>
-            <a:off x="838199" y="1823235"/>
-            <a:ext cx="2905125" cy="4048927"/>
-          </a:xfrm>
-          <a:prstGeom prst="roundRect">
-            <a:avLst>
-              <a:gd name="adj" fmla="val 9231"/>
-            </a:avLst>
-          </a:prstGeom>
-          <a:solidFill>
-            <a:schemeClr val="bg2"/>
-          </a:solidFill>
-          <a:ln w="12700">
-            <a:solidFill>
-              <a:schemeClr val="bg2"/>
-            </a:solidFill>
-            <a:prstDash val="solid"/>
-          </a:ln>
-        </p:spPr>
-        <p:txBody>
-          <a:bodyPr/>
-          <a:lstStyle/>
-          <a:p>
-            <a:endParaRPr lang="LID4096" dirty="0"/>
-          </a:p>
-        </p:txBody>
-      </p:sp>
-      <p:sp>
-        <p:nvSpPr>
-          <p:cNvPr id="11" name="Card Accès immédiat">
-            <a:extLst>
-              <a:ext uri="{FF2B5EF4-FFF2-40B4-BE49-F238E27FC236}">
-                <a16:creationId xmlns:a16="http://schemas.microsoft.com/office/drawing/2014/main" id="{A9D1379B-AA8D-FA04-F350-584CD3FFF252}"/>
-              </a:ext>
-            </a:extLst>
-          </p:cNvPr>
-          <p:cNvSpPr/>
-          <p:nvPr/>
-        </p:nvSpPr>
-        <p:spPr>
-          <a:xfrm>
-            <a:off x="4643436" y="1818874"/>
-            <a:ext cx="2905125" cy="4048927"/>
-          </a:xfrm>
-          <a:prstGeom prst="roundRect">
-            <a:avLst>
-              <a:gd name="adj" fmla="val 9231"/>
-            </a:avLst>
-          </a:prstGeom>
-          <a:solidFill>
-            <a:schemeClr val="tx1">
-              <a:lumMod val="50000"/>
-              <a:lumOff val="50000"/>
-            </a:schemeClr>
-          </a:solidFill>
-          <a:ln w="12700">
-            <a:solidFill>
-              <a:schemeClr val="bg2"/>
-            </a:solidFill>
-            <a:prstDash val="solid"/>
-          </a:ln>
-        </p:spPr>
-      </p:sp>
-      <p:sp>
-        <p:nvSpPr>
-          <p:cNvPr id="13" name="Card Accès immédiat">
-            <a:extLst>
-              <a:ext uri="{FF2B5EF4-FFF2-40B4-BE49-F238E27FC236}">
-                <a16:creationId xmlns:a16="http://schemas.microsoft.com/office/drawing/2014/main" id="{2FA924A8-8723-C9CE-4760-93407E7D0CEC}"/>
-              </a:ext>
-            </a:extLst>
-          </p:cNvPr>
-          <p:cNvSpPr/>
-          <p:nvPr/>
-        </p:nvSpPr>
-        <p:spPr>
-          <a:xfrm>
-            <a:off x="8448672" y="1818873"/>
-            <a:ext cx="2905125" cy="4048927"/>
-          </a:xfrm>
-          <a:prstGeom prst="roundRect">
-            <a:avLst>
-              <a:gd name="adj" fmla="val 9231"/>
-            </a:avLst>
-          </a:prstGeom>
-          <a:solidFill>
-            <a:schemeClr val="tx2">
-              <a:lumMod val="75000"/>
-            </a:schemeClr>
-          </a:solidFill>
-          <a:ln w="12700">
-            <a:solidFill>
-              <a:schemeClr val="bg2"/>
-            </a:solidFill>
-            <a:prstDash val="solid"/>
-          </a:ln>
-        </p:spPr>
-      </p:sp>
-      <p:sp>
-        <p:nvSpPr>
-          <p:cNvPr id="14" name="ZoneTexte 13">
-            <a:extLst>
-              <a:ext uri="{FF2B5EF4-FFF2-40B4-BE49-F238E27FC236}">
-                <a16:creationId xmlns:a16="http://schemas.microsoft.com/office/drawing/2014/main" id="{91A1560C-507A-F71D-0558-C702F896B794}"/>
-              </a:ext>
-            </a:extLst>
-          </p:cNvPr>
-          <p:cNvSpPr txBox="1"/>
-          <p:nvPr/>
-        </p:nvSpPr>
-        <p:spPr>
-          <a:xfrm>
-            <a:off x="1247773" y="2196998"/>
-            <a:ext cx="2085975" cy="400110"/>
-          </a:xfrm>
-          <a:prstGeom prst="rect">
-            <a:avLst/>
-          </a:prstGeom>
-          <a:noFill/>
-        </p:spPr>
-        <p:txBody>
-          <a:bodyPr wrap="square" rtlCol="0">
-            <a:spAutoFit/>
-          </a:bodyPr>
-          <a:lstStyle/>
-          <a:p>
-            <a:pPr algn="ctr"/>
-            <a:r>
-              <a:rPr lang="fr-FR" sz="2000" b="1" i="1" dirty="0">
-                <a:latin typeface="Times New Roman" panose="02020603050405020304" pitchFamily="18" charset="0"/>
-                <a:cs typeface="Times New Roman" panose="02020603050405020304" pitchFamily="18" charset="0"/>
-              </a:rPr>
-              <a:t>Bilan du projet</a:t>
-            </a:r>
-          </a:p>
-        </p:txBody>
-      </p:sp>
-      <p:sp>
-        <p:nvSpPr>
-          <p:cNvPr id="16" name="ZoneTexte 15">
-            <a:extLst>
-              <a:ext uri="{FF2B5EF4-FFF2-40B4-BE49-F238E27FC236}">
-                <a16:creationId xmlns:a16="http://schemas.microsoft.com/office/drawing/2014/main" id="{EEFF32B4-94FD-0C37-D4C1-FB564393EABA}"/>
-              </a:ext>
-            </a:extLst>
-          </p:cNvPr>
-          <p:cNvSpPr txBox="1"/>
-          <p:nvPr/>
-        </p:nvSpPr>
-        <p:spPr>
-          <a:xfrm>
-            <a:off x="5053010" y="2043110"/>
-            <a:ext cx="2085975" cy="707886"/>
-          </a:xfrm>
-          <a:prstGeom prst="rect">
-            <a:avLst/>
-          </a:prstGeom>
-          <a:noFill/>
-        </p:spPr>
-        <p:txBody>
-          <a:bodyPr wrap="square" rtlCol="0">
-            <a:spAutoFit/>
-          </a:bodyPr>
-          <a:lstStyle/>
-          <a:p>
-            <a:pPr algn="ctr"/>
-            <a:r>
-              <a:rPr lang="" sz="2000" b="1" i="1" dirty="0">
-                <a:latin typeface="Times New Roman" panose="02020603050405020304" pitchFamily="18" charset="0"/>
-                <a:cs typeface="Times New Roman" panose="02020603050405020304" pitchFamily="18" charset="0"/>
-              </a:rPr>
-              <a:t>Perspectives d'Évolution</a:t>
-            </a:r>
-            <a:endParaRPr lang="fr-FR" sz="2000" b="1" i="1" dirty="0">
-              <a:latin typeface="Times New Roman" panose="02020603050405020304" pitchFamily="18" charset="0"/>
-              <a:cs typeface="Times New Roman" panose="02020603050405020304" pitchFamily="18" charset="0"/>
-            </a:endParaRPr>
-          </a:p>
-        </p:txBody>
-      </p:sp>
-      <p:sp>
-        <p:nvSpPr>
-          <p:cNvPr id="18" name="ZoneTexte 17">
-            <a:extLst>
-              <a:ext uri="{FF2B5EF4-FFF2-40B4-BE49-F238E27FC236}">
-                <a16:creationId xmlns:a16="http://schemas.microsoft.com/office/drawing/2014/main" id="{24936CCF-24AF-0BB2-CF42-69AB8913E0C8}"/>
-              </a:ext>
-            </a:extLst>
-          </p:cNvPr>
-          <p:cNvSpPr txBox="1"/>
-          <p:nvPr/>
-        </p:nvSpPr>
-        <p:spPr>
-          <a:xfrm>
-            <a:off x="8858252" y="2196998"/>
-            <a:ext cx="2085975" cy="400110"/>
-          </a:xfrm>
-          <a:prstGeom prst="rect">
-            <a:avLst/>
-          </a:prstGeom>
-          <a:noFill/>
-        </p:spPr>
-        <p:txBody>
-          <a:bodyPr wrap="square" rtlCol="0">
-            <a:spAutoFit/>
-          </a:bodyPr>
-          <a:lstStyle/>
-          <a:p>
-            <a:pPr algn="ctr"/>
-            <a:r>
-              <a:rPr lang="" sz="2000" b="1" i="1" dirty="0">
-                <a:solidFill>
-                  <a:schemeClr val="bg1"/>
-                </a:solidFill>
-                <a:latin typeface="Times New Roman" panose="02020603050405020304" pitchFamily="18" charset="0"/>
-                <a:cs typeface="Times New Roman" panose="02020603050405020304" pitchFamily="18" charset="0"/>
-              </a:rPr>
-              <a:t>Apports du Stage</a:t>
-            </a:r>
-            <a:endParaRPr lang="fr-FR" sz="2000" b="1" i="1" dirty="0">
-              <a:solidFill>
-                <a:schemeClr val="bg1"/>
-              </a:solidFill>
-              <a:latin typeface="Times New Roman" panose="02020603050405020304" pitchFamily="18" charset="0"/>
-              <a:cs typeface="Times New Roman" panose="02020603050405020304" pitchFamily="18" charset="0"/>
-            </a:endParaRPr>
-          </a:p>
-        </p:txBody>
-      </p:sp>
-      <p:sp>
-        <p:nvSpPr>
-          <p:cNvPr id="20" name="ZoneTexte 19">
-            <a:extLst>
-              <a:ext uri="{FF2B5EF4-FFF2-40B4-BE49-F238E27FC236}">
-                <a16:creationId xmlns:a16="http://schemas.microsoft.com/office/drawing/2014/main" id="{DCA58E8A-368B-DF6D-11B0-849B5A9EC637}"/>
-              </a:ext>
-            </a:extLst>
-          </p:cNvPr>
-          <p:cNvSpPr txBox="1"/>
-          <p:nvPr/>
-        </p:nvSpPr>
-        <p:spPr>
-          <a:xfrm>
-            <a:off x="1247773" y="3011445"/>
-            <a:ext cx="2085975" cy="1938992"/>
-          </a:xfrm>
-          <a:prstGeom prst="rect">
-            <a:avLst/>
-          </a:prstGeom>
-          <a:noFill/>
-        </p:spPr>
-        <p:txBody>
-          <a:bodyPr wrap="square" rtlCol="0">
-            <a:spAutoFit/>
-          </a:bodyPr>
-          <a:lstStyle/>
-          <a:p>
-            <a:pPr marL="342900" indent="-342900">
-              <a:buFont typeface="Arial" panose="020B0604020202020204" pitchFamily="34" charset="0"/>
-              <a:buChar char="•"/>
-            </a:pPr>
-            <a:r>
-              <a:rPr lang="" sz="2000" dirty="0"/>
-              <a:t>Objectifs atteints</a:t>
-            </a:r>
-          </a:p>
-          <a:p>
-            <a:pPr marL="342900" indent="-342900">
-              <a:buFont typeface="Arial" panose="020B0604020202020204" pitchFamily="34" charset="0"/>
-              <a:buChar char="•"/>
-            </a:pPr>
-            <a:r>
-              <a:rPr lang="" sz="2000" dirty="0"/>
-              <a:t>Modernisation du SI</a:t>
-            </a:r>
-          </a:p>
-          <a:p>
-            <a:pPr marL="342900" indent="-342900">
-              <a:buFont typeface="Arial" panose="020B0604020202020204" pitchFamily="34" charset="0"/>
-              <a:buChar char="•"/>
-            </a:pPr>
-            <a:r>
-              <a:rPr lang="" sz="2000" dirty="0"/>
-              <a:t>Fiabilité technique</a:t>
-            </a:r>
-            <a:endParaRPr lang="fr-FR" sz="2000" dirty="0">
-              <a:latin typeface="Times New Roman" panose="02020603050405020304" pitchFamily="18" charset="0"/>
-              <a:cs typeface="Times New Roman" panose="02020603050405020304" pitchFamily="18" charset="0"/>
-            </a:endParaRPr>
-          </a:p>
-        </p:txBody>
-      </p:sp>
-      <p:sp>
-        <p:nvSpPr>
-          <p:cNvPr id="24" name="ZoneTexte 23">
-            <a:extLst>
-              <a:ext uri="{FF2B5EF4-FFF2-40B4-BE49-F238E27FC236}">
-                <a16:creationId xmlns:a16="http://schemas.microsoft.com/office/drawing/2014/main" id="{646A0746-D0EC-1637-27A7-7AF7FC6C665E}"/>
-              </a:ext>
-            </a:extLst>
-          </p:cNvPr>
-          <p:cNvSpPr txBox="1"/>
-          <p:nvPr/>
-        </p:nvSpPr>
-        <p:spPr>
-          <a:xfrm>
-            <a:off x="5053010" y="2975232"/>
-            <a:ext cx="2085975" cy="1938992"/>
-          </a:xfrm>
-          <a:prstGeom prst="rect">
-            <a:avLst/>
-          </a:prstGeom>
-          <a:noFill/>
-        </p:spPr>
-        <p:txBody>
-          <a:bodyPr wrap="square" rtlCol="0">
-            <a:spAutoFit/>
-          </a:bodyPr>
-          <a:lstStyle/>
-          <a:p>
-            <a:pPr marL="342900" indent="-342900">
-              <a:buFont typeface="Arial" panose="020B0604020202020204" pitchFamily="34" charset="0"/>
-              <a:buChar char="•"/>
-            </a:pPr>
-            <a:r>
-              <a:rPr lang="" sz="2000" dirty="0"/>
-              <a:t>Mode Déconnecté</a:t>
-            </a:r>
-          </a:p>
-          <a:p>
-            <a:pPr marL="342900" indent="-342900">
-              <a:buFont typeface="Arial" panose="020B0604020202020204" pitchFamily="34" charset="0"/>
-              <a:buChar char="•"/>
-            </a:pPr>
-            <a:r>
-              <a:rPr lang="" sz="2000" dirty="0"/>
-              <a:t>Calcul des Taxes</a:t>
-            </a:r>
-          </a:p>
-          <a:p>
-            <a:pPr marL="342900" indent="-342900">
-              <a:buFont typeface="Arial" panose="020B0604020202020204" pitchFamily="34" charset="0"/>
-              <a:buChar char="•"/>
-            </a:pPr>
-            <a:r>
-              <a:rPr lang="" sz="2000" dirty="0"/>
-              <a:t>Paiement en ligne</a:t>
-            </a:r>
-            <a:endParaRPr lang="fr-FR" sz="2000" dirty="0">
-              <a:latin typeface="Times New Roman" panose="02020603050405020304" pitchFamily="18" charset="0"/>
-              <a:cs typeface="Times New Roman" panose="02020603050405020304" pitchFamily="18" charset="0"/>
-            </a:endParaRPr>
-          </a:p>
-        </p:txBody>
-      </p:sp>
-      <p:sp>
-        <p:nvSpPr>
-          <p:cNvPr id="28" name="ZoneTexte 27">
-            <a:extLst>
-              <a:ext uri="{FF2B5EF4-FFF2-40B4-BE49-F238E27FC236}">
-                <a16:creationId xmlns:a16="http://schemas.microsoft.com/office/drawing/2014/main" id="{79B1705A-F32C-320B-EE63-AB526BEA02CA}"/>
-              </a:ext>
-            </a:extLst>
-          </p:cNvPr>
-          <p:cNvSpPr txBox="1"/>
-          <p:nvPr/>
-        </p:nvSpPr>
-        <p:spPr>
-          <a:xfrm>
-            <a:off x="8858252" y="2975232"/>
-            <a:ext cx="2085975" cy="707886"/>
-          </a:xfrm>
-          <a:prstGeom prst="rect">
-            <a:avLst/>
-          </a:prstGeom>
-          <a:noFill/>
-        </p:spPr>
-        <p:txBody>
-          <a:bodyPr wrap="square" rtlCol="0">
-            <a:spAutoFit/>
-          </a:bodyPr>
-          <a:lstStyle/>
-          <a:p>
-            <a:pPr marL="342900" indent="-342900">
-              <a:buFont typeface="Arial" panose="020B0604020202020204" pitchFamily="34" charset="0"/>
-              <a:buChar char="•"/>
-            </a:pPr>
-            <a:r>
-              <a:rPr lang="" sz="2000" dirty="0">
-                <a:solidFill>
-                  <a:schemeClr val="bg1"/>
-                </a:solidFill>
-              </a:rPr>
-              <a:t>Professionnels</a:t>
-            </a:r>
-          </a:p>
-          <a:p>
-            <a:pPr marL="342900" indent="-342900">
-              <a:buFont typeface="Arial" panose="020B0604020202020204" pitchFamily="34" charset="0"/>
-              <a:buChar char="•"/>
-            </a:pPr>
-            <a:r>
-              <a:rPr lang="" sz="2000" dirty="0">
-                <a:solidFill>
-                  <a:schemeClr val="bg1"/>
-                </a:solidFill>
-              </a:rPr>
-              <a:t>Techniques</a:t>
-            </a:r>
-            <a:endParaRPr lang="fr-FR" sz="2000" dirty="0">
-              <a:solidFill>
-                <a:schemeClr val="bg1"/>
-              </a:solidFill>
-              <a:latin typeface="Times New Roman" panose="02020603050405020304" pitchFamily="18" charset="0"/>
-              <a:cs typeface="Times New Roman" panose="02020603050405020304" pitchFamily="18" charset="0"/>
-            </a:endParaRPr>
-          </a:p>
-        </p:txBody>
-      </p:sp>
-      <p:sp>
-        <p:nvSpPr>
-          <p:cNvPr id="29" name="Slide Number Placeholder 0">
-            <a:extLst>
-              <a:ext uri="{FF2B5EF4-FFF2-40B4-BE49-F238E27FC236}">
-                <a16:creationId xmlns:a16="http://schemas.microsoft.com/office/drawing/2014/main" id="{AD01EC70-16C0-F08C-CD78-0BF8E52F66D9}"/>
-              </a:ext>
-            </a:extLst>
-          </p:cNvPr>
-          <p:cNvSpPr txBox="1">
-            <a:spLocks/>
-          </p:cNvSpPr>
-          <p:nvPr/>
-        </p:nvSpPr>
-        <p:spPr>
-          <a:xfrm>
-            <a:off x="10972800" y="6400800"/>
-            <a:ext cx="640080" cy="274320"/>
-          </a:xfrm>
-          <a:prstGeom prst="rect">
-            <a:avLst/>
-          </a:prstGeom>
-          <a:extLst>
-            <a:ext uri="{C572A759-6A51-4108-AA02-DFA0A04FC94B}">
-              <ma14:wrappingTextBoxFlag xmlns:ma14="http://schemas.microsoft.com/office/mac/drawingml/2011/main" xmlns="" val="0"/>
-            </a:ext>
-          </a:extLst>
-        </p:spPr>
-        <p:txBody>
-          <a:bodyPr/>
-          <a:lstStyle>
-            <a:lvl1pPr marL="0" algn="l" defTabSz="914400" rtl="0" eaLnBrk="1" latinLnBrk="0" hangingPunct="1">
-              <a:defRPr sz="1100" kern="1200">
-                <a:solidFill>
-                  <a:schemeClr val="tx1"/>
-                </a:solidFill>
-                <a:latin typeface="+mn-lt"/>
-                <a:ea typeface="+mn-ea"/>
-                <a:cs typeface="+mn-cs"/>
-              </a:defRPr>
-            </a:lvl1pPr>
-            <a:lvl2pPr marL="457200" algn="l" defTabSz="914400" rtl="0" eaLnBrk="1" latinLnBrk="0" hangingPunct="1">
-              <a:defRPr sz="1800" kern="1200">
-                <a:solidFill>
-                  <a:schemeClr val="tx1"/>
-                </a:solidFill>
-                <a:latin typeface="+mn-lt"/>
-                <a:ea typeface="+mn-ea"/>
-                <a:cs typeface="+mn-cs"/>
-              </a:defRPr>
-            </a:lvl2pPr>
-            <a:lvl3pPr marL="914400" algn="l" defTabSz="914400" rtl="0" eaLnBrk="1" latinLnBrk="0" hangingPunct="1">
-              <a:defRPr sz="1800" kern="1200">
-                <a:solidFill>
-                  <a:schemeClr val="tx1"/>
-                </a:solidFill>
-                <a:latin typeface="+mn-lt"/>
-                <a:ea typeface="+mn-ea"/>
-                <a:cs typeface="+mn-cs"/>
-              </a:defRPr>
-            </a:lvl3pPr>
-            <a:lvl4pPr marL="1371600" algn="l" defTabSz="914400" rtl="0" eaLnBrk="1" latinLnBrk="0" hangingPunct="1">
-              <a:defRPr sz="1800" kern="1200">
-                <a:solidFill>
-                  <a:schemeClr val="tx1"/>
-                </a:solidFill>
-                <a:latin typeface="+mn-lt"/>
-                <a:ea typeface="+mn-ea"/>
-                <a:cs typeface="+mn-cs"/>
-              </a:defRPr>
-            </a:lvl4pPr>
-            <a:lvl5pPr marL="1828800" algn="l" defTabSz="914400" rtl="0" eaLnBrk="1" latinLnBrk="0" hangingPunct="1">
-              <a:defRPr sz="1800" kern="1200">
-                <a:solidFill>
-                  <a:schemeClr val="tx1"/>
-                </a:solidFill>
-                <a:latin typeface="+mn-lt"/>
-                <a:ea typeface="+mn-ea"/>
-                <a:cs typeface="+mn-cs"/>
-              </a:defRPr>
-            </a:lvl5pPr>
-            <a:lvl6pPr marL="2286000" algn="l" defTabSz="914400" rtl="0" eaLnBrk="1" latinLnBrk="0" hangingPunct="1">
-              <a:defRPr sz="1800" kern="1200">
-                <a:solidFill>
-                  <a:schemeClr val="tx1"/>
-                </a:solidFill>
-                <a:latin typeface="+mn-lt"/>
-                <a:ea typeface="+mn-ea"/>
-                <a:cs typeface="+mn-cs"/>
-              </a:defRPr>
-            </a:lvl6pPr>
-            <a:lvl7pPr marL="2743200" algn="l" defTabSz="914400" rtl="0" eaLnBrk="1" latinLnBrk="0" hangingPunct="1">
-              <a:defRPr sz="1800" kern="1200">
-                <a:solidFill>
-                  <a:schemeClr val="tx1"/>
-                </a:solidFill>
-                <a:latin typeface="+mn-lt"/>
-                <a:ea typeface="+mn-ea"/>
-                <a:cs typeface="+mn-cs"/>
-              </a:defRPr>
-            </a:lvl7pPr>
-            <a:lvl8pPr marL="3200400" algn="l" defTabSz="914400" rtl="0" eaLnBrk="1" latinLnBrk="0" hangingPunct="1">
-              <a:defRPr sz="1800" kern="1200">
-                <a:solidFill>
-                  <a:schemeClr val="tx1"/>
-                </a:solidFill>
-                <a:latin typeface="+mn-lt"/>
-                <a:ea typeface="+mn-ea"/>
-                <a:cs typeface="+mn-cs"/>
-              </a:defRPr>
-            </a:lvl8pPr>
-            <a:lvl9pPr marL="3657600" algn="l" defTabSz="914400" rtl="0" eaLnBrk="1" latinLnBrk="0" hangingPunct="1">
-              <a:defRPr sz="1800" kern="1200">
-                <a:solidFill>
-                  <a:schemeClr val="tx1"/>
-                </a:solidFill>
-                <a:latin typeface="+mn-lt"/>
-                <a:ea typeface="+mn-ea"/>
-                <a:cs typeface="+mn-cs"/>
-              </a:defRPr>
-            </a:lvl9pPr>
-          </a:lstStyle>
-          <a:p>
-            <a:pPr algn="r"/>
-            <a:fld id="{F7021451-1387-4CA6-816F-3879F97B5CBC}" type="slidenum">
-              <a:rPr lang="en-US" smtClean="0">
-                <a:solidFill>
-                  <a:schemeClr val="bg1"/>
-                </a:solidFill>
-              </a:rPr>
-              <a:pPr algn="r"/>
-              <a:t>23</a:t>
-            </a:fld>
-            <a:endParaRPr lang="en-US" dirty="0">
-              <a:solidFill>
-                <a:schemeClr val="bg1"/>
-              </a:solidFill>
-            </a:endParaRPr>
-          </a:p>
-        </p:txBody>
-      </p:sp>
-    </p:spTree>
-    <p:extLst>
-      <p:ext uri="{BB962C8B-B14F-4D97-AF65-F5344CB8AC3E}">
-        <p14:creationId xmlns:p14="http://schemas.microsoft.com/office/powerpoint/2010/main" val="244142156"/>
-      </p:ext>
-    </p:extLst>
   </p:cSld>
   <p:clrMapOvr>
     <a:masterClrMapping/>
@@ -21369,6 +21110,667 @@
         <p:cNvPr id="1" name="">
           <a:extLst>
             <a:ext uri="{FF2B5EF4-FFF2-40B4-BE49-F238E27FC236}">
+              <a16:creationId xmlns:a16="http://schemas.microsoft.com/office/drawing/2014/main" id="{AA193BC0-D33A-D533-A8AC-AB89713C9449}"/>
+            </a:ext>
+          </a:extLst>
+        </p:cNvPr>
+        <p:cNvGrpSpPr/>
+        <p:nvPr/>
+      </p:nvGrpSpPr>
+      <p:grpSpPr>
+        <a:xfrm>
+          <a:off x="0" y="0"/>
+          <a:ext cx="0" cy="0"/>
+          <a:chOff x="0" y="0"/>
+          <a:chExt cx="0" cy="0"/>
+        </a:xfrm>
+      </p:grpSpPr>
+      <p:sp>
+        <p:nvSpPr>
+          <p:cNvPr id="2" name="Text 0">
+            <a:extLst>
+              <a:ext uri="{FF2B5EF4-FFF2-40B4-BE49-F238E27FC236}">
+                <a16:creationId xmlns:a16="http://schemas.microsoft.com/office/drawing/2014/main" id="{0067683D-E215-1688-1E7C-BBA9145CF3B8}"/>
+              </a:ext>
+            </a:extLst>
+          </p:cNvPr>
+          <p:cNvSpPr>
+            <a:spLocks noGrp="1"/>
+          </p:cNvSpPr>
+          <p:nvPr>
+            <p:ph type="title" idx="100" hasCustomPrompt="1"/>
+          </p:nvPr>
+        </p:nvSpPr>
+        <p:spPr>
+          <a:xfrm>
+            <a:off x="838200" y="311618"/>
+            <a:ext cx="10515600" cy="1097280"/>
+          </a:xfrm>
+          <a:prstGeom prst="rect">
+            <a:avLst/>
+          </a:prstGeom>
+          <a:noFill/>
+          <a:ln/>
+        </p:spPr>
+        <p:txBody>
+          <a:bodyPr wrap="square" lIns="0" tIns="0" rIns="0" bIns="0" rtlCol="0" anchor="ctr"/>
+          <a:lstStyle/>
+          <a:p>
+            <a:pPr marL="0" indent="0" algn="ctr">
+              <a:buNone/>
+            </a:pPr>
+            <a:r>
+              <a:rPr lang="en-US" sz="4400" b="1" dirty="0">
+                <a:solidFill>
+                  <a:schemeClr val="bg1"/>
+                </a:solidFill>
+              </a:rPr>
+              <a:t>Conclusion</a:t>
+            </a:r>
+            <a:endParaRPr lang="en-US" sz="4400" dirty="0"/>
+          </a:p>
+        </p:txBody>
+      </p:sp>
+      <p:sp>
+        <p:nvSpPr>
+          <p:cNvPr id="9" name="Card Accès immédiat">
+            <a:extLst>
+              <a:ext uri="{FF2B5EF4-FFF2-40B4-BE49-F238E27FC236}">
+                <a16:creationId xmlns:a16="http://schemas.microsoft.com/office/drawing/2014/main" id="{1B55DE4A-7FFB-B352-67B0-3959F6B6C726}"/>
+              </a:ext>
+            </a:extLst>
+          </p:cNvPr>
+          <p:cNvSpPr/>
+          <p:nvPr/>
+        </p:nvSpPr>
+        <p:spPr>
+          <a:xfrm>
+            <a:off x="838199" y="1823235"/>
+            <a:ext cx="2905125" cy="4048927"/>
+          </a:xfrm>
+          <a:prstGeom prst="roundRect">
+            <a:avLst>
+              <a:gd name="adj" fmla="val 9231"/>
+            </a:avLst>
+          </a:prstGeom>
+          <a:solidFill>
+            <a:schemeClr val="bg2"/>
+          </a:solidFill>
+          <a:ln w="12700">
+            <a:solidFill>
+              <a:schemeClr val="bg2"/>
+            </a:solidFill>
+            <a:prstDash val="solid"/>
+          </a:ln>
+        </p:spPr>
+        <p:txBody>
+          <a:bodyPr/>
+          <a:lstStyle/>
+          <a:p>
+            <a:endParaRPr lang="LID4096" dirty="0"/>
+          </a:p>
+        </p:txBody>
+      </p:sp>
+      <p:sp>
+        <p:nvSpPr>
+          <p:cNvPr id="11" name="Card Accès immédiat">
+            <a:extLst>
+              <a:ext uri="{FF2B5EF4-FFF2-40B4-BE49-F238E27FC236}">
+                <a16:creationId xmlns:a16="http://schemas.microsoft.com/office/drawing/2014/main" id="{A9D1379B-AA8D-FA04-F350-584CD3FFF252}"/>
+              </a:ext>
+            </a:extLst>
+          </p:cNvPr>
+          <p:cNvSpPr/>
+          <p:nvPr/>
+        </p:nvSpPr>
+        <p:spPr>
+          <a:xfrm>
+            <a:off x="4643436" y="1818874"/>
+            <a:ext cx="2905125" cy="4048927"/>
+          </a:xfrm>
+          <a:prstGeom prst="roundRect">
+            <a:avLst>
+              <a:gd name="adj" fmla="val 9231"/>
+            </a:avLst>
+          </a:prstGeom>
+          <a:solidFill>
+            <a:schemeClr val="tx1">
+              <a:lumMod val="50000"/>
+              <a:lumOff val="50000"/>
+            </a:schemeClr>
+          </a:solidFill>
+          <a:ln w="12700">
+            <a:solidFill>
+              <a:schemeClr val="bg2"/>
+            </a:solidFill>
+            <a:prstDash val="solid"/>
+          </a:ln>
+        </p:spPr>
+      </p:sp>
+      <p:sp>
+        <p:nvSpPr>
+          <p:cNvPr id="13" name="Card Accès immédiat">
+            <a:extLst>
+              <a:ext uri="{FF2B5EF4-FFF2-40B4-BE49-F238E27FC236}">
+                <a16:creationId xmlns:a16="http://schemas.microsoft.com/office/drawing/2014/main" id="{2FA924A8-8723-C9CE-4760-93407E7D0CEC}"/>
+              </a:ext>
+            </a:extLst>
+          </p:cNvPr>
+          <p:cNvSpPr/>
+          <p:nvPr/>
+        </p:nvSpPr>
+        <p:spPr>
+          <a:xfrm>
+            <a:off x="8448672" y="1818873"/>
+            <a:ext cx="2905125" cy="4048927"/>
+          </a:xfrm>
+          <a:prstGeom prst="roundRect">
+            <a:avLst>
+              <a:gd name="adj" fmla="val 9231"/>
+            </a:avLst>
+          </a:prstGeom>
+          <a:solidFill>
+            <a:schemeClr val="tx2">
+              <a:lumMod val="75000"/>
+            </a:schemeClr>
+          </a:solidFill>
+          <a:ln w="12700">
+            <a:solidFill>
+              <a:schemeClr val="bg2"/>
+            </a:solidFill>
+            <a:prstDash val="solid"/>
+          </a:ln>
+        </p:spPr>
+      </p:sp>
+      <p:sp>
+        <p:nvSpPr>
+          <p:cNvPr id="14" name="ZoneTexte 13">
+            <a:extLst>
+              <a:ext uri="{FF2B5EF4-FFF2-40B4-BE49-F238E27FC236}">
+                <a16:creationId xmlns:a16="http://schemas.microsoft.com/office/drawing/2014/main" id="{91A1560C-507A-F71D-0558-C702F896B794}"/>
+              </a:ext>
+            </a:extLst>
+          </p:cNvPr>
+          <p:cNvSpPr txBox="1"/>
+          <p:nvPr/>
+        </p:nvSpPr>
+        <p:spPr>
+          <a:xfrm>
+            <a:off x="1247773" y="2196998"/>
+            <a:ext cx="2085975" cy="400110"/>
+          </a:xfrm>
+          <a:prstGeom prst="rect">
+            <a:avLst/>
+          </a:prstGeom>
+          <a:noFill/>
+        </p:spPr>
+        <p:txBody>
+          <a:bodyPr wrap="square" rtlCol="0">
+            <a:spAutoFit/>
+          </a:bodyPr>
+          <a:lstStyle/>
+          <a:p>
+            <a:pPr algn="ctr"/>
+            <a:r>
+              <a:rPr lang="fr-FR" sz="2000" b="1" i="1" dirty="0">
+                <a:latin typeface="Times New Roman" panose="02020603050405020304" pitchFamily="18" charset="0"/>
+                <a:cs typeface="Times New Roman" panose="02020603050405020304" pitchFamily="18" charset="0"/>
+              </a:rPr>
+              <a:t>Bilan du projet</a:t>
+            </a:r>
+          </a:p>
+        </p:txBody>
+      </p:sp>
+      <p:sp>
+        <p:nvSpPr>
+          <p:cNvPr id="16" name="ZoneTexte 15">
+            <a:extLst>
+              <a:ext uri="{FF2B5EF4-FFF2-40B4-BE49-F238E27FC236}">
+                <a16:creationId xmlns:a16="http://schemas.microsoft.com/office/drawing/2014/main" id="{EEFF32B4-94FD-0C37-D4C1-FB564393EABA}"/>
+              </a:ext>
+            </a:extLst>
+          </p:cNvPr>
+          <p:cNvSpPr txBox="1"/>
+          <p:nvPr/>
+        </p:nvSpPr>
+        <p:spPr>
+          <a:xfrm>
+            <a:off x="5053010" y="2043110"/>
+            <a:ext cx="2085975" cy="707886"/>
+          </a:xfrm>
+          <a:prstGeom prst="rect">
+            <a:avLst/>
+          </a:prstGeom>
+          <a:noFill/>
+        </p:spPr>
+        <p:txBody>
+          <a:bodyPr wrap="square" rtlCol="0">
+            <a:spAutoFit/>
+          </a:bodyPr>
+          <a:lstStyle/>
+          <a:p>
+            <a:pPr algn="ctr"/>
+            <a:r>
+              <a:rPr lang="" sz="2000" b="1" i="1" dirty="0">
+                <a:latin typeface="Times New Roman" panose="02020603050405020304" pitchFamily="18" charset="0"/>
+                <a:cs typeface="Times New Roman" panose="02020603050405020304" pitchFamily="18" charset="0"/>
+              </a:rPr>
+              <a:t>Perspectives d'Évolution</a:t>
+            </a:r>
+            <a:endParaRPr lang="fr-FR" sz="2000" b="1" i="1" dirty="0">
+              <a:latin typeface="Times New Roman" panose="02020603050405020304" pitchFamily="18" charset="0"/>
+              <a:cs typeface="Times New Roman" panose="02020603050405020304" pitchFamily="18" charset="0"/>
+            </a:endParaRPr>
+          </a:p>
+        </p:txBody>
+      </p:sp>
+      <p:sp>
+        <p:nvSpPr>
+          <p:cNvPr id="18" name="ZoneTexte 17">
+            <a:extLst>
+              <a:ext uri="{FF2B5EF4-FFF2-40B4-BE49-F238E27FC236}">
+                <a16:creationId xmlns:a16="http://schemas.microsoft.com/office/drawing/2014/main" id="{24936CCF-24AF-0BB2-CF42-69AB8913E0C8}"/>
+              </a:ext>
+            </a:extLst>
+          </p:cNvPr>
+          <p:cNvSpPr txBox="1"/>
+          <p:nvPr/>
+        </p:nvSpPr>
+        <p:spPr>
+          <a:xfrm>
+            <a:off x="8858252" y="2196998"/>
+            <a:ext cx="2085975" cy="400110"/>
+          </a:xfrm>
+          <a:prstGeom prst="rect">
+            <a:avLst/>
+          </a:prstGeom>
+          <a:noFill/>
+        </p:spPr>
+        <p:txBody>
+          <a:bodyPr wrap="square" rtlCol="0">
+            <a:spAutoFit/>
+          </a:bodyPr>
+          <a:lstStyle/>
+          <a:p>
+            <a:pPr algn="ctr"/>
+            <a:r>
+              <a:rPr lang="" sz="2000" b="1" i="1" dirty="0">
+                <a:solidFill>
+                  <a:schemeClr val="bg1"/>
+                </a:solidFill>
+                <a:latin typeface="Times New Roman" panose="02020603050405020304" pitchFamily="18" charset="0"/>
+                <a:cs typeface="Times New Roman" panose="02020603050405020304" pitchFamily="18" charset="0"/>
+              </a:rPr>
+              <a:t>Apports du Stage</a:t>
+            </a:r>
+            <a:endParaRPr lang="fr-FR" sz="2000" b="1" i="1" dirty="0">
+              <a:solidFill>
+                <a:schemeClr val="bg1"/>
+              </a:solidFill>
+              <a:latin typeface="Times New Roman" panose="02020603050405020304" pitchFamily="18" charset="0"/>
+              <a:cs typeface="Times New Roman" panose="02020603050405020304" pitchFamily="18" charset="0"/>
+            </a:endParaRPr>
+          </a:p>
+        </p:txBody>
+      </p:sp>
+      <p:sp>
+        <p:nvSpPr>
+          <p:cNvPr id="20" name="ZoneTexte 19">
+            <a:extLst>
+              <a:ext uri="{FF2B5EF4-FFF2-40B4-BE49-F238E27FC236}">
+                <a16:creationId xmlns:a16="http://schemas.microsoft.com/office/drawing/2014/main" id="{DCA58E8A-368B-DF6D-11B0-849B5A9EC637}"/>
+              </a:ext>
+            </a:extLst>
+          </p:cNvPr>
+          <p:cNvSpPr txBox="1"/>
+          <p:nvPr/>
+        </p:nvSpPr>
+        <p:spPr>
+          <a:xfrm>
+            <a:off x="1247773" y="3011445"/>
+            <a:ext cx="2085975" cy="1938992"/>
+          </a:xfrm>
+          <a:prstGeom prst="rect">
+            <a:avLst/>
+          </a:prstGeom>
+          <a:noFill/>
+        </p:spPr>
+        <p:txBody>
+          <a:bodyPr wrap="square" rtlCol="0">
+            <a:spAutoFit/>
+          </a:bodyPr>
+          <a:lstStyle/>
+          <a:p>
+            <a:pPr marL="342900" indent="-342900">
+              <a:buFont typeface="Arial" panose="020B0604020202020204" pitchFamily="34" charset="0"/>
+              <a:buChar char="•"/>
+            </a:pPr>
+            <a:r>
+              <a:rPr lang="" sz="2000" dirty="0"/>
+              <a:t>Objectifs atteints</a:t>
+            </a:r>
+          </a:p>
+          <a:p>
+            <a:pPr marL="342900" indent="-342900">
+              <a:buFont typeface="Arial" panose="020B0604020202020204" pitchFamily="34" charset="0"/>
+              <a:buChar char="•"/>
+            </a:pPr>
+            <a:r>
+              <a:rPr lang="" sz="2000" dirty="0"/>
+              <a:t>Modernisation du SI</a:t>
+            </a:r>
+          </a:p>
+          <a:p>
+            <a:pPr marL="342900" indent="-342900">
+              <a:buFont typeface="Arial" panose="020B0604020202020204" pitchFamily="34" charset="0"/>
+              <a:buChar char="•"/>
+            </a:pPr>
+            <a:r>
+              <a:rPr lang="" sz="2000" dirty="0"/>
+              <a:t>Fiabilité technique</a:t>
+            </a:r>
+            <a:endParaRPr lang="fr-FR" sz="2000" dirty="0">
+              <a:latin typeface="Times New Roman" panose="02020603050405020304" pitchFamily="18" charset="0"/>
+              <a:cs typeface="Times New Roman" panose="02020603050405020304" pitchFamily="18" charset="0"/>
+            </a:endParaRPr>
+          </a:p>
+        </p:txBody>
+      </p:sp>
+      <p:sp>
+        <p:nvSpPr>
+          <p:cNvPr id="24" name="ZoneTexte 23">
+            <a:extLst>
+              <a:ext uri="{FF2B5EF4-FFF2-40B4-BE49-F238E27FC236}">
+                <a16:creationId xmlns:a16="http://schemas.microsoft.com/office/drawing/2014/main" id="{646A0746-D0EC-1637-27A7-7AF7FC6C665E}"/>
+              </a:ext>
+            </a:extLst>
+          </p:cNvPr>
+          <p:cNvSpPr txBox="1"/>
+          <p:nvPr/>
+        </p:nvSpPr>
+        <p:spPr>
+          <a:xfrm>
+            <a:off x="5053010" y="2975232"/>
+            <a:ext cx="2085975" cy="1938992"/>
+          </a:xfrm>
+          <a:prstGeom prst="rect">
+            <a:avLst/>
+          </a:prstGeom>
+          <a:noFill/>
+        </p:spPr>
+        <p:txBody>
+          <a:bodyPr wrap="square" rtlCol="0">
+            <a:spAutoFit/>
+          </a:bodyPr>
+          <a:lstStyle/>
+          <a:p>
+            <a:pPr marL="342900" indent="-342900">
+              <a:buFont typeface="Arial" panose="020B0604020202020204" pitchFamily="34" charset="0"/>
+              <a:buChar char="•"/>
+            </a:pPr>
+            <a:r>
+              <a:rPr lang="" sz="2000" dirty="0"/>
+              <a:t>Mode Déconnecté</a:t>
+            </a:r>
+          </a:p>
+          <a:p>
+            <a:pPr marL="342900" indent="-342900">
+              <a:buFont typeface="Arial" panose="020B0604020202020204" pitchFamily="34" charset="0"/>
+              <a:buChar char="•"/>
+            </a:pPr>
+            <a:r>
+              <a:rPr lang="" sz="2000" dirty="0"/>
+              <a:t>Calcul des Taxes</a:t>
+            </a:r>
+          </a:p>
+          <a:p>
+            <a:pPr marL="342900" indent="-342900">
+              <a:buFont typeface="Arial" panose="020B0604020202020204" pitchFamily="34" charset="0"/>
+              <a:buChar char="•"/>
+            </a:pPr>
+            <a:r>
+              <a:rPr lang="" sz="2000" dirty="0"/>
+              <a:t>Paiement en ligne</a:t>
+            </a:r>
+            <a:endParaRPr lang="fr-FR" sz="2000" dirty="0">
+              <a:latin typeface="Times New Roman" panose="02020603050405020304" pitchFamily="18" charset="0"/>
+              <a:cs typeface="Times New Roman" panose="02020603050405020304" pitchFamily="18" charset="0"/>
+            </a:endParaRPr>
+          </a:p>
+        </p:txBody>
+      </p:sp>
+      <p:sp>
+        <p:nvSpPr>
+          <p:cNvPr id="28" name="ZoneTexte 27">
+            <a:extLst>
+              <a:ext uri="{FF2B5EF4-FFF2-40B4-BE49-F238E27FC236}">
+                <a16:creationId xmlns:a16="http://schemas.microsoft.com/office/drawing/2014/main" id="{79B1705A-F32C-320B-EE63-AB526BEA02CA}"/>
+              </a:ext>
+            </a:extLst>
+          </p:cNvPr>
+          <p:cNvSpPr txBox="1"/>
+          <p:nvPr/>
+        </p:nvSpPr>
+        <p:spPr>
+          <a:xfrm>
+            <a:off x="8858252" y="2975232"/>
+            <a:ext cx="2085975" cy="707886"/>
+          </a:xfrm>
+          <a:prstGeom prst="rect">
+            <a:avLst/>
+          </a:prstGeom>
+          <a:noFill/>
+        </p:spPr>
+        <p:txBody>
+          <a:bodyPr wrap="square" rtlCol="0">
+            <a:spAutoFit/>
+          </a:bodyPr>
+          <a:lstStyle/>
+          <a:p>
+            <a:pPr marL="342900" indent="-342900">
+              <a:buFont typeface="Arial" panose="020B0604020202020204" pitchFamily="34" charset="0"/>
+              <a:buChar char="•"/>
+            </a:pPr>
+            <a:r>
+              <a:rPr lang="" sz="2000" dirty="0">
+                <a:solidFill>
+                  <a:schemeClr val="bg1"/>
+                </a:solidFill>
+              </a:rPr>
+              <a:t>Professionnels</a:t>
+            </a:r>
+          </a:p>
+          <a:p>
+            <a:pPr marL="342900" indent="-342900">
+              <a:buFont typeface="Arial" panose="020B0604020202020204" pitchFamily="34" charset="0"/>
+              <a:buChar char="•"/>
+            </a:pPr>
+            <a:r>
+              <a:rPr lang="" sz="2000" dirty="0">
+                <a:solidFill>
+                  <a:schemeClr val="bg1"/>
+                </a:solidFill>
+              </a:rPr>
+              <a:t>Techniques</a:t>
+            </a:r>
+            <a:endParaRPr lang="fr-FR" sz="2000" dirty="0">
+              <a:solidFill>
+                <a:schemeClr val="bg1"/>
+              </a:solidFill>
+              <a:latin typeface="Times New Roman" panose="02020603050405020304" pitchFamily="18" charset="0"/>
+              <a:cs typeface="Times New Roman" panose="02020603050405020304" pitchFamily="18" charset="0"/>
+            </a:endParaRPr>
+          </a:p>
+        </p:txBody>
+      </p:sp>
+      <p:sp>
+        <p:nvSpPr>
+          <p:cNvPr id="29" name="Slide Number Placeholder 0">
+            <a:extLst>
+              <a:ext uri="{FF2B5EF4-FFF2-40B4-BE49-F238E27FC236}">
+                <a16:creationId xmlns:a16="http://schemas.microsoft.com/office/drawing/2014/main" id="{AD01EC70-16C0-F08C-CD78-0BF8E52F66D9}"/>
+              </a:ext>
+            </a:extLst>
+          </p:cNvPr>
+          <p:cNvSpPr txBox="1">
+            <a:spLocks/>
+          </p:cNvSpPr>
+          <p:nvPr/>
+        </p:nvSpPr>
+        <p:spPr>
+          <a:xfrm>
+            <a:off x="10972800" y="6400800"/>
+            <a:ext cx="640080" cy="274320"/>
+          </a:xfrm>
+          <a:prstGeom prst="rect">
+            <a:avLst/>
+          </a:prstGeom>
+          <a:extLst>
+            <a:ext uri="{C572A759-6A51-4108-AA02-DFA0A04FC94B}">
+              <ma14:wrappingTextBoxFlag xmlns="" xmlns:ma14="http://schemas.microsoft.com/office/mac/drawingml/2011/main" val="0"/>
+            </a:ext>
+          </a:extLst>
+        </p:spPr>
+        <p:txBody>
+          <a:bodyPr/>
+          <a:lstStyle>
+            <a:lvl1pPr marL="0" algn="l" defTabSz="914400" rtl="0" eaLnBrk="1" latinLnBrk="0" hangingPunct="1">
+              <a:defRPr sz="1100" kern="1200">
+                <a:solidFill>
+                  <a:schemeClr val="tx1"/>
+                </a:solidFill>
+                <a:latin typeface="+mn-lt"/>
+                <a:ea typeface="+mn-ea"/>
+                <a:cs typeface="+mn-cs"/>
+              </a:defRPr>
+            </a:lvl1pPr>
+            <a:lvl2pPr marL="457200" algn="l" defTabSz="914400" rtl="0" eaLnBrk="1" latinLnBrk="0" hangingPunct="1">
+              <a:defRPr sz="1800" kern="1200">
+                <a:solidFill>
+                  <a:schemeClr val="tx1"/>
+                </a:solidFill>
+                <a:latin typeface="+mn-lt"/>
+                <a:ea typeface="+mn-ea"/>
+                <a:cs typeface="+mn-cs"/>
+              </a:defRPr>
+            </a:lvl2pPr>
+            <a:lvl3pPr marL="914400" algn="l" defTabSz="914400" rtl="0" eaLnBrk="1" latinLnBrk="0" hangingPunct="1">
+              <a:defRPr sz="1800" kern="1200">
+                <a:solidFill>
+                  <a:schemeClr val="tx1"/>
+                </a:solidFill>
+                <a:latin typeface="+mn-lt"/>
+                <a:ea typeface="+mn-ea"/>
+                <a:cs typeface="+mn-cs"/>
+              </a:defRPr>
+            </a:lvl3pPr>
+            <a:lvl4pPr marL="1371600" algn="l" defTabSz="914400" rtl="0" eaLnBrk="1" latinLnBrk="0" hangingPunct="1">
+              <a:defRPr sz="1800" kern="1200">
+                <a:solidFill>
+                  <a:schemeClr val="tx1"/>
+                </a:solidFill>
+                <a:latin typeface="+mn-lt"/>
+                <a:ea typeface="+mn-ea"/>
+                <a:cs typeface="+mn-cs"/>
+              </a:defRPr>
+            </a:lvl4pPr>
+            <a:lvl5pPr marL="1828800" algn="l" defTabSz="914400" rtl="0" eaLnBrk="1" latinLnBrk="0" hangingPunct="1">
+              <a:defRPr sz="1800" kern="1200">
+                <a:solidFill>
+                  <a:schemeClr val="tx1"/>
+                </a:solidFill>
+                <a:latin typeface="+mn-lt"/>
+                <a:ea typeface="+mn-ea"/>
+                <a:cs typeface="+mn-cs"/>
+              </a:defRPr>
+            </a:lvl5pPr>
+            <a:lvl6pPr marL="2286000" algn="l" defTabSz="914400" rtl="0" eaLnBrk="1" latinLnBrk="0" hangingPunct="1">
+              <a:defRPr sz="1800" kern="1200">
+                <a:solidFill>
+                  <a:schemeClr val="tx1"/>
+                </a:solidFill>
+                <a:latin typeface="+mn-lt"/>
+                <a:ea typeface="+mn-ea"/>
+                <a:cs typeface="+mn-cs"/>
+              </a:defRPr>
+            </a:lvl6pPr>
+            <a:lvl7pPr marL="2743200" algn="l" defTabSz="914400" rtl="0" eaLnBrk="1" latinLnBrk="0" hangingPunct="1">
+              <a:defRPr sz="1800" kern="1200">
+                <a:solidFill>
+                  <a:schemeClr val="tx1"/>
+                </a:solidFill>
+                <a:latin typeface="+mn-lt"/>
+                <a:ea typeface="+mn-ea"/>
+                <a:cs typeface="+mn-cs"/>
+              </a:defRPr>
+            </a:lvl7pPr>
+            <a:lvl8pPr marL="3200400" algn="l" defTabSz="914400" rtl="0" eaLnBrk="1" latinLnBrk="0" hangingPunct="1">
+              <a:defRPr sz="1800" kern="1200">
+                <a:solidFill>
+                  <a:schemeClr val="tx1"/>
+                </a:solidFill>
+                <a:latin typeface="+mn-lt"/>
+                <a:ea typeface="+mn-ea"/>
+                <a:cs typeface="+mn-cs"/>
+              </a:defRPr>
+            </a:lvl8pPr>
+            <a:lvl9pPr marL="3657600" algn="l" defTabSz="914400" rtl="0" eaLnBrk="1" latinLnBrk="0" hangingPunct="1">
+              <a:defRPr sz="1800" kern="1200">
+                <a:solidFill>
+                  <a:schemeClr val="tx1"/>
+                </a:solidFill>
+                <a:latin typeface="+mn-lt"/>
+                <a:ea typeface="+mn-ea"/>
+                <a:cs typeface="+mn-cs"/>
+              </a:defRPr>
+            </a:lvl9pPr>
+          </a:lstStyle>
+          <a:p>
+            <a:pPr algn="r"/>
+            <a:r>
+              <a:rPr lang="en-US" dirty="0">
+                <a:solidFill>
+                  <a:schemeClr val="bg1"/>
+                </a:solidFill>
+              </a:rPr>
+              <a:t>21</a:t>
+            </a:r>
+          </a:p>
+        </p:txBody>
+      </p:sp>
+    </p:spTree>
+    <p:extLst>
+      <p:ext uri="{BB962C8B-B14F-4D97-AF65-F5344CB8AC3E}">
+        <p14:creationId xmlns:p14="http://schemas.microsoft.com/office/powerpoint/2010/main" val="244142156"/>
+      </p:ext>
+    </p:extLst>
+  </p:cSld>
+  <p:clrMapOvr>
+    <a:masterClrMapping/>
+  </p:clrMapOvr>
+  <mc:AlternateContent xmlns:mc="http://schemas.openxmlformats.org/markup-compatibility/2006" xmlns:p159="http://schemas.microsoft.com/office/powerpoint/2015/09/main">
+    <mc:Choice Requires="p159">
+      <p:transition xmlns:p14="http://schemas.microsoft.com/office/powerpoint/2010/main" spd="slow" p14:dur="2000">
+        <p159:morph option="byObject"/>
+      </p:transition>
+    </mc:Choice>
+    <mc:Fallback xmlns="">
+      <p:transition spd="slow">
+        <p:fade/>
+      </p:transition>
+    </mc:Fallback>
+  </mc:AlternateContent>
+</p:sld>
+</file>
+
+<file path=ppt/slides/slide25.xml><?xml version="1.0" encoding="utf-8"?>
+<p:sld xmlns:a="http://schemas.openxmlformats.org/drawingml/2006/main" xmlns:r="http://schemas.openxmlformats.org/officeDocument/2006/relationships" xmlns:p="http://schemas.openxmlformats.org/presentationml/2006/main">
+  <p:cSld>
+    <p:spTree>
+      <p:nvGrpSpPr>
+        <p:cNvPr id="1" name="">
+          <a:extLst>
+            <a:ext uri="{FF2B5EF4-FFF2-40B4-BE49-F238E27FC236}">
               <a16:creationId xmlns:a16="http://schemas.microsoft.com/office/drawing/2014/main" id="{DED19406-0F1F-07E1-0EDE-1189C211AC24}"/>
             </a:ext>
           </a:extLst>
@@ -21516,7 +21918,7 @@
           </a:prstGeom>
           <a:extLst>
             <a:ext uri="{C572A759-6A51-4108-AA02-DFA0A04FC94B}">
-              <ma14:wrappingTextBoxFlag xmlns="" xmlns:ma14="http://schemas.microsoft.com/office/mac/drawingml/2011/main" val="0"/>
+              <ma14:wrappingTextBoxFlag xmlns:ma14="http://schemas.microsoft.com/office/mac/drawingml/2011/main" xmlns="" val="0"/>
             </a:ext>
           </a:extLst>
         </p:spPr>
@@ -21616,20 +22018,14 @@
           </a:lstStyle>
           <a:p>
             <a:pPr algn="r"/>
-            <a:fld id="{F7021451-1387-4CA6-816F-3879F97B5CBC}" type="slidenum">
-              <a:rPr lang="en-US" smtClean="0">
+            <a:r>
+              <a:rPr lang="en-US" dirty="0">
                 <a:solidFill>
                   <a:schemeClr val="bg1"/>
                 </a:solidFill>
               </a:rPr>
-              <a:pPr algn="r"/>
-              <a:t>24</a:t>
-            </a:fld>
-            <a:endParaRPr lang="en-US" dirty="0">
-              <a:solidFill>
-                <a:schemeClr val="bg1"/>
-              </a:solidFill>
-            </a:endParaRPr>
+              <a:t>22</a:t>
+            </a:r>
           </a:p>
         </p:txBody>
       </p:sp>
@@ -22281,7 +22677,7 @@
           </a:prstGeom>
           <a:extLst>
             <a:ext uri="{C572A759-6A51-4108-AA02-DFA0A04FC94B}">
-              <ma14:wrappingTextBoxFlag xmlns:ma14="http://schemas.microsoft.com/office/mac/drawingml/2011/main" xmlns="" val="0"/>
+              <ma14:wrappingTextBoxFlag xmlns="" xmlns:ma14="http://schemas.microsoft.com/office/mac/drawingml/2011/main" val="0"/>
             </a:ext>
           </a:extLst>
         </p:spPr>
@@ -22945,7 +23341,7 @@
           </a:prstGeom>
           <a:extLst>
             <a:ext uri="{C572A759-6A51-4108-AA02-DFA0A04FC94B}">
-              <ma14:wrappingTextBoxFlag xmlns="" xmlns:ma14="http://schemas.microsoft.com/office/mac/drawingml/2011/main" val="0"/>
+              <ma14:wrappingTextBoxFlag xmlns:ma14="http://schemas.microsoft.com/office/mac/drawingml/2011/main" xmlns="" val="0"/>
             </a:ext>
           </a:extLst>
         </p:spPr>
@@ -22962,11 +23358,10 @@
           </a:lstStyle>
           <a:p>
             <a:pPr algn="r"/>
-            <a:fld id="{F7021451-1387-4CA6-816F-3879F97B5CBC}" type="slidenum">
-              <a:rPr lang="en-US" b="0"/>
-              <a:t>4</a:t>
-            </a:fld>
-            <a:endParaRPr lang="en-US"/>
+            <a:r>
+              <a:rPr lang="en-US" dirty="0"/>
+              <a:t>3</a:t>
+            </a:r>
           </a:p>
         </p:txBody>
       </p:sp>
@@ -23116,7 +23511,7 @@
           </a:prstGeom>
           <a:extLst>
             <a:ext uri="{C572A759-6A51-4108-AA02-DFA0A04FC94B}">
-              <ma14:wrappingTextBoxFlag xmlns="" xmlns:ma14="http://schemas.microsoft.com/office/mac/drawingml/2011/main" val="0"/>
+              <ma14:wrappingTextBoxFlag xmlns:ma14="http://schemas.microsoft.com/office/mac/drawingml/2011/main" xmlns="" val="0"/>
             </a:ext>
           </a:extLst>
         </p:spPr>
@@ -23216,20 +23611,14 @@
           </a:lstStyle>
           <a:p>
             <a:pPr algn="r"/>
-            <a:fld id="{F7021451-1387-4CA6-816F-3879F97B5CBC}" type="slidenum">
-              <a:rPr lang="en-US" smtClean="0">
+            <a:r>
+              <a:rPr lang="en-US" dirty="0">
                 <a:solidFill>
                   <a:schemeClr val="bg1"/>
                 </a:solidFill>
               </a:rPr>
-              <a:pPr algn="r"/>
-              <a:t>5</a:t>
-            </a:fld>
-            <a:endParaRPr lang="en-US" dirty="0">
-              <a:solidFill>
-                <a:schemeClr val="bg1"/>
-              </a:solidFill>
-            </a:endParaRPr>
+              <a:t>4</a:t>
+            </a:r>
           </a:p>
         </p:txBody>
       </p:sp>
@@ -23923,7 +24312,7 @@
           </a:prstGeom>
           <a:extLst>
             <a:ext uri="{C572A759-6A51-4108-AA02-DFA0A04FC94B}">
-              <ma14:wrappingTextBoxFlag xmlns="" xmlns:ma14="http://schemas.microsoft.com/office/mac/drawingml/2011/main" val="0"/>
+              <ma14:wrappingTextBoxFlag xmlns:ma14="http://schemas.microsoft.com/office/mac/drawingml/2011/main" xmlns="" val="0"/>
             </a:ext>
           </a:extLst>
         </p:spPr>
@@ -23940,11 +24329,11 @@
           </a:lstStyle>
           <a:p>
             <a:pPr algn="r"/>
-            <a:fld id="{F7021451-1387-4CA6-816F-3879F97B5CBC}" type="slidenum">
-              <a:rPr lang="en-US" b="0"/>
-              <a:t>6</a:t>
-            </a:fld>
-            <a:endParaRPr lang="en-US"/>
+            <a:r>
+              <a:rPr lang="en-US" b="0" dirty="0"/>
+              <a:t>5</a:t>
+            </a:r>
+            <a:endParaRPr lang="en-US" dirty="0"/>
           </a:p>
         </p:txBody>
       </p:sp>
@@ -24065,7 +24454,7 @@
           </a:prstGeom>
           <a:extLst>
             <a:ext uri="{C572A759-6A51-4108-AA02-DFA0A04FC94B}">
-              <ma14:wrappingTextBoxFlag xmlns="" xmlns:ma14="http://schemas.microsoft.com/office/mac/drawingml/2011/main" val="0"/>
+              <ma14:wrappingTextBoxFlag xmlns:ma14="http://schemas.microsoft.com/office/mac/drawingml/2011/main" xmlns="" val="0"/>
             </a:ext>
           </a:extLst>
         </p:spPr>
@@ -24082,11 +24471,10 @@
           </a:lstStyle>
           <a:p>
             <a:pPr algn="r"/>
-            <a:fld id="{F7021451-1387-4CA6-816F-3879F97B5CBC}" type="slidenum">
-              <a:rPr lang="en-US" b="0"/>
-              <a:t>7</a:t>
-            </a:fld>
-            <a:endParaRPr lang="en-US"/>
+            <a:r>
+              <a:rPr lang="en-US" b="0" dirty="0"/>
+              <a:t>6</a:t>
+            </a:r>
           </a:p>
         </p:txBody>
       </p:sp>
@@ -24238,7 +24626,7 @@
           </a:prstGeom>
           <a:extLst>
             <a:ext uri="{C572A759-6A51-4108-AA02-DFA0A04FC94B}">
-              <ma14:wrappingTextBoxFlag xmlns="" xmlns:ma14="http://schemas.microsoft.com/office/mac/drawingml/2011/main" val="0"/>
+              <ma14:wrappingTextBoxFlag xmlns:ma14="http://schemas.microsoft.com/office/mac/drawingml/2011/main" xmlns="" val="0"/>
             </a:ext>
           </a:extLst>
         </p:spPr>
@@ -24255,11 +24643,10 @@
           </a:lstStyle>
           <a:p>
             <a:pPr algn="r"/>
-            <a:fld id="{F7021451-1387-4CA6-816F-3879F97B5CBC}" type="slidenum">
-              <a:rPr lang="en-US" b="0"/>
-              <a:t>8</a:t>
-            </a:fld>
-            <a:endParaRPr lang="en-US"/>
+            <a:r>
+              <a:rPr lang="en-US" dirty="0"/>
+              <a:t>7</a:t>
+            </a:r>
           </a:p>
         </p:txBody>
       </p:sp>
@@ -24703,7 +25090,7 @@
           </a:prstGeom>
           <a:extLst>
             <a:ext uri="{C572A759-6A51-4108-AA02-DFA0A04FC94B}">
-              <ma14:wrappingTextBoxFlag xmlns:ma14="http://schemas.microsoft.com/office/mac/drawingml/2011/main" xmlns="" val="0"/>
+              <ma14:wrappingTextBoxFlag xmlns="" xmlns:ma14="http://schemas.microsoft.com/office/mac/drawingml/2011/main" val="0"/>
             </a:ext>
           </a:extLst>
         </p:spPr>
@@ -24720,11 +25107,10 @@
           </a:lstStyle>
           <a:p>
             <a:pPr algn="r"/>
-            <a:fld id="{F7021451-1387-4CA6-816F-3879F97B5CBC}" type="slidenum">
-              <a:rPr lang="en-US" b="0"/>
-              <a:t>9</a:t>
-            </a:fld>
-            <a:endParaRPr lang="en-US" dirty="0"/>
+            <a:r>
+              <a:rPr lang="en-US" dirty="0"/>
+              <a:t>8</a:t>
+            </a:r>
           </a:p>
         </p:txBody>
       </p:sp>
@@ -25145,7 +25531,7 @@
         <p:spPr>
           <a:xfrm>
             <a:off x="6732860" y="3952010"/>
-            <a:ext cx="3623300" cy="400110"/>
+            <a:ext cx="3652154" cy="400110"/>
           </a:xfrm>
           <a:prstGeom prst="rect">
             <a:avLst/>
@@ -25166,7 +25552,7 @@
                 <a:latin typeface="Times New Roman" panose="02020603050405020304" pitchFamily="18" charset="0"/>
                 <a:cs typeface="Times New Roman" panose="02020603050405020304" pitchFamily="18" charset="0"/>
               </a:rPr>
-              <a:t>Environnement Logitiel existan</a:t>
+              <a:t>Environnement Logiciel existan</a:t>
             </a:r>
             <a:endParaRPr lang="LID4096" sz="2000" b="1" dirty="0">
               <a:solidFill>

</xml_diff>

<commit_message>
Modification apporter dans le formulaire sinistre du client
</commit_message>
<xml_diff>
--- a/Sources/Conception et developpement d'une application de gestion d'assurance automobile - soutenance.pptx
+++ b/Sources/Conception et developpement d'une application de gestion d'assurance automobile - soutenance.pptx
@@ -8337,35 +8337,72 @@
           <a:lstStyle/>
           <a:p>
             <a:r>
+              <a:rPr lang="" sz="1200" b="1" i="1" u="none" strike="noStrike" kern="1200" dirty="0">
+                <a:solidFill>
+                  <a:schemeClr val="tx1"/>
+                </a:solidFill>
+                <a:effectLst/>
+                <a:latin typeface="+mn-lt"/>
+                <a:ea typeface="+mn-ea"/>
+                <a:cs typeface="+mn-cs"/>
+              </a:rPr>
+              <a:t>Mon étude du terrain a révélé plusieurs problèmes importants qui expliquent mon projet, mais elle montre aussi des points forts essentiels à garder.</a:t>
+            </a:r>
+            <a:r>
+              <a:rPr lang="" sz="1200" b="0" i="1" u="none" strike="noStrike" kern="1200" dirty="0">
+                <a:solidFill>
+                  <a:schemeClr val="tx1"/>
+                </a:solidFill>
+                <a:effectLst/>
+                <a:latin typeface="+mn-lt"/>
+                <a:ea typeface="+mn-ea"/>
+                <a:cs typeface="+mn-cs"/>
+              </a:rPr>
+              <a:t> Même si le travail actuel est lourd à cause des saisies manuelles, des blocages du papier, des pannes de réseau et des envois tardifs au siège, il repose sur des règles très efficaces. </a:t>
+            </a:r>
+            <a:r>
+              <a:rPr lang="" sz="1200" b="1" i="1" u="none" strike="noStrike" kern="1200" dirty="0">
+                <a:solidFill>
+                  <a:schemeClr val="tx1"/>
+                </a:solidFill>
+                <a:effectLst/>
+                <a:latin typeface="+mn-lt"/>
+                <a:ea typeface="+mn-ea"/>
+                <a:cs typeface="+mn-cs"/>
+              </a:rPr>
+              <a:t>Le fonctionnement actuel assure une sécurité financière totale et un suivi précis, grâce à la règle des trois exemplaires et à la double vérification avec la caisse.</a:t>
+            </a:r>
+            <a:r>
               <a:rPr lang="" dirty="0"/>
-              <a:t>Suite à l'analyse menée sur le terrain, j’ai dressé un bilan critique de l'existant. Ce slide résume les dysfonctionnements majeurs qui justifient notre projet, ainsi que les forces à préserver.</a:t>
-            </a:r>
-          </a:p>
-          <a:p>
-            <a:endParaRPr lang="" dirty="0"/>
-          </a:p>
-          <a:p>
+              <a:t> Le but de </a:t>
+            </a:r>
+            <a:r>
+              <a:rPr lang="" sz="1200" b="1" u="none" strike="noStrike" kern="1200" dirty="0">
+                <a:solidFill>
+                  <a:schemeClr val="tx1"/>
+                </a:solidFill>
+                <a:effectLst/>
+                <a:latin typeface="+mn-lt"/>
+                <a:ea typeface="+mn-ea"/>
+                <a:cs typeface="+mn-cs"/>
+              </a:rPr>
+              <a:t>mon</a:t>
+            </a:r>
             <a:r>
               <a:rPr lang="" dirty="0"/>
-              <a:t>D’abord, le traitement des "Affaires nouvelles" est aujourd'hui particulièrement lourd. L'agent doit ressaisir manuellement toutes les informations issues des justificatifs physiques du client, ce qui augmente le risque d'erreur humaine. De plus, le circuit papier crée un véritable goulot d'étranglement. Le contrat imprimé doit circuler physiquement de bureau en bureau pour obtenir la signature manuscrite du Directeur avant que le client ne puisse passer en caisse, générant des temps d'attente inutiles.</a:t>
-            </a:r>
-          </a:p>
-          <a:p>
-            <a:endParaRPr lang="" dirty="0"/>
-          </a:p>
-          <a:p>
-            <a:r>
-              <a:rPr lang="" dirty="0"/>
-              <a:t>Puis, le service souffre d'une dépendance critique à la connexion Internet. En cas de coupure réseau, le progiciel Odoo devient totalement inaccessible. Les agents sont contraints de basculer sur Excel en mode dégradé, ce qui implique une double saisie ultérieure fastidieuse. Enfin, l'envoi des dossiers physiques et la consolidation des données avec le siège ne se font qu'une fois par mois. Si une erreur de saisie est détectée après cet envoi, sa correction impose une procédure de régularisation lourde avec le niveau central. </a:t>
-            </a:r>
-          </a:p>
-          <a:p>
-            <a:endParaRPr lang="" dirty="0"/>
-          </a:p>
-          <a:p>
-            <a:r>
-              <a:rPr lang="" dirty="0"/>
-              <a:t>Cependant, l'informatisation ne doit pas détruire ce qui fonctionne. Le circuit actuel offre une excellente sécurité financière et une traçabilité rigoureuse grâce à la règle des trois exemplaires et à la double vérification avec la caisse. Notre objectif est donc de dématérialiser ce processus pour supprimer les lenteurs, tout en conservant intacts ces mécanismes de contrôle et de traçabilité.</a:t>
+              <a:t> projet n'est pas de tout changer, mais de </a:t>
+            </a:r>
+            <a:r>
+              <a:rPr lang="" sz="1200" b="1" u="none" strike="noStrike" kern="1200" dirty="0">
+                <a:solidFill>
+                  <a:schemeClr val="tx1"/>
+                </a:solidFill>
+                <a:effectLst/>
+                <a:latin typeface="+mn-lt"/>
+                <a:ea typeface="+mn-ea"/>
+                <a:cs typeface="+mn-cs"/>
+              </a:rPr>
+              <a:t>passer au numérique pour supprimer les lenteurs tout en protégeant ces contrôles indispensables.</a:t>
             </a:r>
             <a:endParaRPr lang="en-US" dirty="0"/>
           </a:p>
@@ -8659,19 +8696,6 @@
           <a:lstStyle/>
           <a:p>
             <a:r>
-              <a:rPr lang="" dirty="0"/>
-              <a:t>Au terme de l’étude comparative, la solution d'une application web sur-mesure s'est imposée comme le choix technologique le plus stratégique pour AUXIMAD. Ce slide présente les raisons de ce choix ainsi que notre écosystème technique.</a:t>
-            </a:r>
-          </a:p>
-          <a:p>
-            <a:endParaRPr lang="" dirty="0"/>
-          </a:p>
-          <a:p>
-            <a:r>
-              <a:rPr lang="" dirty="0"/>
-              <a:t>Premièrement, le choix de l'architecture Web se justifie par trois critères opérationnels clés. D'abord, l'</a:t>
-            </a:r>
-            <a:r>
               <a:rPr lang="" sz="1200" b="1" u="none" strike="noStrike" kern="1200" dirty="0">
                 <a:solidFill>
                   <a:schemeClr val="tx1"/>
@@ -8681,11 +8705,11 @@
                 <a:ea typeface="+mn-ea"/>
                 <a:cs typeface="+mn-cs"/>
               </a:rPr>
-              <a:t>accès immédiat</a:t>
+              <a:t>Le choix d'une application web sur-mesure s'impose comme la solution la plus stratégique pour AUXIMAD</a:t>
             </a:r>
             <a:r>
               <a:rPr lang="" dirty="0"/>
-              <a:t>. Les clients assurés n'ont aucun prérequis d'installation ; un simple navigateur internet leur permet de gérer leurs contrats et de déclarer leurs sinistres à distance. Ensuite, cela garantit une </a:t>
+              <a:t>, portée par une architecture web qui répond à trois critères opérationnels majeurs. D'une part, elle offre aux assurés un </a:t>
             </a:r>
             <a:r>
               <a:rPr lang="" sz="1200" b="1" u="none" strike="noStrike" kern="1200" dirty="0">
@@ -8697,11 +8721,11 @@
                 <a:ea typeface="+mn-ea"/>
                 <a:cs typeface="+mn-cs"/>
               </a:rPr>
-              <a:t>maintenance entièrement centralisée</a:t>
+              <a:t>accès immédiat</a:t>
             </a:r>
             <a:r>
               <a:rPr lang="" dirty="0"/>
-              <a:t> au niveau du service informatique d'AUXIMAD. Toute mise à jour appliquée sur le serveur est instantanément disponible pour tous les utilisateurs, éliminant le support technique poste par poste. Enfin, cette interface est </a:t>
+              <a:t> et à distance via un simple navigateur, tout en garantissant au service informatique une </a:t>
             </a:r>
             <a:r>
               <a:rPr lang="" sz="1200" b="1" u="none" strike="noStrike" kern="1200" dirty="0">
@@ -8713,30 +8737,11 @@
                 <a:ea typeface="+mn-ea"/>
                 <a:cs typeface="+mn-cs"/>
               </a:rPr>
-              <a:t>parfaitement adaptée aux exigences du backoffice</a:t>
+              <a:t>maintenance centralisée</a:t>
             </a:r>
             <a:r>
               <a:rPr lang="" dirty="0"/>
-              <a:t> pour les agents, facilitant la manipulation de grands tableaux de données et les saisies volumineuses nécessaires lors de la gestion des flottes d'automobiles.</a:t>
-            </a:r>
-          </a:p>
-          <a:p>
-            <a:endParaRPr lang="" dirty="0"/>
-          </a:p>
-          <a:p>
-            <a:r>
-              <a:rPr lang="" dirty="0"/>
-              <a:t>Deuxièmement, pour concrétiser cette solution, je me suis arrêté sur une pile technologique moderne et robuste.</a:t>
-            </a:r>
-          </a:p>
-          <a:p>
-            <a:pPr marL="171450" indent="-171450">
-              <a:buFont typeface="Arial" panose="020B0604020202020204" pitchFamily="34" charset="0"/>
-              <a:buChar char="•"/>
-            </a:pPr>
-            <a:r>
-              <a:rPr lang="" dirty="0"/>
-              <a:t>Pour la couche de présentation (le Frontend), j’ai utilisé </a:t>
+              <a:t> et instantanée sans intervention poste par poste. D'autre part, son interface est parfaitement calibrée pour les besoins du backoffice, facilitant la saisie de volumes importants de données pour la gestion des flottes d'automobiles. Pour concrétiser cette solution, l'écosystème s'appuie sur une pile technologique moderne et robuste : un frontend sous </a:t>
             </a:r>
             <a:r>
               <a:rPr lang="" sz="1200" b="1" u="none" strike="noStrike" kern="1200" dirty="0">
@@ -8748,21 +8753,11 @@
                 <a:ea typeface="+mn-ea"/>
                 <a:cs typeface="+mn-cs"/>
               </a:rPr>
-              <a:t>Angular couplé à Bootstrap</a:t>
+              <a:t>Angular et Bootstrap</a:t>
             </a:r>
             <a:r>
               <a:rPr lang="" dirty="0"/>
-              <a:t> afin de concevoir une interface réactive et responsive.</a:t>
-            </a:r>
-          </a:p>
-          <a:p>
-            <a:pPr marL="171450" indent="-171450">
-              <a:buFont typeface="Arial" panose="020B0604020202020204" pitchFamily="34" charset="0"/>
-              <a:buChar char="•"/>
-            </a:pPr>
-            <a:r>
-              <a:rPr lang="" dirty="0"/>
-              <a:t>Le cœur logique (le Backend) est propulsé par </a:t>
+              <a:t> pour l'ergonomie, un backend propulsé par </a:t>
             </a:r>
             <a:r>
               <a:rPr lang="" sz="1200" b="1" u="none" strike="noStrike" kern="1200" dirty="0">
@@ -8774,21 +8769,11 @@
                 <a:ea typeface="+mn-ea"/>
                 <a:cs typeface="+mn-cs"/>
               </a:rPr>
-              <a:t>Spring Boot</a:t>
+              <a:t>Spring Boot (API REST)</a:t>
             </a:r>
             <a:r>
               <a:rPr lang="" dirty="0"/>
-              <a:t> configuré en architecture API REST. Ce choix garantit la sécurité des transactions et la robustesse des traitements métiers, notamment pour l'automatisation des calculs de primes.</a:t>
-            </a:r>
-          </a:p>
-          <a:p>
-            <a:pPr marL="171450" indent="-171450">
-              <a:buFont typeface="Arial" panose="020B0604020202020204" pitchFamily="34" charset="0"/>
-              <a:buChar char="•"/>
-            </a:pPr>
-            <a:r>
-              <a:rPr lang="" dirty="0"/>
-              <a:t>La persistance et la sécurité des flux d'informations sont confiées au système de gestion de base de données </a:t>
+              <a:t> pour sécuriser les transactions et automatiser les calculs, ainsi qu'une base de données </a:t>
             </a:r>
             <a:r>
               <a:rPr lang="" sz="1200" b="1" u="none" strike="noStrike" kern="1200" dirty="0">
@@ -8804,17 +8789,7 @@
             </a:r>
             <a:r>
               <a:rPr lang="" dirty="0"/>
-              <a:t>.</a:t>
-            </a:r>
-          </a:p>
-          <a:p>
-            <a:pPr marL="171450" indent="-171450">
-              <a:buFont typeface="Arial" panose="020B0604020202020204" pitchFamily="34" charset="0"/>
-              <a:buChar char="•"/>
-            </a:pPr>
-            <a:r>
-              <a:rPr lang="" dirty="0"/>
-              <a:t>Enfin, toute cette implémentation s'appuie sur une phase rigoureuse de modélisation et de </a:t>
+              <a:t>. L'ensemble de cette implémentation a été sécurisé en amont par une phase rigoureuse de </a:t>
             </a:r>
             <a:r>
               <a:rPr lang="" sz="1200" b="1" u="none" strike="noStrike" kern="1200" dirty="0">
@@ -8826,11 +8801,11 @@
                 <a:ea typeface="+mn-ea"/>
                 <a:cs typeface="+mn-cs"/>
               </a:rPr>
-              <a:t>conception UML</a:t>
+              <a:t>modélisation UML</a:t>
             </a:r>
             <a:r>
               <a:rPr lang="" dirty="0"/>
-              <a:t> pour figer proprement la structure et la dynamique du système avant le codage. </a:t>
+              <a:t>.</a:t>
             </a:r>
             <a:endParaRPr lang="en-US" dirty="0"/>
           </a:p>
@@ -8940,69 +8915,33 @@
           <a:p>
             <a:pPr rtl="0"/>
             <a:r>
+              <a:rPr lang="" sz="1200" b="1" u="none" strike="noStrike" kern="1200" dirty="0">
+                <a:solidFill>
+                  <a:schemeClr val="tx1"/>
+                </a:solidFill>
+                <a:effectLst/>
+                <a:latin typeface="+mn-lt"/>
+                <a:ea typeface="+mn-ea"/>
+                <a:cs typeface="+mn-cs"/>
+              </a:rPr>
+              <a:t>Ce diagramme de Gantt présente le déroulement de mon projet sur 9 semaines, du 13 août au 13 octobre 2026, structuré en quatre grandes phases.</a:t>
+            </a:r>
+            <a:r>
               <a:rPr lang="" dirty="0"/>
-              <a:t>Ce diagramme de Gantt présente le déroulement de mon projet sur 9 semaines, du 13 août au 13 octobre 2026. Il suit les grandes étapes de mon mémoire.</a:t>
-            </a:r>
-          </a:p>
-          <a:p>
-            <a:pPr rtl="0"/>
-            <a:endParaRPr lang="" dirty="0"/>
-          </a:p>
-          <a:p>
-            <a:pPr rtl="0"/>
-            <a:r>
-              <a:rPr lang="" dirty="0"/>
-              <a:t>Le projet a commencé par l’analyse préalable : la découverte de la société et de l’existant, puis l’étude préalable avec le diagnostic, le dossier des choix et le choix de la solution, et enfin le cahier des charges de la solution retenue. Ces trois tâches se chevauchent légèrement, ce qui m’a permis d’avancer sans attendre la fin de chacune.</a:t>
-            </a:r>
-          </a:p>
-          <a:p>
-            <a:pPr rtl="0"/>
-            <a:endParaRPr lang="" dirty="0"/>
-          </a:p>
-          <a:p>
-            <a:pPr rtl="0"/>
-            <a:r>
-              <a:rPr lang="" dirty="0"/>
-              <a:t>Vient ensuite la conception UML, avec les diagrammes de cas d’utilisation, de séquence, d’activité et de classes. Le développement du backend a démarré en parallèle, dès que les bases de la conception étaient posées.</a:t>
-            </a:r>
-          </a:p>
-          <a:p>
-            <a:pPr rtl="0"/>
-            <a:r>
-              <a:rPr lang="" dirty="0"/>
-              <a:t>La phase de réalisation a été la plus longue du projet. Le backend s’est étendu jusqu’à début octobre, et le frontend a démarré à mi-parcours avant de se terminer autour du 9 octobre. Le développement m’a pris plus de temps que prévu, ce qui a un peu réduit la marge pour la suite.</a:t>
-            </a:r>
-          </a:p>
-          <a:p>
-            <a:pPr rtl="0"/>
-            <a:endParaRPr lang="" dirty="0"/>
-          </a:p>
-          <a:p>
-            <a:pPr rtl="0"/>
-            <a:r>
-              <a:rPr lang="" dirty="0"/>
-              <a:t>Les tests et corrections se sont donc déroulés en fin de projet, en même temps que le manuel utilisateur.</a:t>
-            </a:r>
-          </a:p>
-          <a:p>
-            <a:pPr rtl="0"/>
-            <a:r>
-              <a:rPr lang="" dirty="0"/>
-              <a:t>Enfin, la rédaction du mémoire s’étend sur presque toute la durée du projet. Je l’ai écrite au fil de l’avancement, et la relecture et la finalisation occupent le dernier jour.</a:t>
-            </a:r>
-          </a:p>
-          <a:p>
-            <a:pPr rtl="0"/>
-            <a:endParaRPr lang="" dirty="0"/>
-          </a:p>
-          <a:p>
-            <a:pPr rtl="0"/>
-            <a:r>
-              <a:rPr lang="" dirty="0"/>
-              <a:t>En résumé, le projet est organisé en quatre grandes phases : analyse, conception, réalisation et rédaction, avec un développement qui a été le gros du travail.</a:t>
-            </a:r>
-          </a:p>
-          <a:p>
+              <a:t> Tout a commencé par l'analyse de l'entreprise et de l'existant pour rédiger le cahier des charges. J'ai enchaîné avec la conception UML, puis le développement du backend et du frontend. Cette réalisation a été la partie la plus longue et m'a pris plus de temps que prévu, ce qui a réduit le délai pour les tests et le guide utilisateur en fin de parcours. Enfin, j'ai écrit mon mémoire au fil de l'eau sur toute la durée du projet, en réservant le dernier jour pour la relecture finale. </a:t>
+            </a:r>
+            <a:r>
+              <a:rPr lang="" sz="1200" b="1" u="none" strike="noStrike" kern="1200" dirty="0">
+                <a:solidFill>
+                  <a:schemeClr val="tx1"/>
+                </a:solidFill>
+                <a:effectLst/>
+                <a:latin typeface="+mn-lt"/>
+                <a:ea typeface="+mn-ea"/>
+                <a:cs typeface="+mn-cs"/>
+              </a:rPr>
+              <a:t>En résumé, malgré un développement gourmand en temps, j'ai réussi à mener de front l'analyse, la conception, la réalisation et la rédaction.</a:t>
+            </a:r>
             <a:endParaRPr lang="LID4096" dirty="0"/>
           </a:p>
         </p:txBody>
@@ -9843,10 +9782,6 @@
           <a:p>
             <a:pPr rtl="0"/>
             <a:r>
-              <a:rPr lang="" dirty="0"/>
-              <a:t>La numérisation des services est devenue un levier incontournable pour moderniser l'organisation des entreprises. Au sein d'AUXIMAD, à travers son service dédié </a:t>
-            </a:r>
-            <a:r>
               <a:rPr lang="" sz="1200" b="1" u="none" strike="noStrike" kern="1200" dirty="0">
                 <a:solidFill>
                   <a:schemeClr val="tx1"/>
@@ -9856,85 +9791,11 @@
                 <a:ea typeface="+mn-ea"/>
                 <a:cs typeface="+mn-cs"/>
               </a:rPr>
-              <a:t>AUXIASSUR, </a:t>
+              <a:t>Aujourd'hui, la numérisation est indispensable pour moderniser les entreprises, particulièrement pour la branche automobile d'AUXIASSUR qui gère la souscription, la facturation et les sinistres.</a:t>
             </a:r>
             <a:r>
               <a:rPr lang="" dirty="0"/>
-              <a:t>l'assurance automobile représente une activité hautement stratégique couvrant la souscription, le suivi des renouvellements, la facturation et l'instruction des sinistres.</a:t>
-            </a:r>
-          </a:p>
-          <a:p>
-            <a:pPr rtl="0"/>
-            <a:endParaRPr lang="" dirty="0"/>
-          </a:p>
-          <a:p>
-            <a:pPr rtl="0"/>
-            <a:r>
-              <a:rPr lang="" dirty="0"/>
-              <a:t>J’ai constaté que la gestion de ces opérations reposait encore en grande partie sur des supports physiques, des saisies manuelles et une combinaison fragmentée d’outils hétérogènes comme le progiciel </a:t>
-            </a:r>
-            <a:r>
-              <a:rPr lang="" sz="1200" b="1" u="none" strike="noStrike" kern="1200" dirty="0">
-                <a:solidFill>
-                  <a:schemeClr val="tx1"/>
-                </a:solidFill>
-                <a:effectLst/>
-                <a:latin typeface="+mn-lt"/>
-                <a:ea typeface="+mn-ea"/>
-                <a:cs typeface="+mn-cs"/>
-              </a:rPr>
-              <a:t>Odoo</a:t>
-            </a:r>
-            <a:r>
-              <a:rPr lang="" dirty="0"/>
-              <a:t> et des tableurs </a:t>
-            </a:r>
-            <a:r>
-              <a:rPr lang="" sz="1200" b="1" u="none" strike="noStrike" kern="1200" dirty="0">
-                <a:solidFill>
-                  <a:schemeClr val="tx1"/>
-                </a:solidFill>
-                <a:effectLst/>
-                <a:latin typeface="+mn-lt"/>
-                <a:ea typeface="+mn-ea"/>
-                <a:cs typeface="+mn-cs"/>
-              </a:rPr>
-              <a:t>Microsoft Excel</a:t>
-            </a:r>
-            <a:r>
-              <a:rPr lang="" dirty="0"/>
-              <a:t> utilisés en mode de secours. Ce fonctionnement induit une lourdeur administrative, une latence dans l'instruction des dossiers, un risque élevé d'erreurs de saisie.</a:t>
-            </a:r>
-          </a:p>
-          <a:p>
-            <a:pPr rtl="0"/>
-            <a:endParaRPr lang="" sz="1200" b="0" i="1" u="none" strike="noStrike" kern="1200" dirty="0">
-              <a:solidFill>
-                <a:schemeClr val="tx1"/>
-              </a:solidFill>
-              <a:effectLst/>
-              <a:latin typeface="+mn-lt"/>
-              <a:ea typeface="+mn-ea"/>
-              <a:cs typeface="+mn-cs"/>
-            </a:endParaRPr>
-          </a:p>
-          <a:p>
-            <a:pPr rtl="0"/>
-            <a:r>
-              <a:rPr lang="" sz="1200" b="0" i="1" u="none" strike="noStrike" kern="1200" dirty="0">
-                <a:solidFill>
-                  <a:schemeClr val="tx1"/>
-                </a:solidFill>
-                <a:effectLst/>
-                <a:latin typeface="+mn-lt"/>
-                <a:ea typeface="+mn-ea"/>
-                <a:cs typeface="+mn-cs"/>
-              </a:rPr>
-              <a:t>D'où notre question centrale :</a:t>
-            </a:r>
-            <a:r>
-              <a:rPr lang="" dirty="0"/>
-              <a:t> Comment optimiser et sécuriser l'ensemble du cycle de vie des contrats d'assurance automobile tout en offrant un outil centralisé en interne et un accès dématérialisé pour les assurés ?</a:t>
+              <a:t> Lors de mon analyse sur le terrain, j'ai constaté que ce service s'appuie encore sur des documents papier, des saisies manuelles et des outils séparés comme le logiciel Odoo et des fichiers Excel de secours. Ce fonctionnement crée de la lourdeur administrative, des retards et des risques d'erreurs. C'est ce constat qui m'a conduit à ma question centrale : comment optimiser et sécuriser tout le cycle de vie de ces contrats d'assurance, à travers un outil interne unique et un accès en ligne pour les clients ?</a:t>
             </a:r>
           </a:p>
         </p:txBody>
@@ -10122,10 +9983,8 @@
             </a:pPr>
             <a:r>
               <a:rPr lang="" dirty="0"/>
-              <a:t>Nous entamons à présent la troisième et dernière partie de notre exposé, entièrement consacrée à la Réalisation technique de l’application. Pour illustrer concrètement le fonctionnement d'AUXIASSUR, je vous propose de suivre un scénario de démonstration complet, qui simule le cycle de vie d'un assuré et d'un contrat.</a:t>
-            </a:r>
-          </a:p>
-          <a:p>
+              <a:t>Nous entamons à présent la troisième et dernière partie de notre exposé, entièrement consacrée à la Réalisation technique de l’application. </a:t>
+            </a:r>
             <a:endParaRPr lang="en-US" dirty="0"/>
           </a:p>
         </p:txBody>
@@ -10332,7 +10191,7 @@
                 <a:ea typeface="+mn-ea"/>
                 <a:cs typeface="+mn-cs"/>
               </a:rPr>
-              <a:t>AUXIASSUR</a:t>
+              <a:t>AUXIDRIVE</a:t>
             </a:r>
             <a:r>
               <a:rPr lang="" dirty="0"/>
@@ -10516,7 +10375,7 @@
           <a:p>
             <a:r>
               <a:rPr lang="" dirty="0"/>
-              <a:t>Comme tout projet logiciel, cette plateforme reste évolutive. Parmi les perspectives à court terme, Je prévois de finaliser la gestion fine du mode déconnecté pour garantir une continuité parfaite du service en cas de panne réseau. Je dois également valider auprès de la direction de production les formules exactes liées aux codes de taxes spécifiques de l'assurance automobile. À plus long terme, l'intégration d'un module de paiement en ligne via les solutions locales de Mobile Money constituera un atout stratégique majeur.</a:t>
+              <a:t>Comme tout projet logiciel, cette plateforme reste évolutive. Parmi les perspectives à court terme, Je prévois de finaliser la gestion fine du mode déconnecté pour garantir une continuité parfaite du service en cas de panne réseau et l'intégration d'un module de paiement en ligne via les solutions locales de Mobile Money constituera un atout stratégique majeur.</a:t>
             </a:r>
           </a:p>
           <a:p>
@@ -10926,7 +10785,7 @@
                 <a:ea typeface="+mn-ea"/>
                 <a:cs typeface="+mn-cs"/>
               </a:rPr>
-              <a:t>, qui détaillera l'environnement technique ainsi que les modules applicatifs, avant de clore par une démonstration en direct.</a:t>
+              <a:t>, qui sera une démonstration en direct du projet.</a:t>
             </a:r>
           </a:p>
         </p:txBody>
@@ -11161,7 +11020,7 @@
                 <a:ea typeface="+mn-ea"/>
                 <a:cs typeface="+mn-cs"/>
               </a:rPr>
-              <a:t>, qui détaillera l'environnement technique ainsi que les modules applicatifs, avant de clore par une démonstration en direct.</a:t>
+              <a:t>, qui sera une démonstration en direct du projet.</a:t>
             </a:r>
           </a:p>
         </p:txBody>
@@ -11337,11 +11196,7 @@
           <a:lstStyle/>
           <a:p>
             <a:r>
-              <a:rPr lang="" dirty="0"/>
-              <a:t>Pour situer le cadre opérationnel de ce projet, il faut savoir qu'AUXIMAD est une institution historique à Madagascar. Fondée en 1902 sous le nom de </a:t>
-            </a:r>
-            <a:r>
-              <a:rPr lang="" sz="1200" b="0" i="1" u="none" strike="noStrike" kern="1200" dirty="0">
+              <a:rPr lang="" sz="1200" b="1" u="none" strike="noStrike" kern="1200" dirty="0">
                 <a:solidFill>
                   <a:schemeClr val="tx1"/>
                 </a:solidFill>
@@ -11350,28 +11205,11 @@
                 <a:ea typeface="+mn-ea"/>
                 <a:cs typeface="+mn-cs"/>
               </a:rPr>
-              <a:t>Wharf de Tamatave</a:t>
+              <a:t>Pour situer le cadre de mon projet, il faut savoir qu'AUXIMAD est une entreprise historique.</a:t>
             </a:r>
             <a:r>
               <a:rPr lang="" dirty="0"/>
-              <a:t>, elle a fêté ses 120 ans d'existence. C’est une Société Anonyme au capital de 222 millions d'Ariary.</a:t>
-            </a:r>
-          </a:p>
-          <a:p>
-            <a:endParaRPr lang="" sz="1200" b="0" u="none" strike="noStrike" kern="1200" dirty="0">
-              <a:solidFill>
-                <a:schemeClr val="tx1"/>
-              </a:solidFill>
-              <a:effectLst/>
-              <a:latin typeface="+mn-lt"/>
-              <a:ea typeface="+mn-ea"/>
-              <a:cs typeface="+mn-cs"/>
-            </a:endParaRPr>
-          </a:p>
-          <a:p>
-            <a:r>
-              <a:rPr lang="" dirty="0"/>
-              <a:t>Reconnue historiquement comme un acteur incontournable de la logistique, du transit et de la consignation maritime, AUXIMAD a su diversifier ses activités au fil du temps. Elle dispose notamment d'un département dédié aux assurances nommé </a:t>
+              <a:t> Fondée en 1902 avec le Wharf de Tamatave, elle prend officiellement le nom de Société Auxiliaire Maritime de Madagascar en 1952. C'est un acteur majeur de la logistique qui propose des services de consignation, transit, dédouanement, manutention, transport, entreposage et groupage. Pour diversifier ses activités, l'entreprise a créé le service </a:t>
             </a:r>
             <a:r>
               <a:rPr lang="" sz="1200" b="1" u="none" strike="noStrike" kern="1200" dirty="0">
@@ -11387,7 +11225,7 @@
             </a:r>
             <a:r>
               <a:rPr lang="" dirty="0"/>
-              <a:t>. Dans ce cadre, l'entreprise n’est pas assureur direct, mais elle opère en tant qu’</a:t>
+              <a:t>. Elle y opère comme Agent Général d'ARO, la compagnie leader à Madagascar qui détient </a:t>
             </a:r>
             <a:r>
               <a:rPr lang="" sz="1200" b="1" u="none" strike="noStrike" kern="1200" dirty="0">
@@ -11399,11 +11237,27 @@
                 <a:ea typeface="+mn-ea"/>
                 <a:cs typeface="+mn-cs"/>
               </a:rPr>
-              <a:t>Agent Général de la compagnie ARO</a:t>
+              <a:t>61,2 % de part de marché</a:t>
             </a:r>
             <a:r>
               <a:rPr lang="" dirty="0"/>
-              <a:t>, le leader historique de l'assurance à Madagascar. C'est précisément pour moderniser la gestion de cette branche automobile d'AUXIASSUR que mon projet a été initié. </a:t>
+              <a:t>. C’est précisément pour moderniser la branche automobile de ce service qu'a été lancé </a:t>
+            </a:r>
+            <a:r>
+              <a:rPr lang="" sz="1200" b="1" u="none" strike="noStrike" kern="1200" dirty="0">
+                <a:solidFill>
+                  <a:schemeClr val="tx1"/>
+                </a:solidFill>
+                <a:effectLst/>
+                <a:latin typeface="+mn-lt"/>
+                <a:ea typeface="+mn-ea"/>
+                <a:cs typeface="+mn-cs"/>
+              </a:rPr>
+              <a:t>mon</a:t>
+            </a:r>
+            <a:r>
+              <a:rPr lang="" dirty="0"/>
+              <a:t> projet.</a:t>
             </a:r>
             <a:endParaRPr lang="" sz="1200" b="0" u="none" strike="noStrike" kern="1200" dirty="0">
               <a:solidFill>
@@ -11617,17 +11471,20 @@
           <a:lstStyle/>
           <a:p>
             <a:r>
+              <a:rPr lang="" sz="1200" b="1" u="none" strike="noStrike" kern="1200" dirty="0">
+                <a:solidFill>
+                  <a:schemeClr val="tx1"/>
+                </a:solidFill>
+                <a:effectLst/>
+                <a:latin typeface="+mn-lt"/>
+                <a:ea typeface="+mn-ea"/>
+                <a:cs typeface="+mn-cs"/>
+              </a:rPr>
+              <a:t>L'objectif général de mon projet est de concevoir une plateforme unique pour gérer tout le cycle de vie des contrats d'assurance automobile.</a:t>
+            </a:r>
+            <a:r>
               <a:rPr lang="" dirty="0"/>
-              <a:t>Comme vous pouvez le voir sur ce slide, l’objectif général est de concevoir et déployer une plateforme unique capable de piloter l'intégralité du cycle de vie des contrats d'assurance automobile. De manière spécifique, j’ai cibler la centralisation des données pour mettre fin à la dispersion actuelle. J’ai viser également l'automatisation complète des calculs métiers complexes : le système doit calculer instantanément les primes nettes et globales selon les profils, gérer l'application automatique des remises de flottes à partir de 5 véhicules, et mettre à jour le coefficient de bonus-malus dès la clôture d'un sinistre. Enfin, il s'agit d'intégrer un volet décisionnel pour fournir un tableau de bord statistique complet à la direction.</a:t>
-            </a:r>
-          </a:p>
-          <a:p>
-            <a:endParaRPr lang="" dirty="0"/>
-          </a:p>
-          <a:p>
-            <a:r>
-              <a:rPr lang="" dirty="0"/>
-              <a:t>Face à ces objectifs, les résultats concrets attendus à l'issue de ce projet sont majeurs pour AUXIMAD. Sur le plan opérationnel, l'application élimine la double saisie papier et le recours aux tableurs Excel de secours. Les assurés bénéficient désormais d'une autonomie totale via un portail web dédié pour soumettre numériquement leurs pièces obligatoires comme la carte grise ou la CIN. Du côté des agents internes, le résultat se traduit par une fluidification nette du workflow : la facturation TTC est instantanément générée et téléchargeable au format PDF, et le suivi des sinistres passe par un circuit numérique transparent, du signalement jusqu’à la clôture du dossier.</a:t>
+              <a:t> Plus précisément, j'ai cherché à centraliser toutes les données et à automatiser entièrement les calculs complexes, comme les tarifs selon les profils, les remises pour les flottes de plus de 5 véhicules et la mise à jour du bonus-malus. J'ai aussi intégré un tableau de bord statistique pour aider la direction à prendre des décisions. Grâce à cette application, les résultats concrets sont majeurs pour AUXIMAD : elle supprime la double saisie papier et les fichiers Excel de secours. Les assurés gagnent en autonomie en envoyant leurs justificatifs directement sur un portail web, tandis que les agents profitent d'un travail plus fluide, avec des factures PDF générées instantanément et un suivi numérique transparent des sinistres.</a:t>
             </a:r>
             <a:endParaRPr lang="en-US" dirty="0"/>
           </a:p>
@@ -11751,7 +11608,7 @@
           <a:p>
             <a:r>
               <a:rPr lang="" dirty="0"/>
-              <a:t>Sur le plan informatique, les agents s'appuient principalement sur le progiciel Odoo pour enregistrer les fiches des assurés. Cependant, l'analyse montre que le service utilise couramment Microsoft Excel comme outil complémentaire ou solution de secours appelée "mode dégradé" pour pallier manuellement les lenteurs ou les ruptures régulières de la connexion internet.</a:t>
+              <a:t>Sur le plan informatique, les agents s'appuient principalement sur le logiciel Odoo pour enregistrer les fiches des assurés. Cependant, l'analyse montre que le service utilise couramment Microsoft Excel comme outil complémentaire ou solution de secours appelée "mode dégradé" pour pallier manuellement les lenteurs ou les ruptures régulières de la connexion internet.</a:t>
             </a:r>
             <a:endParaRPr lang="en-US" dirty="0"/>
           </a:p>
@@ -12363,7 +12220,7 @@
           <a:p>
             <a:fld id="{CA02FB80-71B9-47BF-852E-5AF5189041F3}" type="datetimeFigureOut">
               <a:rPr lang="LID4096" smtClean="0"/>
-              <a:t>10/11/2026</a:t>
+              <a:t>10/13/2026</a:t>
             </a:fld>
             <a:endParaRPr lang="LID4096"/>
           </a:p>
@@ -19847,7 +19704,7 @@
         <p:spPr>
           <a:xfrm>
             <a:off x="548640" y="182880"/>
-            <a:ext cx="11064240" cy="1097280"/>
+            <a:ext cx="11064240" cy="356616"/>
           </a:xfrm>
           <a:prstGeom prst="rect">
             <a:avLst/>
@@ -19941,8 +19798,8 @@
         </p:blipFill>
         <p:spPr>
           <a:xfrm>
-            <a:off x="661772" y="962526"/>
-            <a:ext cx="10951108" cy="5438274"/>
+            <a:off x="661772" y="539496"/>
+            <a:ext cx="10951108" cy="5861304"/>
           </a:xfrm>
           <a:prstGeom prst="rect">
             <a:avLst/>
@@ -21491,7 +21348,7 @@
         <p:spPr>
           <a:xfrm>
             <a:off x="5053010" y="2975232"/>
-            <a:ext cx="2085975" cy="1938992"/>
+            <a:ext cx="2085975" cy="1323439"/>
           </a:xfrm>
           <a:prstGeom prst="rect">
             <a:avLst/>
@@ -21511,16 +21368,6 @@
             <a:r>
               <a:rPr lang="" sz="2000" dirty="0"/>
               <a:t>Mode Déconnecté</a:t>
-            </a:r>
-          </a:p>
-          <a:p>
-            <a:pPr marL="342900" indent="-342900">
-              <a:buFont typeface="Arial" panose="020B0604020202020204" pitchFamily="34" charset="0"/>
-              <a:buChar char="•"/>
-            </a:pPr>
-            <a:r>
-              <a:rPr lang="" sz="2000" dirty="0"/>
-              <a:t>Calcul des Taxes</a:t>
             </a:r>
           </a:p>
           <a:p>
@@ -21817,7 +21664,7 @@
           <a:bodyPr wrap="square" lIns="0" tIns="0" rIns="0" bIns="0" rtlCol="0" anchor="ctr"/>
           <a:lstStyle/>
           <a:p>
-            <a:pPr marL="0" indent="0" algn="l">
+            <a:pPr marL="0" indent="0" algn="ctr">
               <a:buNone/>
             </a:pPr>
             <a:r>
@@ -21879,7 +21726,7 @@
           <a:bodyPr wrap="square" lIns="0" tIns="0" rIns="0" bIns="0" rtlCol="0" anchor="t"/>
           <a:lstStyle/>
           <a:p>
-            <a:pPr marL="0" indent="0" algn="l">
+            <a:pPr marL="0" indent="0" algn="ctr">
               <a:buNone/>
             </a:pPr>
             <a:r>

</xml_diff>

<commit_message>
Rajout et modification des fichiers dans le dossier /Sourvces
</commit_message>
<xml_diff>
--- a/Sources/Conception et developpement d'une application de gestion d'assurance automobile - soutenance.pptx
+++ b/Sources/Conception et developpement d'une application de gestion d'assurance automobile - soutenance.pptx
@@ -8093,9 +8093,9 @@
                   <a:schemeClr val="tx1"/>
                 </a:solidFill>
                 <a:effectLst/>
-                <a:latin typeface="+mn-lt"/>
+                <a:latin typeface="Times New Roman" panose="02020603050405020304" pitchFamily="18" charset="0"/>
                 <a:ea typeface="+mn-ea"/>
-                <a:cs typeface="+mn-cs"/>
+                <a:cs typeface="Times New Roman" panose="02020603050405020304" pitchFamily="18" charset="0"/>
               </a:rPr>
               <a:t>Madame la Présidente du Jury,</a:t>
             </a:r>
@@ -8107,9 +8107,9 @@
                   <a:schemeClr val="tx1"/>
                 </a:solidFill>
                 <a:effectLst/>
-                <a:latin typeface="+mn-lt"/>
+                <a:latin typeface="Times New Roman" panose="02020603050405020304" pitchFamily="18" charset="0"/>
                 <a:ea typeface="+mn-ea"/>
-                <a:cs typeface="+mn-cs"/>
+                <a:cs typeface="Times New Roman" panose="02020603050405020304" pitchFamily="18" charset="0"/>
               </a:rPr>
             </a:br>
             <a:r>
@@ -8118,9 +8118,9 @@
                   <a:schemeClr val="tx1"/>
                 </a:solidFill>
                 <a:effectLst/>
-                <a:latin typeface="+mn-lt"/>
+                <a:latin typeface="Times New Roman" panose="02020603050405020304" pitchFamily="18" charset="0"/>
                 <a:ea typeface="+mn-ea"/>
-                <a:cs typeface="+mn-cs"/>
+                <a:cs typeface="Times New Roman" panose="02020603050405020304" pitchFamily="18" charset="0"/>
               </a:rPr>
               <a:t>Mesdames et messieurs les membres du jury,</a:t>
             </a:r>
@@ -8132,9 +8132,9 @@
                   <a:schemeClr val="tx1"/>
                 </a:solidFill>
                 <a:effectLst/>
-                <a:latin typeface="+mn-lt"/>
+                <a:latin typeface="Times New Roman" panose="02020603050405020304" pitchFamily="18" charset="0"/>
                 <a:ea typeface="+mn-ea"/>
-                <a:cs typeface="+mn-cs"/>
+                <a:cs typeface="Times New Roman" panose="02020603050405020304" pitchFamily="18" charset="0"/>
               </a:rPr>
             </a:br>
             <a:r>
@@ -8143,9 +8143,9 @@
                   <a:schemeClr val="tx1"/>
                 </a:solidFill>
                 <a:effectLst/>
-                <a:latin typeface="+mn-lt"/>
+                <a:latin typeface="Times New Roman" panose="02020603050405020304" pitchFamily="18" charset="0"/>
                 <a:ea typeface="+mn-ea"/>
-                <a:cs typeface="+mn-cs"/>
+                <a:cs typeface="Times New Roman" panose="02020603050405020304" pitchFamily="18" charset="0"/>
               </a:rPr>
               <a:t>Honorables assistances,</a:t>
             </a:r>
@@ -8156,9 +8156,9 @@
                 <a:schemeClr val="tx1"/>
               </a:solidFill>
               <a:effectLst/>
-              <a:latin typeface="+mn-lt"/>
+              <a:latin typeface="Times New Roman" panose="02020603050405020304" pitchFamily="18" charset="0"/>
               <a:ea typeface="+mn-ea"/>
-              <a:cs typeface="+mn-cs"/>
+              <a:cs typeface="Times New Roman" panose="02020603050405020304" pitchFamily="18" charset="0"/>
             </a:endParaRPr>
           </a:p>
           <a:p>
@@ -8168,9 +8168,9 @@
                   <a:schemeClr val="tx1"/>
                 </a:solidFill>
                 <a:effectLst/>
-                <a:latin typeface="+mn-lt"/>
+                <a:latin typeface="Times New Roman" panose="02020603050405020304" pitchFamily="18" charset="0"/>
                 <a:ea typeface="+mn-ea"/>
-                <a:cs typeface="+mn-cs"/>
+                <a:cs typeface="Times New Roman" panose="02020603050405020304" pitchFamily="18" charset="0"/>
               </a:rPr>
               <a:t>J’ai l’honneur de vous présenter aujourd’hui le projet que j’ai réalisé dans le cadre de l’obtention de mon diplôme de Licence en </a:t>
             </a:r>
@@ -8180,9 +8180,9 @@
                   <a:schemeClr val="tx1"/>
                 </a:solidFill>
                 <a:effectLst/>
-                <a:latin typeface="+mn-lt"/>
+                <a:latin typeface="Times New Roman" panose="02020603050405020304" pitchFamily="18" charset="0"/>
                 <a:ea typeface="+mn-ea"/>
-                <a:cs typeface="+mn-cs"/>
+                <a:cs typeface="Times New Roman" panose="02020603050405020304" pitchFamily="18" charset="0"/>
               </a:rPr>
               <a:t>Génie Logiciel</a:t>
             </a:r>
@@ -8192,9 +8192,9 @@
                   <a:schemeClr val="tx1"/>
                 </a:solidFill>
                 <a:effectLst/>
-                <a:latin typeface="+mn-lt"/>
+                <a:latin typeface="Times New Roman" panose="02020603050405020304" pitchFamily="18" charset="0"/>
                 <a:ea typeface="+mn-ea"/>
-                <a:cs typeface="+mn-cs"/>
+                <a:cs typeface="Times New Roman" panose="02020603050405020304" pitchFamily="18" charset="0"/>
               </a:rPr>
               <a:t> à l’Établissement Supérieur Professionnel BIG (</a:t>
             </a:r>
@@ -8204,9 +8204,9 @@
                   <a:schemeClr val="tx1"/>
                 </a:solidFill>
                 <a:effectLst/>
-                <a:latin typeface="+mn-lt"/>
+                <a:latin typeface="Times New Roman" panose="02020603050405020304" pitchFamily="18" charset="0"/>
                 <a:ea typeface="+mn-ea"/>
-                <a:cs typeface="+mn-cs"/>
+                <a:cs typeface="Times New Roman" panose="02020603050405020304" pitchFamily="18" charset="0"/>
               </a:rPr>
               <a:t>ESP-BIG</a:t>
             </a:r>
@@ -8216,9 +8216,9 @@
                   <a:schemeClr val="tx1"/>
                 </a:solidFill>
                 <a:effectLst/>
-                <a:latin typeface="+mn-lt"/>
+                <a:latin typeface="Times New Roman" panose="02020603050405020304" pitchFamily="18" charset="0"/>
                 <a:ea typeface="+mn-ea"/>
-                <a:cs typeface="+mn-cs"/>
+                <a:cs typeface="Times New Roman" panose="02020603050405020304" pitchFamily="18" charset="0"/>
               </a:rPr>
               <a:t>). Ce travail marque l'aboutissement d'un stage de trois mois que j’ai effectué au sein de la société </a:t>
             </a:r>
@@ -8228,9 +8228,9 @@
                   <a:schemeClr val="tx1"/>
                 </a:solidFill>
                 <a:effectLst/>
-                <a:latin typeface="+mn-lt"/>
+                <a:latin typeface="Times New Roman" panose="02020603050405020304" pitchFamily="18" charset="0"/>
                 <a:ea typeface="+mn-ea"/>
-                <a:cs typeface="+mn-cs"/>
+                <a:cs typeface="Times New Roman" panose="02020603050405020304" pitchFamily="18" charset="0"/>
               </a:rPr>
               <a:t>AUXIMAD</a:t>
             </a:r>
@@ -8240,9 +8240,9 @@
                   <a:schemeClr val="tx1"/>
                 </a:solidFill>
                 <a:effectLst/>
-                <a:latin typeface="+mn-lt"/>
+                <a:latin typeface="Times New Roman" panose="02020603050405020304" pitchFamily="18" charset="0"/>
                 <a:ea typeface="+mn-ea"/>
-                <a:cs typeface="+mn-cs"/>
+                <a:cs typeface="Times New Roman" panose="02020603050405020304" pitchFamily="18" charset="0"/>
               </a:rPr>
               <a:t>. Le thème de mon mémoire porte sur la : </a:t>
             </a:r>
@@ -8252,9 +8252,9 @@
                   <a:schemeClr val="tx1"/>
                 </a:solidFill>
                 <a:effectLst/>
-                <a:latin typeface="+mn-lt"/>
+                <a:latin typeface="Times New Roman" panose="02020603050405020304" pitchFamily="18" charset="0"/>
                 <a:ea typeface="+mn-ea"/>
-                <a:cs typeface="+mn-cs"/>
+                <a:cs typeface="Times New Roman" panose="02020603050405020304" pitchFamily="18" charset="0"/>
               </a:rPr>
               <a:t>« CONCEPTION ET DEVELOPPEMENT D’UNE APPLICATION DE GESTION D’ASSURANCE AUTOMOBILE »</a:t>
             </a:r>
@@ -8264,9 +8264,9 @@
                   <a:schemeClr val="tx1"/>
                 </a:solidFill>
                 <a:effectLst/>
-                <a:latin typeface="+mn-lt"/>
+                <a:latin typeface="Times New Roman" panose="02020603050405020304" pitchFamily="18" charset="0"/>
                 <a:ea typeface="+mn-ea"/>
-                <a:cs typeface="+mn-cs"/>
+                <a:cs typeface="Times New Roman" panose="02020603050405020304" pitchFamily="18" charset="0"/>
               </a:rPr>
               <a:t>.</a:t>
             </a:r>
@@ -8331,129 +8331,69 @@
           <a:lstStyle/>
           <a:p>
             <a:r>
-              <a:rPr lang="" sz="1200" b="1" u="none" strike="noStrike" kern="1200" dirty="0">
-                <a:solidFill>
-                  <a:schemeClr val="tx1"/>
-                </a:solidFill>
-                <a:effectLst/>
-                <a:latin typeface="+mn-lt"/>
-                <a:ea typeface="+mn-ea"/>
-                <a:cs typeface="+mn-cs"/>
-              </a:rPr>
-              <a:t>J'ai synthétisé ici une comparaison entre les deux solutions envisagées</a:t>
-            </a:r>
-            <a:r>
               <a:rPr lang="" dirty="0"/>
-              <a:t> pour guider notre prise de décision.</a:t>
-            </a:r>
-          </a:p>
-          <a:p>
-            <a:endParaRPr lang="" dirty="0"/>
-          </a:p>
-          <a:p>
+              <a:t>Ce tableau présente une comparaison entre les deux solutions envisagées : </a:t>
+            </a:r>
+            <a:r>
+              <a:rPr lang="" b="1" dirty="0"/>
+              <a:t>l'application Web et le logiciel Desktop</a:t>
+            </a:r>
             <a:r>
               <a:rPr lang="" dirty="0"/>
-              <a:t>Pour la comparaisons des solutions, sur le plan financier et logistique, l'Application Web l'emporte largement. Son </a:t>
-            </a:r>
-            <a:r>
-              <a:rPr lang="" sz="1200" b="1" u="none" strike="noStrike" kern="1200" dirty="0">
-                <a:solidFill>
-                  <a:schemeClr val="tx1"/>
-                </a:solidFill>
-                <a:effectLst/>
-                <a:latin typeface="+mn-lt"/>
-                <a:ea typeface="+mn-ea"/>
-                <a:cs typeface="+mn-cs"/>
-              </a:rPr>
-              <a:t>coût initial</a:t>
-            </a:r>
+              <a:t>.</a:t>
+            </a:r>
+          </a:p>
+          <a:p>
             <a:r>
               <a:rPr lang="" dirty="0"/>
-              <a:t> est modéré puisque j’ai exploité une stack open-source. Le </a:t>
-            </a:r>
-            <a:r>
-              <a:rPr lang="" sz="1200" b="1" u="none" strike="noStrike" kern="1200" dirty="0">
-                <a:solidFill>
-                  <a:schemeClr val="tx1"/>
-                </a:solidFill>
-                <a:effectLst/>
-                <a:latin typeface="+mn-lt"/>
-                <a:ea typeface="+mn-ea"/>
-                <a:cs typeface="+mn-cs"/>
-              </a:rPr>
-              <a:t>matériel nécessaire</a:t>
+              <a:t>Sur le plan financier et technique, l'application Web présente plusieurs avantages : un </a:t>
+            </a:r>
+            <a:r>
+              <a:rPr lang="" b="1" dirty="0"/>
+              <a:t>coût initial réduit</a:t>
             </a:r>
             <a:r>
               <a:rPr lang="" dirty="0"/>
-              <a:t> se limite au parc informatique existant : un simple navigateur web suffit pour y accéder, sans aucune installation locale. À l'inverse, le Logiciel Desktop exige un déploiement lourd, machine par machine, ce qui complique l'harmonisation des versions au sein de l'agence.</a:t>
-            </a:r>
-          </a:p>
-          <a:p>
-            <a:endParaRPr lang="" dirty="0"/>
+              <a:t>, un matériel minimal et un déploiement centralisé, contrairement au logiciel Desktop qui nécessite une installation sur chaque poste.</a:t>
+            </a:r>
           </a:p>
           <a:p>
             <a:r>
               <a:rPr lang="" dirty="0"/>
-              <a:t>Ensuite, concernant l'aspect fonctionnel et humain, l'assurance automobile impose un suivi strict des échéances. L'application Web permet une </a:t>
-            </a:r>
-            <a:r>
-              <a:rPr lang="" sz="1200" b="1" u="none" strike="noStrike" kern="1200" dirty="0">
-                <a:solidFill>
-                  <a:schemeClr val="tx1"/>
-                </a:solidFill>
-                <a:effectLst/>
-                <a:latin typeface="+mn-lt"/>
-                <a:ea typeface="+mn-ea"/>
-                <a:cs typeface="+mn-cs"/>
-              </a:rPr>
-              <a:t>gestion des alertes</a:t>
+              <a:t>Sur le plan fonctionnel, elle facilite également la </a:t>
+            </a:r>
+            <a:r>
+              <a:rPr lang="" b="1" dirty="0"/>
+              <a:t>gestion dynamique des alertes</a:t>
             </a:r>
             <a:r>
               <a:rPr lang="" dirty="0"/>
-              <a:t> centralisée et dynamique, capable de déclencher des tâches de fond automatisées. Côté </a:t>
-            </a:r>
-            <a:r>
-              <a:rPr lang="" sz="1200" b="1" u="none" strike="noStrike" kern="1200" dirty="0">
-                <a:solidFill>
-                  <a:schemeClr val="tx1"/>
-                </a:solidFill>
-                <a:effectLst/>
-                <a:latin typeface="+mn-lt"/>
-                <a:ea typeface="+mn-ea"/>
-                <a:cs typeface="+mn-cs"/>
-              </a:rPr>
-              <a:t>charges humaines</a:t>
+              <a:t> et simplifie la maintenance grâce aux mises à jour centralisées.</a:t>
+            </a:r>
+          </a:p>
+          <a:p>
+            <a:r>
+              <a:rPr lang="" b="1" dirty="0"/>
+              <a:t>Cependant, mon choix ne repose pas uniquement sur le coût réduit</a:t>
             </a:r>
             <a:r>
               <a:rPr lang="" dirty="0"/>
-              <a:t>, la maintenance d'une application web est entièrement centralisée sur le serveur. Si une mise à jour est nécessaire, le service informatique d'AUXIMAD l'applique en une seule fois au niveau central, évitant ainsi aux techniciens de devoir intervenir physiquement sur chaque ordinateur de l'entreprise.</a:t>
-            </a:r>
-          </a:p>
-          <a:p>
-            <a:endParaRPr lang="" dirty="0"/>
+              <a:t>, mais surtout sur les avantages fonctionnels, la facilité de déploiement et de maintenance, ainsi que l'adaptation aux besoins d'AUXIMAD.</a:t>
+            </a:r>
           </a:p>
           <a:p>
             <a:r>
               <a:rPr lang="" dirty="0"/>
-              <a:t>C’est l’ensemble de ces arguments technico-économiques qui ma naturellement conduits à retenir la </a:t>
-            </a:r>
-            <a:r>
-              <a:rPr lang="" sz="1200" b="1" u="none" strike="noStrike" kern="1200" dirty="0">
-                <a:solidFill>
-                  <a:schemeClr val="tx1"/>
-                </a:solidFill>
-                <a:effectLst/>
-                <a:latin typeface="+mn-lt"/>
-                <a:ea typeface="+mn-ea"/>
-                <a:cs typeface="+mn-cs"/>
-              </a:rPr>
-              <a:t>Solution Web</a:t>
+              <a:t>C'est donc pour l'ensemble de ces raisons que j'ai retenu </a:t>
+            </a:r>
+            <a:r>
+              <a:rPr lang="" b="1" dirty="0"/>
+              <a:t>la solution Web pour développer AUXIDRIVE</a:t>
             </a:r>
             <a:r>
               <a:rPr lang="" dirty="0"/>
-              <a:t> pour concevoir l'application AUXIDRIVE. </a:t>
-            </a:r>
-            <a:endParaRPr lang="en-US" dirty="0"/>
+              <a:t>.</a:t>
+            </a:r>
           </a:p>
         </p:txBody>
       </p:sp>
@@ -8766,7 +8706,7 @@
                 <a:ea typeface="+mn-ea"/>
                 <a:cs typeface="+mn-cs"/>
               </a:rPr>
-              <a:t>Ce diagramme de Gantt présente le déroulement de mon projet sur 9 semaines, du 13 août au 13 octobre 2026, structuré en quatre grandes phases.</a:t>
+              <a:t>Ce diagramme de Gantt présente le déroulement de mon projet sur 9 semaines, structuré en quatre grandes phases.</a:t>
             </a:r>
             <a:r>
               <a:rPr lang="" dirty="0"/>
@@ -8845,104 +8785,13 @@
           <a:bodyPr/>
           <a:lstStyle/>
           <a:p>
-            <a:pPr marL="0" marR="0" lvl="0" indent="0" algn="l" defTabSz="914400" rtl="0" eaLnBrk="1" fontAlgn="auto" latinLnBrk="0" hangingPunct="1">
-              <a:lnSpc>
-                <a:spcPct val="100000"/>
-              </a:lnSpc>
-              <a:spcBef>
-                <a:spcPts val="0"/>
-              </a:spcBef>
-              <a:spcAft>
-                <a:spcPts val="0"/>
-              </a:spcAft>
-              <a:buClrTx/>
-              <a:buSzTx/>
-              <a:buFontTx/>
-              <a:buNone/>
-              <a:tabLst/>
-              <a:defRPr/>
-            </a:pPr>
             <a:r>
               <a:rPr lang="" dirty="0"/>
-              <a:t>Nous abordons à présent la deuxième partie de notre présentation, dédiée à l’Étude détaillée et à la modélisation UML de notre système.</a:t>
-            </a:r>
-          </a:p>
-          <a:p>
-            <a:endParaRPr lang="" dirty="0"/>
-          </a:p>
-          <a:p>
-            <a:r>
-              <a:rPr lang="" dirty="0"/>
-              <a:t>Pour garantir la robustesse et la pérennité de l'application </a:t>
-            </a:r>
-            <a:r>
-              <a:rPr lang="" sz="1200" b="1" u="none" strike="noStrike" kern="1200" dirty="0">
-                <a:solidFill>
-                  <a:schemeClr val="tx1"/>
-                </a:solidFill>
-                <a:effectLst/>
-                <a:latin typeface="+mn-lt"/>
-                <a:ea typeface="+mn-ea"/>
-                <a:cs typeface="+mn-cs"/>
-              </a:rPr>
-              <a:t>AUXIDRIVE</a:t>
-            </a:r>
-            <a:r>
-              <a:rPr lang="" dirty="0"/>
-              <a:t>, j’ai adopté une démarche orientée objet à l’aide du langage de modélisation standardisé UML. Cette étape essentielle m’a permis de traduire toutes les règles complexes du secteur de l'assurance automobile en modèles logiques rigoureux avant d'attaquer la phase de codage.</a:t>
-            </a:r>
-          </a:p>
-          <a:p>
-            <a:endParaRPr lang="" dirty="0"/>
-          </a:p>
-          <a:p>
-            <a:r>
-              <a:rPr lang="" dirty="0"/>
-              <a:t>Afin de structurer au mieux le système, j’ai conçu une suite complète de diagrammes. J’ai d'abord isolé les droits de chaque utilisateur avec le </a:t>
-            </a:r>
-            <a:r>
-              <a:rPr lang="" sz="1200" b="1" u="none" strike="noStrike" kern="1200" dirty="0">
-                <a:solidFill>
-                  <a:schemeClr val="tx1"/>
-                </a:solidFill>
-                <a:effectLst/>
-                <a:latin typeface="+mn-lt"/>
-                <a:ea typeface="+mn-ea"/>
-                <a:cs typeface="+mn-cs"/>
-              </a:rPr>
-              <a:t>diagramme de cas d'utilisation</a:t>
-            </a:r>
-            <a:r>
-              <a:rPr lang="" dirty="0"/>
-              <a:t>, modélisé la chronologie des processus critiques comme l'inscription ou la souscription de flotte avec les </a:t>
-            </a:r>
-            <a:r>
-              <a:rPr lang="" sz="1200" b="1" u="none" strike="noStrike" kern="1200" dirty="0">
-                <a:solidFill>
-                  <a:schemeClr val="tx1"/>
-                </a:solidFill>
-                <a:effectLst/>
-                <a:latin typeface="+mn-lt"/>
-                <a:ea typeface="+mn-ea"/>
-                <a:cs typeface="+mn-cs"/>
-              </a:rPr>
-              <a:t>diagrammes de séquence</a:t>
-            </a:r>
-            <a:r>
-              <a:rPr lang="" dirty="0"/>
-              <a:t>, et posé la structure de notre base de données grâce au </a:t>
-            </a:r>
-            <a:r>
-              <a:rPr lang="" sz="1200" b="1" u="none" strike="noStrike" kern="1200" dirty="0">
-                <a:solidFill>
-                  <a:schemeClr val="tx1"/>
-                </a:solidFill>
-                <a:effectLst/>
-                <a:latin typeface="+mn-lt"/>
-                <a:ea typeface="+mn-ea"/>
-                <a:cs typeface="+mn-cs"/>
-              </a:rPr>
-              <a:t>diagramme de classes</a:t>
+              <a:t>Nous passons maintenant à la deuxième partie de notre présentation, consacrée à </a:t>
+            </a:r>
+            <a:r>
+              <a:rPr lang="" b="1" dirty="0"/>
+              <a:t>l’étude détaillée et à la modélisation UML</a:t>
             </a:r>
             <a:r>
               <a:rPr lang="" dirty="0"/>
@@ -8955,23 +8804,82 @@
           <a:p>
             <a:r>
               <a:rPr lang="" dirty="0"/>
-              <a:t>Afin d'optimiser le temps imparti pour cette présentation orale et d'aller directement à l'essentiel de notre réalisation, </a:t>
-            </a:r>
-            <a:r>
-              <a:rPr lang="" sz="1200" b="1" u="none" strike="noStrike" kern="1200" dirty="0">
-                <a:solidFill>
-                  <a:schemeClr val="tx1"/>
-                </a:solidFill>
-                <a:effectLst/>
-                <a:latin typeface="+mn-lt"/>
-                <a:ea typeface="+mn-ea"/>
-                <a:cs typeface="+mn-cs"/>
-              </a:rPr>
-              <a:t>l'intégralité des visuels et l'analyse détaillée étape par étape de ces diagrammes UML sont consignées dans notre mémoire</a:t>
-            </a:r>
+              <a:t>Pour concevoir l’application AUXIDRIVE, j’ai utilisé le langage UML, qui permet de représenter et de mieux comprendre le fonctionnement d’un système avant de passer au développement.</a:t>
+            </a:r>
+          </a:p>
+          <a:p>
+            <a:endParaRPr lang="" dirty="0"/>
+          </a:p>
+          <a:p>
             <a:r>
               <a:rPr lang="" dirty="0"/>
-              <a:t>. Je vous invite à vous y référer pour en examiner les spécificités techniques.</a:t>
+              <a:t>Pour cela, j’ai réalisé plusieurs diagrammes, notamment :</a:t>
+            </a:r>
+          </a:p>
+          <a:p>
+            <a:pPr marL="171450" lvl="0" indent="-171450">
+              <a:buFont typeface="Arial" panose="020B0604020202020204" pitchFamily="34" charset="0"/>
+              <a:buChar char="•"/>
+            </a:pPr>
+            <a:r>
+              <a:rPr lang="" b="1" dirty="0"/>
+              <a:t>Le diagramme de cas d’utilisation</a:t>
+            </a:r>
+            <a:r>
+              <a:rPr lang="" dirty="0"/>
+              <a:t>, qui présente les différentes fonctionnalités accessibles à chaque utilisateur.</a:t>
+            </a:r>
+          </a:p>
+          <a:p>
+            <a:pPr marL="171450" lvl="0" indent="-171450">
+              <a:buFont typeface="Arial" panose="020B0604020202020204" pitchFamily="34" charset="0"/>
+              <a:buChar char="•"/>
+            </a:pPr>
+            <a:r>
+              <a:rPr lang="" b="1" dirty="0"/>
+              <a:t>Le diagramme de séquence</a:t>
+            </a:r>
+            <a:r>
+              <a:rPr lang="" dirty="0"/>
+              <a:t>, qui montre comment les différentes actions se déroulent dans le temps.</a:t>
+            </a:r>
+          </a:p>
+          <a:p>
+            <a:pPr marL="171450" lvl="0" indent="-171450">
+              <a:buFont typeface="Arial" panose="020B0604020202020204" pitchFamily="34" charset="0"/>
+              <a:buChar char="•"/>
+            </a:pPr>
+            <a:r>
+              <a:rPr lang="" b="1" dirty="0"/>
+              <a:t>Le diagramme d’activités</a:t>
+            </a:r>
+            <a:r>
+              <a:rPr lang="" dirty="0"/>
+              <a:t>, qui représente les étapes des différents processus.</a:t>
+            </a:r>
+          </a:p>
+          <a:p>
+            <a:pPr marL="171450" lvl="0" indent="-171450">
+              <a:buFont typeface="Arial" panose="020B0604020202020204" pitchFamily="34" charset="0"/>
+              <a:buChar char="•"/>
+            </a:pPr>
+            <a:r>
+              <a:rPr lang="" dirty="0"/>
+              <a:t>Et enfin, </a:t>
+            </a:r>
+            <a:r>
+              <a:rPr lang="" b="1" dirty="0"/>
+              <a:t>le diagramme de classes</a:t>
+            </a:r>
+            <a:r>
+              <a:rPr lang="" dirty="0"/>
+              <a:t>, qui présente la structure du système ainsi que les relations entre les différentes classes.</a:t>
+            </a:r>
+          </a:p>
+          <a:p>
+            <a:r>
+              <a:rPr lang="" dirty="0"/>
+              <a:t>Ces diagrammes m’ont permis de mieux organiser le projet et de préparer la phase de développement.</a:t>
             </a:r>
           </a:p>
           <a:p>
@@ -8980,9 +8888,29 @@
           <a:p>
             <a:r>
               <a:rPr lang="" dirty="0"/>
-              <a:t>Sans plus attendre, je vous propose de basculer vers la troisième grande partie de notre exposé, dédiée à la réalisation technique et concrète de l'application.</a:t>
-            </a:r>
-            <a:endParaRPr lang="en-US" dirty="0"/>
+              <a:t>Cependant, afin de respecter le temps qui nous est accordé, je ne vais pas présenter chaque diagramme en détail. </a:t>
+            </a:r>
+            <a:r>
+              <a:rPr lang="" b="1" dirty="0"/>
+              <a:t>Vous pourrez retrouver l’ensemble de ces diagrammes, accompagnés de leurs explications, dans mon livre de mémoire.</a:t>
+            </a:r>
+          </a:p>
+          <a:p>
+            <a:endParaRPr lang="" dirty="0"/>
+          </a:p>
+          <a:p>
+            <a:r>
+              <a:rPr lang="" dirty="0"/>
+              <a:t>Nous allons donc passer à </a:t>
+            </a:r>
+            <a:r>
+              <a:rPr lang="" b="1" dirty="0"/>
+              <a:t>la troisième et dernière partie de notre présentation, consacrée à la réalisation de l’application AUXIDRIVE</a:t>
+            </a:r>
+            <a:r>
+              <a:rPr lang="" dirty="0"/>
+              <a:t>.</a:t>
+            </a:r>
           </a:p>
         </p:txBody>
       </p:sp>
@@ -9086,23 +9014,82 @@
           <a:p>
             <a:r>
               <a:rPr lang="" dirty="0"/>
-              <a:t>Pour garantir la robustesse et la pérennité de l'application </a:t>
-            </a:r>
-            <a:r>
-              <a:rPr lang="" sz="1200" b="1" u="none" strike="noStrike" kern="1200" dirty="0">
-                <a:solidFill>
-                  <a:schemeClr val="tx1"/>
-                </a:solidFill>
-                <a:effectLst/>
-                <a:latin typeface="+mn-lt"/>
-                <a:ea typeface="+mn-ea"/>
-                <a:cs typeface="+mn-cs"/>
-              </a:rPr>
-              <a:t>AUXIDRIVE</a:t>
-            </a:r>
+              <a:t>Pour concevoir l’application AUXIDRIVE, j’ai utilisé le langage UML, qui permet de représenter et de mieux comprendre le fonctionnement d’un système avant de passer au développement.</a:t>
+            </a:r>
+          </a:p>
+          <a:p>
+            <a:endParaRPr lang="" dirty="0"/>
+          </a:p>
+          <a:p>
             <a:r>
               <a:rPr lang="" dirty="0"/>
-              <a:t>, j’ai adopté une démarche orientée objet à l’aide du langage de modélisation standardisé UML. Cette étape essentielle m’a permis de traduire toutes les règles complexes du secteur de l'assurance automobile en modèles logiques rigoureux avant d'attaquer la phase de codage.</a:t>
+              <a:t>Pour cela, j’ai réalisé plusieurs diagrammes, notamment :</a:t>
+            </a:r>
+          </a:p>
+          <a:p>
+            <a:pPr marL="171450" lvl="0" indent="-171450">
+              <a:buFont typeface="Arial" panose="020B0604020202020204" pitchFamily="34" charset="0"/>
+              <a:buChar char="•"/>
+            </a:pPr>
+            <a:r>
+              <a:rPr lang="" b="1" dirty="0"/>
+              <a:t>Le diagramme de cas d’utilisation</a:t>
+            </a:r>
+            <a:r>
+              <a:rPr lang="" dirty="0"/>
+              <a:t>, qui présente les différentes fonctionnalités accessibles à chaque utilisateur.</a:t>
+            </a:r>
+          </a:p>
+          <a:p>
+            <a:pPr marL="171450" lvl="0" indent="-171450">
+              <a:buFont typeface="Arial" panose="020B0604020202020204" pitchFamily="34" charset="0"/>
+              <a:buChar char="•"/>
+            </a:pPr>
+            <a:r>
+              <a:rPr lang="" b="1" dirty="0"/>
+              <a:t>Le diagramme de séquence</a:t>
+            </a:r>
+            <a:r>
+              <a:rPr lang="" dirty="0"/>
+              <a:t>, qui montre comment les différentes actions se déroulent dans le temps.</a:t>
+            </a:r>
+          </a:p>
+          <a:p>
+            <a:pPr marL="171450" lvl="0" indent="-171450">
+              <a:buFont typeface="Arial" panose="020B0604020202020204" pitchFamily="34" charset="0"/>
+              <a:buChar char="•"/>
+            </a:pPr>
+            <a:r>
+              <a:rPr lang="" b="1" dirty="0"/>
+              <a:t>Le diagramme d’activités</a:t>
+            </a:r>
+            <a:r>
+              <a:rPr lang="" dirty="0"/>
+              <a:t>, qui représente les étapes des différents processus.</a:t>
+            </a:r>
+          </a:p>
+          <a:p>
+            <a:pPr marL="171450" lvl="0" indent="-171450">
+              <a:buFont typeface="Arial" panose="020B0604020202020204" pitchFamily="34" charset="0"/>
+              <a:buChar char="•"/>
+            </a:pPr>
+            <a:r>
+              <a:rPr lang="" dirty="0"/>
+              <a:t>Et enfin, </a:t>
+            </a:r>
+            <a:r>
+              <a:rPr lang="" b="1" dirty="0"/>
+              <a:t>le diagramme de classes</a:t>
+            </a:r>
+            <a:r>
+              <a:rPr lang="" dirty="0"/>
+              <a:t>, qui présente la structure du système ainsi que les relations entre les différentes classes.</a:t>
+            </a:r>
+          </a:p>
+          <a:p>
+            <a:r>
+              <a:rPr lang="" dirty="0"/>
+              <a:t>Ces diagrammes m’ont permis de mieux organiser le projet et de préparer la phase de développement.</a:t>
             </a:r>
           </a:p>
           <a:p>
@@ -9111,91 +9098,29 @@
           <a:p>
             <a:r>
               <a:rPr lang="" dirty="0"/>
-              <a:t>Afin de structurer au mieux le système, j’ai conçu une suite complète de diagrammes. J’ai d'abord isolé les droits de chaque utilisateur avec le </a:t>
-            </a:r>
-            <a:r>
-              <a:rPr lang="" sz="1200" b="1" u="none" strike="noStrike" kern="1200" dirty="0">
-                <a:solidFill>
-                  <a:schemeClr val="tx1"/>
-                </a:solidFill>
-                <a:effectLst/>
-                <a:latin typeface="+mn-lt"/>
-                <a:ea typeface="+mn-ea"/>
-                <a:cs typeface="+mn-cs"/>
-              </a:rPr>
-              <a:t>diagramme de cas d'utilisation</a:t>
-            </a:r>
+              <a:t>Cependant, afin de respecter le temps qui nous est accordé, je ne vais pas présenter chaque diagramme en détail. </a:t>
+            </a:r>
+            <a:r>
+              <a:rPr lang="" b="1" dirty="0"/>
+              <a:t>Vous pourrez retrouver l’ensemble de ces diagrammes, accompagnés de leurs explications, dans mon livre de mémoire.</a:t>
+            </a:r>
+          </a:p>
+          <a:p>
+            <a:endParaRPr lang="" dirty="0"/>
+          </a:p>
+          <a:p>
             <a:r>
               <a:rPr lang="" dirty="0"/>
-              <a:t>, modélisé la chronologie des processus critiques comme l'inscription ou la souscription de flotte avec les </a:t>
-            </a:r>
-            <a:r>
-              <a:rPr lang="" sz="1200" b="1" u="none" strike="noStrike" kern="1200" dirty="0">
-                <a:solidFill>
-                  <a:schemeClr val="tx1"/>
-                </a:solidFill>
-                <a:effectLst/>
-                <a:latin typeface="+mn-lt"/>
-                <a:ea typeface="+mn-ea"/>
-                <a:cs typeface="+mn-cs"/>
-              </a:rPr>
-              <a:t>diagrammes de séquence</a:t>
-            </a:r>
-            <a:r>
-              <a:rPr lang="" dirty="0"/>
-              <a:t>, et posé la structure de notre base de données grâce au </a:t>
-            </a:r>
-            <a:r>
-              <a:rPr lang="" sz="1200" b="1" u="none" strike="noStrike" kern="1200" dirty="0">
-                <a:solidFill>
-                  <a:schemeClr val="tx1"/>
-                </a:solidFill>
-                <a:effectLst/>
-                <a:latin typeface="+mn-lt"/>
-                <a:ea typeface="+mn-ea"/>
-                <a:cs typeface="+mn-cs"/>
-              </a:rPr>
-              <a:t>diagramme de classes</a:t>
+              <a:t>Nous allons donc passer à </a:t>
+            </a:r>
+            <a:r>
+              <a:rPr lang="" b="1" dirty="0"/>
+              <a:t>la troisième et dernière partie de notre présentation, consacrée à la réalisation de l’application AUXIDRIVE</a:t>
             </a:r>
             <a:r>
               <a:rPr lang="" dirty="0"/>
               <a:t>.</a:t>
             </a:r>
-          </a:p>
-          <a:p>
-            <a:endParaRPr lang="" dirty="0"/>
-          </a:p>
-          <a:p>
-            <a:r>
-              <a:rPr lang="" dirty="0"/>
-              <a:t>Afin d'optimiser le temps imparti pour cette présentation orale et d'aller directement à l'essentiel de notre réalisation, </a:t>
-            </a:r>
-            <a:r>
-              <a:rPr lang="" sz="1200" b="1" u="none" strike="noStrike" kern="1200" dirty="0">
-                <a:solidFill>
-                  <a:schemeClr val="tx1"/>
-                </a:solidFill>
-                <a:effectLst/>
-                <a:latin typeface="+mn-lt"/>
-                <a:ea typeface="+mn-ea"/>
-                <a:cs typeface="+mn-cs"/>
-              </a:rPr>
-              <a:t>l'intégralité des visuels et l'analyse détaillée étape par étape de ces diagrammes UML sont consignées dans notre mémoire</a:t>
-            </a:r>
-            <a:r>
-              <a:rPr lang="" dirty="0"/>
-              <a:t>. Je vous invite à vous y référer pour en examiner les spécificités techniques.</a:t>
-            </a:r>
-          </a:p>
-          <a:p>
-            <a:endParaRPr lang="" dirty="0"/>
-          </a:p>
-          <a:p>
-            <a:r>
-              <a:rPr lang="" dirty="0"/>
-              <a:t>Sans plus attendre, je vous propose de basculer vers la troisième grande partie de notre exposé, dédiée à la réalisation technique et concrète de l'application.</a:t>
-            </a:r>
-            <a:endParaRPr lang="en-US" dirty="0"/>
           </a:p>
         </p:txBody>
       </p:sp>
@@ -9879,23 +9804,15 @@
           <a:p>
             <a:r>
               <a:rPr lang="" dirty="0"/>
-              <a:t>En conclusion, ce projet a représenté un défi technologique et fonctionnel majeur. L'application </a:t>
-            </a:r>
-            <a:r>
-              <a:rPr lang="" sz="1200" b="1" u="none" strike="noStrike" kern="1200" dirty="0">
-                <a:solidFill>
-                  <a:schemeClr val="tx1"/>
-                </a:solidFill>
-                <a:effectLst/>
-                <a:latin typeface="+mn-lt"/>
-                <a:ea typeface="+mn-ea"/>
-                <a:cs typeface="+mn-cs"/>
-              </a:rPr>
+              <a:t>Pour conclure cette présentation, le développement de l'application </a:t>
+            </a:r>
+            <a:r>
+              <a:rPr lang="" b="1" dirty="0"/>
               <a:t>AUXIDRIVE</a:t>
             </a:r>
             <a:r>
               <a:rPr lang="" dirty="0"/>
-              <a:t> que j’ai conçue et développée répond avec précision aux exigences du cahier des charges initial. Elle offre une transition numérique concrète pour l'entreprise en éliminant les tâches manuelles redondantes, les risques d'erreurs de saisie et la dépendance critique aux outils bureautiques fragmentés comme Excel. </a:t>
+              <a:t> m'a permis d'atteindre les principaux objectifs fixés au début du projet.</a:t>
             </a:r>
           </a:p>
           <a:p>
@@ -9903,8 +9820,12 @@
           </a:p>
           <a:p>
             <a:r>
+              <a:rPr lang="" b="1" dirty="0"/>
+              <a:t>Tout d'abord, concernant le bilan du projet</a:t>
+            </a:r>
+            <a:r>
               <a:rPr lang="" dirty="0"/>
-              <a:t>Comme tout projet logiciel, cette plateforme reste évolutive. Parmi les perspectives à court terme, Je prévois de finaliser la gestion fine du mode déconnecté pour garantir une continuité parfaite du service en cas de panne réseau. Je dois également valider auprès de la direction de production les formules exactes liées aux codes de taxes spécifiques de l'assurance automobile. À plus long terme, l'intégration d'un module de paiement en ligne via les solutions locales de Mobile Money constituera un atout stratégique majeur.</a:t>
+              <a:t>, l'application contribue à moderniser la gestion de l'assurance automobile au sein d'AUXIMAD, en automatisant plusieurs tâches, en réduisant les risques d'erreurs et en facilitant le suivi des opérations.</a:t>
             </a:r>
           </a:p>
           <a:p>
@@ -9912,41 +9833,36 @@
           </a:p>
           <a:p>
             <a:r>
+              <a:rPr lang="" b="1" dirty="0"/>
+              <a:t>Ensuite, concernant les perspectives d'évolution</a:t>
+            </a:r>
+            <a:r>
               <a:rPr lang="" dirty="0"/>
-              <a:t>Sur un plan personnel et professionnel, ce stage de trois mois au sein du </a:t>
-            </a:r>
-            <a:r>
-              <a:rPr lang="" sz="1200" b="0" i="1" u="none" strike="noStrike" kern="1200" dirty="0">
-                <a:solidFill>
-                  <a:schemeClr val="tx1"/>
-                </a:solidFill>
-                <a:effectLst/>
-                <a:latin typeface="+mn-lt"/>
-                <a:ea typeface="+mn-ea"/>
-                <a:cs typeface="+mn-cs"/>
-              </a:rPr>
-              <a:t>Service Informatique et Technologique</a:t>
+              <a:t>, certaines améliorations restent à prévoir, notamment la mise en place d'un mode déconnecté pour permettre aux agents de travailler même en cas de panne réseau, ainsi que l'intégration d'un système de paiement en ligne, notamment par Mobile Money.</a:t>
+            </a:r>
+          </a:p>
+          <a:p>
+            <a:endParaRPr lang="" dirty="0"/>
+          </a:p>
+          <a:p>
+            <a:r>
+              <a:rPr lang="" b="1" dirty="0"/>
+              <a:t>Enfin, sur le plan personnel et professionnel</a:t>
             </a:r>
             <a:r>
               <a:rPr lang="" dirty="0"/>
-              <a:t> d'AUXIMAD a été d'une immense valeur. Il m'a permis de faire le pont entre la théorie académique dispensée à l’</a:t>
-            </a:r>
-            <a:r>
-              <a:rPr lang="" sz="1200" b="1" u="none" strike="noStrike" kern="1200" dirty="0">
-                <a:solidFill>
-                  <a:schemeClr val="tx1"/>
-                </a:solidFill>
-                <a:effectLst/>
-                <a:latin typeface="+mn-lt"/>
-                <a:ea typeface="+mn-ea"/>
-                <a:cs typeface="+mn-cs"/>
-              </a:rPr>
-              <a:t>ESP-BIG</a:t>
-            </a:r>
-            <a:r>
-              <a:rPr lang="" dirty="0"/>
-              <a:t> et les exigences industrielles concrètes du monde du travail, tout en consolidant mes compétences sur des frameworks de référence comme Spring Boot et Angular.</a:t>
-            </a:r>
+              <a:t>, ce stage de trois mois au sein d'AUXIMAD m'a permis de découvrir le monde professionnel, de mettre en pratique mes connaissances acquises à l'ESP-BIG et de renforcer mes compétences techniques, notamment avec Angular et Spring Boot.</a:t>
+            </a:r>
+          </a:p>
+          <a:p>
+            <a:endParaRPr lang="" dirty="0"/>
+          </a:p>
+          <a:p>
+            <a:r>
+              <a:rPr lang="" b="1" dirty="0"/>
+              <a:t>Ce projet a donc été une expérience très enrichissante, aussi bien sur le plan technique que professionnel.</a:t>
+            </a:r>
+            <a:endParaRPr lang="" dirty="0"/>
           </a:p>
         </p:txBody>
       </p:sp>
@@ -10050,23 +9966,15 @@
           <a:p>
             <a:r>
               <a:rPr lang="" dirty="0"/>
-              <a:t>En conclusion, ce projet a représenté un défi technologique et fonctionnel majeur. L'application </a:t>
-            </a:r>
-            <a:r>
-              <a:rPr lang="" sz="1200" b="1" u="none" strike="noStrike" kern="1200" dirty="0">
-                <a:solidFill>
-                  <a:schemeClr val="tx1"/>
-                </a:solidFill>
-                <a:effectLst/>
-                <a:latin typeface="+mn-lt"/>
-                <a:ea typeface="+mn-ea"/>
-                <a:cs typeface="+mn-cs"/>
-              </a:rPr>
-              <a:t>AUXIASSUR</a:t>
+              <a:t>Pour conclure cette présentation, le développement de l'application </a:t>
+            </a:r>
+            <a:r>
+              <a:rPr lang="" b="1" dirty="0"/>
+              <a:t>AUXIDRIVE</a:t>
             </a:r>
             <a:r>
               <a:rPr lang="" dirty="0"/>
-              <a:t> que j’ai conçue et développée répond avec précision aux exigences du cahier des charges initial. Elle offre une transition numérique concrète pour l'entreprise en éliminant les tâches manuelles redondantes, les risques d'erreurs de saisie et la dépendance critique aux outils bureautiques fragmentés comme Excel. </a:t>
+              <a:t> m'a permis d'atteindre les principaux objectifs fixés au début du projet.</a:t>
             </a:r>
           </a:p>
           <a:p>
@@ -10074,8 +9982,12 @@
           </a:p>
           <a:p>
             <a:r>
+              <a:rPr lang="" b="1" dirty="0"/>
+              <a:t>Tout d'abord, concernant le bilan du projet</a:t>
+            </a:r>
+            <a:r>
               <a:rPr lang="" dirty="0"/>
-              <a:t>Comme tout projet logiciel, cette plateforme reste évolutive. Parmi les perspectives à court terme, Je prévois de finaliser la gestion fine du mode déconnecté pour garantir une continuité parfaite du service en cas de panne réseau et l'intégration d'un module de paiement en ligne via les solutions locales de Mobile Money constituera un atout stratégique majeur.</a:t>
+              <a:t>, l'application contribue à moderniser la gestion de l'assurance automobile au sein d'AUXIMAD, en automatisant plusieurs tâches, en réduisant les risques d'erreurs et en facilitant le suivi des opérations.</a:t>
             </a:r>
           </a:p>
           <a:p>
@@ -10083,41 +9995,40 @@
           </a:p>
           <a:p>
             <a:r>
+              <a:rPr lang="" b="1" dirty="0"/>
+              <a:t>Ensuite, concernant les perspectives d'évolution</a:t>
+            </a:r>
+            <a:r>
               <a:rPr lang="" dirty="0"/>
-              <a:t>Sur un plan personnel et professionnel, ce stage de trois mois au sein du </a:t>
-            </a:r>
-            <a:r>
-              <a:rPr lang="" sz="1200" b="0" i="1" u="none" strike="noStrike" kern="1200" dirty="0">
-                <a:solidFill>
-                  <a:schemeClr val="tx1"/>
-                </a:solidFill>
-                <a:effectLst/>
-                <a:latin typeface="+mn-lt"/>
-                <a:ea typeface="+mn-ea"/>
-                <a:cs typeface="+mn-cs"/>
-              </a:rPr>
-              <a:t>Service Informatique et Technologique</a:t>
+              <a:t>, certaines améliorations restent à prévoir, notamment la mise en place d'un mode déconnecté pour permettre aux agents de travailler même en cas de panne réseau, ainsi que l'intégration d'un système de paiement en ligne, notamment par Mobile Money.</a:t>
+            </a:r>
+          </a:p>
+          <a:p>
+            <a:endParaRPr lang="" dirty="0"/>
+          </a:p>
+          <a:p>
+            <a:r>
+              <a:rPr lang="" b="1" dirty="0"/>
+              <a:t>Enfin, sur le plan personnel et professionnel</a:t>
             </a:r>
             <a:r>
               <a:rPr lang="" dirty="0"/>
-              <a:t> d'AUXIMAD a été d'une immense valeur. Il m'a permis de faire le pont entre la théorie académique dispensée à l’</a:t>
-            </a:r>
-            <a:r>
-              <a:rPr lang="" sz="1200" b="1" u="none" strike="noStrike" kern="1200" dirty="0">
-                <a:solidFill>
-                  <a:schemeClr val="tx1"/>
-                </a:solidFill>
-                <a:effectLst/>
-                <a:latin typeface="+mn-lt"/>
-                <a:ea typeface="+mn-ea"/>
-                <a:cs typeface="+mn-cs"/>
-              </a:rPr>
-              <a:t>ESP-BIG</a:t>
-            </a:r>
-            <a:r>
-              <a:rPr lang="" dirty="0"/>
-              <a:t> et les exigences industrielles concrètes du monde du travail, tout en consolidant mes compétences sur des frameworks de référence comme Spring Boot et Angular.</a:t>
-            </a:r>
+              <a:t>, ce stage de trois mois au sein d'AUXIMAD m'a permis de découvrir le monde professionnel, de mettre en pratique mes connaissances acquises à l'ESP-BIG et de renforcer mes </a:t>
+            </a:r>
+            <a:r>
+              <a:rPr lang=""/>
+              <a:t>compétences techniques.</a:t>
+            </a:r>
+          </a:p>
+          <a:p>
+            <a:endParaRPr lang="" dirty="0"/>
+          </a:p>
+          <a:p>
+            <a:r>
+              <a:rPr lang="" b="1" dirty="0"/>
+              <a:t>Ce projet a donc été une expérience très enrichissante, aussi bien sur le plan technique que professionnel.</a:t>
+            </a:r>
+            <a:endParaRPr lang="" dirty="0"/>
           </a:p>
         </p:txBody>
       </p:sp>
@@ -10242,7 +10153,7 @@
                 <a:ea typeface="+mn-ea"/>
                 <a:cs typeface="+mn-cs"/>
               </a:rPr>
-              <a:t>Mesdames et messieurs les membres du jury, Monsieur le Président du Jury,</a:t>
+              <a:t>Mes dames et messieurs les membres du jury, Madame la Présidente du Jury,</a:t>
             </a:r>
             <a:br>
               <a:rPr lang="" dirty="0"/>
@@ -11112,22 +11023,70 @@
           <a:lstStyle/>
           <a:p>
             <a:r>
-              <a:rPr lang="" sz="1200" b="1" u="none" strike="noStrike" kern="1200" dirty="0">
-                <a:solidFill>
-                  <a:schemeClr val="tx1"/>
-                </a:solidFill>
-                <a:effectLst/>
-                <a:latin typeface="+mn-lt"/>
-                <a:ea typeface="+mn-ea"/>
-                <a:cs typeface="+mn-cs"/>
-              </a:rPr>
-              <a:t>L'objectif général de mon projet est de concevoir une plateforme unique pour gérer tout le cycle de vie des contrats d'assurance automobile.</a:t>
+              <a:rPr lang="" b="1" dirty="0"/>
+              <a:t>L'objectif principal de mon projet est de concevoir une application Web unique</a:t>
             </a:r>
             <a:r>
               <a:rPr lang="" dirty="0"/>
-              <a:t> Plus précisément, j'ai cherché à centraliser toutes les données et à automatiser entièrement les calculs complexes, comme les tarifs selon les profils, les remises pour les flottes de plus de 5 véhicules et la mise à jour du bonus-malus. J'ai aussi intégré un tableau de bord statistique pour aider la direction à prendre des décisions. Grâce à cette application, les résultats concrets sont majeurs pour AUXIMAD : elle supprime la double saisie papier et les fichiers Excel de secours. Les assurés gagnent en autonomie en envoyant leurs justificatifs directement sur un portail web, tandis que les agents profitent d'un travail plus fluide, avec des factures PDF générées instantanément et un suivi numérique transparent des sinistres.</a:t>
-            </a:r>
-            <a:endParaRPr lang="en-US" dirty="0"/>
+              <a:t>, appelée AUXIDRIVE, permettant de centraliser la gestion de l'assurance automobile.</a:t>
+            </a:r>
+          </a:p>
+          <a:p>
+            <a:endParaRPr lang="" dirty="0"/>
+          </a:p>
+          <a:p>
+            <a:r>
+              <a:rPr lang="" dirty="0"/>
+              <a:t>Plus précisément, cette application vise à </a:t>
+            </a:r>
+            <a:r>
+              <a:rPr lang="" b="1" dirty="0"/>
+              <a:t>automatiser le calcul des primes</a:t>
+            </a:r>
+            <a:r>
+              <a:rPr lang="" dirty="0"/>
+              <a:t>, aussi bien pour un seul véhicule que pour une flotte, tout en prenant en compte les règles de bonus-malus.</a:t>
+            </a:r>
+          </a:p>
+          <a:p>
+            <a:endParaRPr lang="" dirty="0"/>
+          </a:p>
+          <a:p>
+            <a:r>
+              <a:rPr lang="" dirty="0"/>
+              <a:t>Elle permet également de simplifier la gestion des documents, de suivre les échéances des contrats, de déclarer les sinistres en ligne et de disposer d'un tableau de bord statistique pour faciliter la prise de décision.</a:t>
+            </a:r>
+          </a:p>
+          <a:p>
+            <a:endParaRPr lang="" dirty="0"/>
+          </a:p>
+          <a:p>
+            <a:r>
+              <a:rPr lang="" b="1" dirty="0"/>
+              <a:t>Concernant les résultats attendus</a:t>
+            </a:r>
+            <a:r>
+              <a:rPr lang="" dirty="0"/>
+              <a:t>, AUXIDRIVE vise à réduire les doubles saisies et la dépendance aux fichiers Excel.</a:t>
+            </a:r>
+          </a:p>
+          <a:p>
+            <a:endParaRPr lang="" dirty="0"/>
+          </a:p>
+          <a:p>
+            <a:r>
+              <a:rPr lang="" dirty="0"/>
+              <a:t>Du côté des clients, elle offre un espace personnel permettant d'envoyer leurs documents et de suivre leurs dossiers en ligne.</a:t>
+            </a:r>
+          </a:p>
+          <a:p>
+            <a:endParaRPr lang="" dirty="0"/>
+          </a:p>
+          <a:p>
+            <a:r>
+              <a:rPr lang="" dirty="0"/>
+              <a:t>Enfin, pour les agents, elle facilite le travail grâce à la génération automatique des factures PDF et au suivi numérique des sinistres, permettant ainsi de réduire le temps de traitement des dossiers.</a:t>
+            </a:r>
           </a:p>
         </p:txBody>
       </p:sp>
@@ -11231,7 +11190,7 @@
           <a:p>
             <a:r>
               <a:rPr lang="" dirty="0"/>
-              <a:t>Pour concevoir une solution adaptée, j’ai analysé le fonctionnement quotidien du service de production automobile d'AUXIASSUR. Ce service gère deux grands types d’opérations : le traitement des "affaires nouvelles" et la reconduction des contrats, appelés renouvellements. Trois profils collaborent de façon séquentielle : le chargé de production qui instruit le dossier, le Directeur d’agence qui valide, et enfin le caissier qui gère le règlement physique des primes.</a:t>
+              <a:t>Pour cette étude de l’existant, j’ai analysé le fonctionnement du service de production automobile d’AUXIASSUR.</a:t>
             </a:r>
           </a:p>
           <a:p>
@@ -11239,8 +11198,12 @@
           </a:p>
           <a:p>
             <a:r>
+              <a:rPr lang="" b="1" dirty="0"/>
+              <a:t>Tout d’abord, concernant le système actuel</a:t>
+            </a:r>
+            <a:r>
               <a:rPr lang="" dirty="0"/>
-              <a:t>La pièce maîtresse de ce système est la carte grise du véhicule. Sans elle, aucune procédure ne peut démarrer. Elle est complétée par la CIN du client pour générer le contrat officiel en trois exemplaires papier. Un exemplaire est remis au client après passage en caisse, un est conservé en agence, et le dernier est expédié physiquement au siège à la fin de chaque mois. </a:t>
+              <a:t>, ce service assure principalement la gestion des nouvelles souscriptions et des renouvellements, avec l’intervention de trois acteurs clés : le chargé de production, le Directeur d’agence et le caissier.</a:t>
             </a:r>
           </a:p>
           <a:p>
@@ -11248,10 +11211,26 @@
           </a:p>
           <a:p>
             <a:r>
+              <a:rPr lang="" b="1" dirty="0"/>
+              <a:t>Ensuite, sur le plan documentaire</a:t>
+            </a:r>
+            <a:r>
               <a:rPr lang="" dirty="0"/>
-              <a:t>Sur le plan informatique, les agents s'appuient principalement sur le logiciel Odoo pour enregistrer les fiches des assurés. Cependant, l'analyse montre que le service utilise couramment Microsoft Excel comme outil complémentaire ou solution de secours appelée "mode dégradé" pour pallier manuellement les lenteurs ou les ruptures régulières de la connexion internet.</a:t>
-            </a:r>
-            <a:endParaRPr lang="en-US" dirty="0"/>
+              <a:t>, les principales pièces d’entrée sont la carte grise du véhicule et la CIN du client. Elles permettent d’établir les documents de sortie, notamment l’attestation d’assurance, le contrat en trois exemplaires et le dossier de sinistre.</a:t>
+            </a:r>
+          </a:p>
+          <a:p>
+            <a:endParaRPr lang="" dirty="0"/>
+          </a:p>
+          <a:p>
+            <a:r>
+              <a:rPr lang="" b="1" dirty="0"/>
+              <a:t>Enfin, concernant l’environnement logiciel existant</a:t>
+            </a:r>
+            <a:r>
+              <a:rPr lang="" dirty="0"/>
+              <a:t>, le service utilise principalement Odoo pour l’enregistrement des souscriptions et le suivi des assurés, tandis que Microsoft Excel sert d’outil complémentaire, notamment en cas de panne de connexion réseau.</a:t>
+            </a:r>
           </a:p>
         </p:txBody>
       </p:sp>
@@ -12007,7 +11986,7 @@
           <a:p>
             <a:fld id="{CA02FB80-71B9-47BF-852E-5AF5189041F3}" type="datetimeFigureOut">
               <a:rPr lang="LID4096" smtClean="0"/>
-              <a:t>10/16/2026</a:t>
+              <a:t>10/20/2026</a:t>
             </a:fld>
             <a:endParaRPr lang="LID4096"/>
           </a:p>
@@ -12490,7 +12469,7 @@
         </p:nvSpPr>
         <p:spPr>
           <a:xfrm>
-            <a:off x="2395368" y="2651538"/>
+            <a:off x="2361505" y="2800969"/>
             <a:ext cx="7114377" cy="1572992"/>
           </a:xfrm>
         </p:spPr>
@@ -12501,16 +12480,35 @@
           <a:lstStyle/>
           <a:p>
             <a:r>
-              <a:rPr lang="fr-FR" sz="2800" dirty="0">
+              <a:rPr lang="fr-FR" sz="2000" dirty="0">
                 <a:solidFill>
                   <a:schemeClr val="bg1"/>
                 </a:solidFill>
                 <a:latin typeface="Times New Roman" panose="02020603050405020304" pitchFamily="18" charset="0"/>
                 <a:cs typeface="Times New Roman" panose="02020603050405020304" pitchFamily="18" charset="0"/>
               </a:rPr>
-              <a:t>Conception et développement d’une application de gestion d’assurance automobile</a:t>
-            </a:r>
-            <a:endParaRPr lang="LID4096" sz="2800" dirty="0">
+              <a:t>CONCEPTION ET DEVELOPPEMENT D’UNE APPLICATION DE GESTION D’ASSURANCE AUTOMOBILE</a:t>
+            </a:r>
+            <a:br>
+              <a:rPr lang="fr-FR" sz="2000" dirty="0">
+                <a:solidFill>
+                  <a:schemeClr val="bg1"/>
+                </a:solidFill>
+                <a:latin typeface="Times New Roman" panose="02020603050405020304" pitchFamily="18" charset="0"/>
+                <a:cs typeface="Times New Roman" panose="02020603050405020304" pitchFamily="18" charset="0"/>
+              </a:rPr>
+            </a:br>
+            <a:r>
+              <a:rPr lang="fr-FR" sz="2000" dirty="0">
+                <a:solidFill>
+                  <a:schemeClr val="bg1"/>
+                </a:solidFill>
+                <a:latin typeface="Times New Roman" panose="02020603050405020304" pitchFamily="18" charset="0"/>
+                <a:cs typeface="Times New Roman" panose="02020603050405020304" pitchFamily="18" charset="0"/>
+              </a:rPr>
+              <a:t>cas : AUXIMAD</a:t>
+            </a:r>
+            <a:endParaRPr lang="LID4096" sz="2000" dirty="0">
               <a:solidFill>
                 <a:schemeClr val="bg1"/>
               </a:solidFill>
@@ -12925,31 +12923,7 @@
                 <a:latin typeface="Times New Roman" panose="02020603050405020304" pitchFamily="18" charset="0"/>
                 <a:cs typeface="Times New Roman" panose="02020603050405020304" pitchFamily="18" charset="0"/>
               </a:rPr>
-              <a:t> : </a:t>
-            </a:r>
-            <a:r>
-              <a:rPr lang="en-US" sz="1400" b="1" i="1" dirty="0" err="1">
-                <a:solidFill>
-                  <a:schemeClr val="bg2">
-                    <a:lumMod val="10000"/>
-                  </a:schemeClr>
-                </a:solidFill>
-                <a:latin typeface="Times New Roman" panose="02020603050405020304" pitchFamily="18" charset="0"/>
-                <a:cs typeface="Times New Roman" panose="02020603050405020304" pitchFamily="18" charset="0"/>
-              </a:rPr>
-              <a:t>Mme</a:t>
-            </a:r>
-            <a:r>
-              <a:rPr lang="en-US" sz="1400" b="1" i="1" dirty="0">
-                <a:solidFill>
-                  <a:schemeClr val="bg2">
-                    <a:lumMod val="10000"/>
-                  </a:schemeClr>
-                </a:solidFill>
-                <a:latin typeface="Times New Roman" panose="02020603050405020304" pitchFamily="18" charset="0"/>
-                <a:cs typeface="Times New Roman" panose="02020603050405020304" pitchFamily="18" charset="0"/>
-              </a:rPr>
-              <a:t> RAVAOHOLISOA Dorette </a:t>
+              <a:t> : Madame RAVAOHOLISOA Dorette </a:t>
             </a:r>
             <a:r>
               <a:rPr lang="en-US" sz="1400" b="1" i="1" dirty="0" err="1">
@@ -13011,7 +12985,7 @@
                 <a:latin typeface="Times New Roman" panose="02020603050405020304" pitchFamily="18" charset="0"/>
                 <a:cs typeface="Times New Roman" panose="02020603050405020304" pitchFamily="18" charset="0"/>
               </a:rPr>
-              <a:t> : M. RANAMBOARIMANGA Rindranianina</a:t>
+              <a:t> : Monsieur RANAMBOARIMANGA Rindranianina</a:t>
             </a:r>
           </a:p>
         </p:txBody>
@@ -13176,6 +13150,8 @@
                     <a:lumMod val="10000"/>
                   </a:schemeClr>
                 </a:solidFill>
+                <a:latin typeface="Times New Roman" panose="02020603050405020304" pitchFamily="18" charset="0"/>
+                <a:cs typeface="Times New Roman" panose="02020603050405020304" pitchFamily="18" charset="0"/>
               </a:rPr>
               <a:t>Mention</a:t>
             </a:r>
@@ -13186,6 +13162,8 @@
                     <a:lumMod val="10000"/>
                   </a:schemeClr>
                 </a:solidFill>
+                <a:latin typeface="Times New Roman" panose="02020603050405020304" pitchFamily="18" charset="0"/>
+                <a:cs typeface="Times New Roman" panose="02020603050405020304" pitchFamily="18" charset="0"/>
               </a:rPr>
               <a:t> : Informatique</a:t>
             </a:r>
@@ -13201,6 +13179,8 @@
                     <a:lumMod val="10000"/>
                   </a:schemeClr>
                 </a:solidFill>
+                <a:latin typeface="Times New Roman" panose="02020603050405020304" pitchFamily="18" charset="0"/>
+                <a:cs typeface="Times New Roman" panose="02020603050405020304" pitchFamily="18" charset="0"/>
               </a:rPr>
               <a:t>Parcours</a:t>
             </a:r>
@@ -13211,6 +13191,8 @@
                     <a:lumMod val="10000"/>
                   </a:schemeClr>
                 </a:solidFill>
+                <a:latin typeface="Times New Roman" panose="02020603050405020304" pitchFamily="18" charset="0"/>
+                <a:cs typeface="Times New Roman" panose="02020603050405020304" pitchFamily="18" charset="0"/>
               </a:rPr>
               <a:t> : Génie </a:t>
             </a:r>
@@ -13221,6 +13203,8 @@
                     <a:lumMod val="10000"/>
                   </a:schemeClr>
                 </a:solidFill>
+                <a:latin typeface="Times New Roman" panose="02020603050405020304" pitchFamily="18" charset="0"/>
+                <a:cs typeface="Times New Roman" panose="02020603050405020304" pitchFamily="18" charset="0"/>
               </a:rPr>
               <a:t>Logiciel</a:t>
             </a:r>
@@ -13230,6 +13214,8 @@
                   <a:lumMod val="10000"/>
                 </a:schemeClr>
               </a:solidFill>
+              <a:latin typeface="Times New Roman" panose="02020603050405020304" pitchFamily="18" charset="0"/>
+              <a:cs typeface="Times New Roman" panose="02020603050405020304" pitchFamily="18" charset="0"/>
             </a:endParaRPr>
           </a:p>
           <a:p>
@@ -13240,6 +13226,8 @@
                     <a:lumMod val="10000"/>
                   </a:schemeClr>
                 </a:solidFill>
+                <a:latin typeface="Times New Roman" panose="02020603050405020304" pitchFamily="18" charset="0"/>
+                <a:cs typeface="Times New Roman" panose="02020603050405020304" pitchFamily="18" charset="0"/>
               </a:rPr>
               <a:t>Cycle</a:t>
             </a:r>
@@ -13250,6 +13238,8 @@
                     <a:lumMod val="10000"/>
                   </a:schemeClr>
                 </a:solidFill>
+                <a:latin typeface="Times New Roman" panose="02020603050405020304" pitchFamily="18" charset="0"/>
+                <a:cs typeface="Times New Roman" panose="02020603050405020304" pitchFamily="18" charset="0"/>
               </a:rPr>
               <a:t> : Premier cycle</a:t>
             </a:r>
@@ -13262,6 +13252,8 @@
                     <a:lumMod val="10000"/>
                   </a:schemeClr>
                 </a:solidFill>
+                <a:latin typeface="Times New Roman" panose="02020603050405020304" pitchFamily="18" charset="0"/>
+                <a:cs typeface="Times New Roman" panose="02020603050405020304" pitchFamily="18" charset="0"/>
               </a:rPr>
               <a:t>Présenté</a:t>
             </a:r>
@@ -13272,6 +13264,8 @@
                     <a:lumMod val="10000"/>
                   </a:schemeClr>
                 </a:solidFill>
+                <a:latin typeface="Times New Roman" panose="02020603050405020304" pitchFamily="18" charset="0"/>
+                <a:cs typeface="Times New Roman" panose="02020603050405020304" pitchFamily="18" charset="0"/>
               </a:rPr>
               <a:t> par</a:t>
             </a:r>
@@ -13282,8 +13276,34 @@
                     <a:lumMod val="10000"/>
                   </a:schemeClr>
                 </a:solidFill>
+                <a:latin typeface="Times New Roman" panose="02020603050405020304" pitchFamily="18" charset="0"/>
+                <a:cs typeface="Times New Roman" panose="02020603050405020304" pitchFamily="18" charset="0"/>
               </a:rPr>
-              <a:t> : Rafalimanana Ny Harena </a:t>
+              <a:t> </a:t>
+            </a:r>
+            <a:r>
+              <a:rPr lang="en-US" sz="1600" b="1" i="1">
+                <a:solidFill>
+                  <a:schemeClr val="bg2">
+                    <a:lumMod val="10000"/>
+                  </a:schemeClr>
+                </a:solidFill>
+                <a:latin typeface="Times New Roman" panose="02020603050405020304" pitchFamily="18" charset="0"/>
+                <a:cs typeface="Times New Roman" panose="02020603050405020304" pitchFamily="18" charset="0"/>
+              </a:rPr>
+              <a:t>: Monsieur </a:t>
+            </a:r>
+            <a:r>
+              <a:rPr lang="en-US" sz="1600" b="1" i="1" dirty="0">
+                <a:solidFill>
+                  <a:schemeClr val="bg2">
+                    <a:lumMod val="10000"/>
+                  </a:schemeClr>
+                </a:solidFill>
+                <a:latin typeface="Times New Roman" panose="02020603050405020304" pitchFamily="18" charset="0"/>
+                <a:cs typeface="Times New Roman" panose="02020603050405020304" pitchFamily="18" charset="0"/>
+              </a:rPr>
+              <a:t>RAFALIMANANA Ny Harena </a:t>
             </a:r>
             <a:r>
               <a:rPr lang="en-US" sz="1600" b="1" i="1" dirty="0" err="1">
@@ -13292,6 +13312,8 @@
                     <a:lumMod val="10000"/>
                   </a:schemeClr>
                 </a:solidFill>
+                <a:latin typeface="Times New Roman" panose="02020603050405020304" pitchFamily="18" charset="0"/>
+                <a:cs typeface="Times New Roman" panose="02020603050405020304" pitchFamily="18" charset="0"/>
               </a:rPr>
               <a:t>Nohavinstsoa</a:t>
             </a:r>
@@ -13301,6 +13323,8 @@
                   <a:lumMod val="10000"/>
                 </a:schemeClr>
               </a:solidFill>
+              <a:latin typeface="Times New Roman" panose="02020603050405020304" pitchFamily="18" charset="0"/>
+              <a:cs typeface="Times New Roman" panose="02020603050405020304" pitchFamily="18" charset="0"/>
             </a:endParaRPr>
           </a:p>
         </p:txBody>
@@ -29757,6 +29781,827 @@
       </p:transition>
     </mc:Fallback>
   </mc:AlternateContent>
+  <p:timing>
+    <p:tnLst>
+      <p:par>
+        <p:cTn id="1" dur="indefinite" restart="never" nodeType="tmRoot">
+          <p:childTnLst>
+            <p:seq concurrent="1" nextAc="seek">
+              <p:cTn id="2" dur="indefinite" nodeType="mainSeq">
+                <p:childTnLst>
+                  <p:par>
+                    <p:cTn id="3" fill="hold">
+                      <p:stCondLst>
+                        <p:cond delay="indefinite"/>
+                      </p:stCondLst>
+                      <p:childTnLst>
+                        <p:par>
+                          <p:cTn id="4" fill="hold">
+                            <p:stCondLst>
+                              <p:cond delay="0"/>
+                            </p:stCondLst>
+                            <p:childTnLst>
+                              <p:par>
+                                <p:cTn id="5" presetID="42" presetClass="entr" presetSubtype="0" fill="hold" nodeType="clickEffect">
+                                  <p:stCondLst>
+                                    <p:cond delay="0"/>
+                                  </p:stCondLst>
+                                  <p:childTnLst>
+                                    <p:set>
+                                      <p:cBhvr>
+                                        <p:cTn id="6" dur="1" fill="hold">
+                                          <p:stCondLst>
+                                            <p:cond delay="0"/>
+                                          </p:stCondLst>
+                                        </p:cTn>
+                                        <p:tgtEl>
+                                          <p:spTgt spid="8"/>
+                                        </p:tgtEl>
+                                        <p:attrNameLst>
+                                          <p:attrName>style.visibility</p:attrName>
+                                        </p:attrNameLst>
+                                      </p:cBhvr>
+                                      <p:to>
+                                        <p:strVal val="visible"/>
+                                      </p:to>
+                                    </p:set>
+                                    <p:animEffect transition="in" filter="fade">
+                                      <p:cBhvr>
+                                        <p:cTn id="7" dur="1000"/>
+                                        <p:tgtEl>
+                                          <p:spTgt spid="8"/>
+                                        </p:tgtEl>
+                                      </p:cBhvr>
+                                    </p:animEffect>
+                                    <p:anim calcmode="lin" valueType="num">
+                                      <p:cBhvr>
+                                        <p:cTn id="8" dur="1000" fill="hold"/>
+                                        <p:tgtEl>
+                                          <p:spTgt spid="8"/>
+                                        </p:tgtEl>
+                                        <p:attrNameLst>
+                                          <p:attrName>ppt_x</p:attrName>
+                                        </p:attrNameLst>
+                                      </p:cBhvr>
+                                      <p:tavLst>
+                                        <p:tav tm="0">
+                                          <p:val>
+                                            <p:strVal val="#ppt_x"/>
+                                          </p:val>
+                                        </p:tav>
+                                        <p:tav tm="100000">
+                                          <p:val>
+                                            <p:strVal val="#ppt_x"/>
+                                          </p:val>
+                                        </p:tav>
+                                      </p:tavLst>
+                                    </p:anim>
+                                    <p:anim calcmode="lin" valueType="num">
+                                      <p:cBhvr>
+                                        <p:cTn id="9" dur="1000" fill="hold"/>
+                                        <p:tgtEl>
+                                          <p:spTgt spid="8"/>
+                                        </p:tgtEl>
+                                        <p:attrNameLst>
+                                          <p:attrName>ppt_y</p:attrName>
+                                        </p:attrNameLst>
+                                      </p:cBhvr>
+                                      <p:tavLst>
+                                        <p:tav tm="0">
+                                          <p:val>
+                                            <p:strVal val="#ppt_y+.1"/>
+                                          </p:val>
+                                        </p:tav>
+                                        <p:tav tm="100000">
+                                          <p:val>
+                                            <p:strVal val="#ppt_y"/>
+                                          </p:val>
+                                        </p:tav>
+                                      </p:tavLst>
+                                    </p:anim>
+                                  </p:childTnLst>
+                                </p:cTn>
+                              </p:par>
+                              <p:par>
+                                <p:cTn id="10" presetID="42" presetClass="entr" presetSubtype="0" fill="hold" grpId="0" nodeType="withEffect">
+                                  <p:stCondLst>
+                                    <p:cond delay="0"/>
+                                  </p:stCondLst>
+                                  <p:childTnLst>
+                                    <p:set>
+                                      <p:cBhvr>
+                                        <p:cTn id="11" dur="1" fill="hold">
+                                          <p:stCondLst>
+                                            <p:cond delay="0"/>
+                                          </p:stCondLst>
+                                        </p:cTn>
+                                        <p:tgtEl>
+                                          <p:spTgt spid="5"/>
+                                        </p:tgtEl>
+                                        <p:attrNameLst>
+                                          <p:attrName>style.visibility</p:attrName>
+                                        </p:attrNameLst>
+                                      </p:cBhvr>
+                                      <p:to>
+                                        <p:strVal val="visible"/>
+                                      </p:to>
+                                    </p:set>
+                                    <p:animEffect transition="in" filter="fade">
+                                      <p:cBhvr>
+                                        <p:cTn id="12" dur="1000"/>
+                                        <p:tgtEl>
+                                          <p:spTgt spid="5"/>
+                                        </p:tgtEl>
+                                      </p:cBhvr>
+                                    </p:animEffect>
+                                    <p:anim calcmode="lin" valueType="num">
+                                      <p:cBhvr>
+                                        <p:cTn id="13" dur="1000" fill="hold"/>
+                                        <p:tgtEl>
+                                          <p:spTgt spid="5"/>
+                                        </p:tgtEl>
+                                        <p:attrNameLst>
+                                          <p:attrName>ppt_x</p:attrName>
+                                        </p:attrNameLst>
+                                      </p:cBhvr>
+                                      <p:tavLst>
+                                        <p:tav tm="0">
+                                          <p:val>
+                                            <p:strVal val="#ppt_x"/>
+                                          </p:val>
+                                        </p:tav>
+                                        <p:tav tm="100000">
+                                          <p:val>
+                                            <p:strVal val="#ppt_x"/>
+                                          </p:val>
+                                        </p:tav>
+                                      </p:tavLst>
+                                    </p:anim>
+                                    <p:anim calcmode="lin" valueType="num">
+                                      <p:cBhvr>
+                                        <p:cTn id="14" dur="1000" fill="hold"/>
+                                        <p:tgtEl>
+                                          <p:spTgt spid="5"/>
+                                        </p:tgtEl>
+                                        <p:attrNameLst>
+                                          <p:attrName>ppt_y</p:attrName>
+                                        </p:attrNameLst>
+                                      </p:cBhvr>
+                                      <p:tavLst>
+                                        <p:tav tm="0">
+                                          <p:val>
+                                            <p:strVal val="#ppt_y+.1"/>
+                                          </p:val>
+                                        </p:tav>
+                                        <p:tav tm="100000">
+                                          <p:val>
+                                            <p:strVal val="#ppt_y"/>
+                                          </p:val>
+                                        </p:tav>
+                                      </p:tavLst>
+                                    </p:anim>
+                                  </p:childTnLst>
+                                </p:cTn>
+                              </p:par>
+                              <p:par>
+                                <p:cTn id="15" presetID="42" presetClass="entr" presetSubtype="0" fill="hold" grpId="0" nodeType="withEffect">
+                                  <p:stCondLst>
+                                    <p:cond delay="0"/>
+                                  </p:stCondLst>
+                                  <p:childTnLst>
+                                    <p:set>
+                                      <p:cBhvr>
+                                        <p:cTn id="16" dur="1" fill="hold">
+                                          <p:stCondLst>
+                                            <p:cond delay="0"/>
+                                          </p:stCondLst>
+                                        </p:cTn>
+                                        <p:tgtEl>
+                                          <p:spTgt spid="6"/>
+                                        </p:tgtEl>
+                                        <p:attrNameLst>
+                                          <p:attrName>style.visibility</p:attrName>
+                                        </p:attrNameLst>
+                                      </p:cBhvr>
+                                      <p:to>
+                                        <p:strVal val="visible"/>
+                                      </p:to>
+                                    </p:set>
+                                    <p:animEffect transition="in" filter="fade">
+                                      <p:cBhvr>
+                                        <p:cTn id="17" dur="1000"/>
+                                        <p:tgtEl>
+                                          <p:spTgt spid="6"/>
+                                        </p:tgtEl>
+                                      </p:cBhvr>
+                                    </p:animEffect>
+                                    <p:anim calcmode="lin" valueType="num">
+                                      <p:cBhvr>
+                                        <p:cTn id="18" dur="1000" fill="hold"/>
+                                        <p:tgtEl>
+                                          <p:spTgt spid="6"/>
+                                        </p:tgtEl>
+                                        <p:attrNameLst>
+                                          <p:attrName>ppt_x</p:attrName>
+                                        </p:attrNameLst>
+                                      </p:cBhvr>
+                                      <p:tavLst>
+                                        <p:tav tm="0">
+                                          <p:val>
+                                            <p:strVal val="#ppt_x"/>
+                                          </p:val>
+                                        </p:tav>
+                                        <p:tav tm="100000">
+                                          <p:val>
+                                            <p:strVal val="#ppt_x"/>
+                                          </p:val>
+                                        </p:tav>
+                                      </p:tavLst>
+                                    </p:anim>
+                                    <p:anim calcmode="lin" valueType="num">
+                                      <p:cBhvr>
+                                        <p:cTn id="19" dur="1000" fill="hold"/>
+                                        <p:tgtEl>
+                                          <p:spTgt spid="6"/>
+                                        </p:tgtEl>
+                                        <p:attrNameLst>
+                                          <p:attrName>ppt_y</p:attrName>
+                                        </p:attrNameLst>
+                                      </p:cBhvr>
+                                      <p:tavLst>
+                                        <p:tav tm="0">
+                                          <p:val>
+                                            <p:strVal val="#ppt_y+.1"/>
+                                          </p:val>
+                                        </p:tav>
+                                        <p:tav tm="100000">
+                                          <p:val>
+                                            <p:strVal val="#ppt_y"/>
+                                          </p:val>
+                                        </p:tav>
+                                      </p:tavLst>
+                                    </p:anim>
+                                  </p:childTnLst>
+                                </p:cTn>
+                              </p:par>
+                            </p:childTnLst>
+                          </p:cTn>
+                        </p:par>
+                      </p:childTnLst>
+                    </p:cTn>
+                  </p:par>
+                  <p:par>
+                    <p:cTn id="20" fill="hold">
+                      <p:stCondLst>
+                        <p:cond delay="indefinite"/>
+                      </p:stCondLst>
+                      <p:childTnLst>
+                        <p:par>
+                          <p:cTn id="21" fill="hold">
+                            <p:stCondLst>
+                              <p:cond delay="0"/>
+                            </p:stCondLst>
+                            <p:childTnLst>
+                              <p:par>
+                                <p:cTn id="22" presetID="47" presetClass="entr" presetSubtype="0" fill="hold" grpId="0" nodeType="clickEffect">
+                                  <p:stCondLst>
+                                    <p:cond delay="0"/>
+                                  </p:stCondLst>
+                                  <p:childTnLst>
+                                    <p:set>
+                                      <p:cBhvr>
+                                        <p:cTn id="23" dur="1" fill="hold">
+                                          <p:stCondLst>
+                                            <p:cond delay="0"/>
+                                          </p:stCondLst>
+                                        </p:cTn>
+                                        <p:tgtEl>
+                                          <p:spTgt spid="24"/>
+                                        </p:tgtEl>
+                                        <p:attrNameLst>
+                                          <p:attrName>style.visibility</p:attrName>
+                                        </p:attrNameLst>
+                                      </p:cBhvr>
+                                      <p:to>
+                                        <p:strVal val="visible"/>
+                                      </p:to>
+                                    </p:set>
+                                    <p:animEffect transition="in" filter="fade">
+                                      <p:cBhvr>
+                                        <p:cTn id="24" dur="1000"/>
+                                        <p:tgtEl>
+                                          <p:spTgt spid="24"/>
+                                        </p:tgtEl>
+                                      </p:cBhvr>
+                                    </p:animEffect>
+                                    <p:anim calcmode="lin" valueType="num">
+                                      <p:cBhvr>
+                                        <p:cTn id="25" dur="1000" fill="hold"/>
+                                        <p:tgtEl>
+                                          <p:spTgt spid="24"/>
+                                        </p:tgtEl>
+                                        <p:attrNameLst>
+                                          <p:attrName>ppt_x</p:attrName>
+                                        </p:attrNameLst>
+                                      </p:cBhvr>
+                                      <p:tavLst>
+                                        <p:tav tm="0">
+                                          <p:val>
+                                            <p:strVal val="#ppt_x"/>
+                                          </p:val>
+                                        </p:tav>
+                                        <p:tav tm="100000">
+                                          <p:val>
+                                            <p:strVal val="#ppt_x"/>
+                                          </p:val>
+                                        </p:tav>
+                                      </p:tavLst>
+                                    </p:anim>
+                                    <p:anim calcmode="lin" valueType="num">
+                                      <p:cBhvr>
+                                        <p:cTn id="26" dur="1000" fill="hold"/>
+                                        <p:tgtEl>
+                                          <p:spTgt spid="24"/>
+                                        </p:tgtEl>
+                                        <p:attrNameLst>
+                                          <p:attrName>ppt_y</p:attrName>
+                                        </p:attrNameLst>
+                                      </p:cBhvr>
+                                      <p:tavLst>
+                                        <p:tav tm="0">
+                                          <p:val>
+                                            <p:strVal val="#ppt_y-.1"/>
+                                          </p:val>
+                                        </p:tav>
+                                        <p:tav tm="100000">
+                                          <p:val>
+                                            <p:strVal val="#ppt_y"/>
+                                          </p:val>
+                                        </p:tav>
+                                      </p:tavLst>
+                                    </p:anim>
+                                  </p:childTnLst>
+                                </p:cTn>
+                              </p:par>
+                              <p:par>
+                                <p:cTn id="27" presetID="47" presetClass="entr" presetSubtype="0" fill="hold" nodeType="withEffect">
+                                  <p:stCondLst>
+                                    <p:cond delay="0"/>
+                                  </p:stCondLst>
+                                  <p:childTnLst>
+                                    <p:set>
+                                      <p:cBhvr>
+                                        <p:cTn id="28" dur="1" fill="hold">
+                                          <p:stCondLst>
+                                            <p:cond delay="0"/>
+                                          </p:stCondLst>
+                                        </p:cTn>
+                                        <p:tgtEl>
+                                          <p:spTgt spid="22"/>
+                                        </p:tgtEl>
+                                        <p:attrNameLst>
+                                          <p:attrName>style.visibility</p:attrName>
+                                        </p:attrNameLst>
+                                      </p:cBhvr>
+                                      <p:to>
+                                        <p:strVal val="visible"/>
+                                      </p:to>
+                                    </p:set>
+                                    <p:animEffect transition="in" filter="fade">
+                                      <p:cBhvr>
+                                        <p:cTn id="29" dur="1000"/>
+                                        <p:tgtEl>
+                                          <p:spTgt spid="22"/>
+                                        </p:tgtEl>
+                                      </p:cBhvr>
+                                    </p:animEffect>
+                                    <p:anim calcmode="lin" valueType="num">
+                                      <p:cBhvr>
+                                        <p:cTn id="30" dur="1000" fill="hold"/>
+                                        <p:tgtEl>
+                                          <p:spTgt spid="22"/>
+                                        </p:tgtEl>
+                                        <p:attrNameLst>
+                                          <p:attrName>ppt_x</p:attrName>
+                                        </p:attrNameLst>
+                                      </p:cBhvr>
+                                      <p:tavLst>
+                                        <p:tav tm="0">
+                                          <p:val>
+                                            <p:strVal val="#ppt_x"/>
+                                          </p:val>
+                                        </p:tav>
+                                        <p:tav tm="100000">
+                                          <p:val>
+                                            <p:strVal val="#ppt_x"/>
+                                          </p:val>
+                                        </p:tav>
+                                      </p:tavLst>
+                                    </p:anim>
+                                    <p:anim calcmode="lin" valueType="num">
+                                      <p:cBhvr>
+                                        <p:cTn id="31" dur="1000" fill="hold"/>
+                                        <p:tgtEl>
+                                          <p:spTgt spid="22"/>
+                                        </p:tgtEl>
+                                        <p:attrNameLst>
+                                          <p:attrName>ppt_y</p:attrName>
+                                        </p:attrNameLst>
+                                      </p:cBhvr>
+                                      <p:tavLst>
+                                        <p:tav tm="0">
+                                          <p:val>
+                                            <p:strVal val="#ppt_y-.1"/>
+                                          </p:val>
+                                        </p:tav>
+                                        <p:tav tm="100000">
+                                          <p:val>
+                                            <p:strVal val="#ppt_y"/>
+                                          </p:val>
+                                        </p:tav>
+                                      </p:tavLst>
+                                    </p:anim>
+                                  </p:childTnLst>
+                                </p:cTn>
+                              </p:par>
+                              <p:par>
+                                <p:cTn id="32" presetID="47" presetClass="entr" presetSubtype="0" fill="hold" grpId="0" nodeType="withEffect">
+                                  <p:stCondLst>
+                                    <p:cond delay="0"/>
+                                  </p:stCondLst>
+                                  <p:childTnLst>
+                                    <p:set>
+                                      <p:cBhvr>
+                                        <p:cTn id="33" dur="1" fill="hold">
+                                          <p:stCondLst>
+                                            <p:cond delay="0"/>
+                                          </p:stCondLst>
+                                        </p:cTn>
+                                        <p:tgtEl>
+                                          <p:spTgt spid="26"/>
+                                        </p:tgtEl>
+                                        <p:attrNameLst>
+                                          <p:attrName>style.visibility</p:attrName>
+                                        </p:attrNameLst>
+                                      </p:cBhvr>
+                                      <p:to>
+                                        <p:strVal val="visible"/>
+                                      </p:to>
+                                    </p:set>
+                                    <p:animEffect transition="in" filter="fade">
+                                      <p:cBhvr>
+                                        <p:cTn id="34" dur="1000"/>
+                                        <p:tgtEl>
+                                          <p:spTgt spid="26"/>
+                                        </p:tgtEl>
+                                      </p:cBhvr>
+                                    </p:animEffect>
+                                    <p:anim calcmode="lin" valueType="num">
+                                      <p:cBhvr>
+                                        <p:cTn id="35" dur="1000" fill="hold"/>
+                                        <p:tgtEl>
+                                          <p:spTgt spid="26"/>
+                                        </p:tgtEl>
+                                        <p:attrNameLst>
+                                          <p:attrName>ppt_x</p:attrName>
+                                        </p:attrNameLst>
+                                      </p:cBhvr>
+                                      <p:tavLst>
+                                        <p:tav tm="0">
+                                          <p:val>
+                                            <p:strVal val="#ppt_x"/>
+                                          </p:val>
+                                        </p:tav>
+                                        <p:tav tm="100000">
+                                          <p:val>
+                                            <p:strVal val="#ppt_x"/>
+                                          </p:val>
+                                        </p:tav>
+                                      </p:tavLst>
+                                    </p:anim>
+                                    <p:anim calcmode="lin" valueType="num">
+                                      <p:cBhvr>
+                                        <p:cTn id="36" dur="1000" fill="hold"/>
+                                        <p:tgtEl>
+                                          <p:spTgt spid="26"/>
+                                        </p:tgtEl>
+                                        <p:attrNameLst>
+                                          <p:attrName>ppt_y</p:attrName>
+                                        </p:attrNameLst>
+                                      </p:cBhvr>
+                                      <p:tavLst>
+                                        <p:tav tm="0">
+                                          <p:val>
+                                            <p:strVal val="#ppt_y-.1"/>
+                                          </p:val>
+                                        </p:tav>
+                                        <p:tav tm="100000">
+                                          <p:val>
+                                            <p:strVal val="#ppt_y"/>
+                                          </p:val>
+                                        </p:tav>
+                                      </p:tavLst>
+                                    </p:anim>
+                                  </p:childTnLst>
+                                </p:cTn>
+                              </p:par>
+                            </p:childTnLst>
+                          </p:cTn>
+                        </p:par>
+                      </p:childTnLst>
+                    </p:cTn>
+                  </p:par>
+                  <p:par>
+                    <p:cTn id="37" fill="hold">
+                      <p:stCondLst>
+                        <p:cond delay="indefinite"/>
+                      </p:stCondLst>
+                      <p:childTnLst>
+                        <p:par>
+                          <p:cTn id="38" fill="hold">
+                            <p:stCondLst>
+                              <p:cond delay="0"/>
+                            </p:stCondLst>
+                            <p:childTnLst>
+                              <p:par>
+                                <p:cTn id="39" presetID="42" presetClass="entr" presetSubtype="0" fill="hold" grpId="0" nodeType="clickEffect">
+                                  <p:stCondLst>
+                                    <p:cond delay="0"/>
+                                  </p:stCondLst>
+                                  <p:childTnLst>
+                                    <p:set>
+                                      <p:cBhvr>
+                                        <p:cTn id="40" dur="1" fill="hold">
+                                          <p:stCondLst>
+                                            <p:cond delay="0"/>
+                                          </p:stCondLst>
+                                        </p:cTn>
+                                        <p:tgtEl>
+                                          <p:spTgt spid="30"/>
+                                        </p:tgtEl>
+                                        <p:attrNameLst>
+                                          <p:attrName>style.visibility</p:attrName>
+                                        </p:attrNameLst>
+                                      </p:cBhvr>
+                                      <p:to>
+                                        <p:strVal val="visible"/>
+                                      </p:to>
+                                    </p:set>
+                                    <p:animEffect transition="in" filter="fade">
+                                      <p:cBhvr>
+                                        <p:cTn id="41" dur="1000"/>
+                                        <p:tgtEl>
+                                          <p:spTgt spid="30"/>
+                                        </p:tgtEl>
+                                      </p:cBhvr>
+                                    </p:animEffect>
+                                    <p:anim calcmode="lin" valueType="num">
+                                      <p:cBhvr>
+                                        <p:cTn id="42" dur="1000" fill="hold"/>
+                                        <p:tgtEl>
+                                          <p:spTgt spid="30"/>
+                                        </p:tgtEl>
+                                        <p:attrNameLst>
+                                          <p:attrName>ppt_x</p:attrName>
+                                        </p:attrNameLst>
+                                      </p:cBhvr>
+                                      <p:tavLst>
+                                        <p:tav tm="0">
+                                          <p:val>
+                                            <p:strVal val="#ppt_x"/>
+                                          </p:val>
+                                        </p:tav>
+                                        <p:tav tm="100000">
+                                          <p:val>
+                                            <p:strVal val="#ppt_x"/>
+                                          </p:val>
+                                        </p:tav>
+                                      </p:tavLst>
+                                    </p:anim>
+                                    <p:anim calcmode="lin" valueType="num">
+                                      <p:cBhvr>
+                                        <p:cTn id="43" dur="1000" fill="hold"/>
+                                        <p:tgtEl>
+                                          <p:spTgt spid="30"/>
+                                        </p:tgtEl>
+                                        <p:attrNameLst>
+                                          <p:attrName>ppt_y</p:attrName>
+                                        </p:attrNameLst>
+                                      </p:cBhvr>
+                                      <p:tavLst>
+                                        <p:tav tm="0">
+                                          <p:val>
+                                            <p:strVal val="#ppt_y+.1"/>
+                                          </p:val>
+                                        </p:tav>
+                                        <p:tav tm="100000">
+                                          <p:val>
+                                            <p:strVal val="#ppt_y"/>
+                                          </p:val>
+                                        </p:tav>
+                                      </p:tavLst>
+                                    </p:anim>
+                                  </p:childTnLst>
+                                </p:cTn>
+                              </p:par>
+                              <p:par>
+                                <p:cTn id="44" presetID="42" presetClass="entr" presetSubtype="0" fill="hold" grpId="0" nodeType="withEffect">
+                                  <p:stCondLst>
+                                    <p:cond delay="0"/>
+                                  </p:stCondLst>
+                                  <p:childTnLst>
+                                    <p:set>
+                                      <p:cBhvr>
+                                        <p:cTn id="45" dur="1" fill="hold">
+                                          <p:stCondLst>
+                                            <p:cond delay="0"/>
+                                          </p:stCondLst>
+                                        </p:cTn>
+                                        <p:tgtEl>
+                                          <p:spTgt spid="20"/>
+                                        </p:tgtEl>
+                                        <p:attrNameLst>
+                                          <p:attrName>style.visibility</p:attrName>
+                                        </p:attrNameLst>
+                                      </p:cBhvr>
+                                      <p:to>
+                                        <p:strVal val="visible"/>
+                                      </p:to>
+                                    </p:set>
+                                    <p:animEffect transition="in" filter="fade">
+                                      <p:cBhvr>
+                                        <p:cTn id="46" dur="1000"/>
+                                        <p:tgtEl>
+                                          <p:spTgt spid="20"/>
+                                        </p:tgtEl>
+                                      </p:cBhvr>
+                                    </p:animEffect>
+                                    <p:anim calcmode="lin" valueType="num">
+                                      <p:cBhvr>
+                                        <p:cTn id="47" dur="1000" fill="hold"/>
+                                        <p:tgtEl>
+                                          <p:spTgt spid="20"/>
+                                        </p:tgtEl>
+                                        <p:attrNameLst>
+                                          <p:attrName>ppt_x</p:attrName>
+                                        </p:attrNameLst>
+                                      </p:cBhvr>
+                                      <p:tavLst>
+                                        <p:tav tm="0">
+                                          <p:val>
+                                            <p:strVal val="#ppt_x"/>
+                                          </p:val>
+                                        </p:tav>
+                                        <p:tav tm="100000">
+                                          <p:val>
+                                            <p:strVal val="#ppt_x"/>
+                                          </p:val>
+                                        </p:tav>
+                                      </p:tavLst>
+                                    </p:anim>
+                                    <p:anim calcmode="lin" valueType="num">
+                                      <p:cBhvr>
+                                        <p:cTn id="48" dur="1000" fill="hold"/>
+                                        <p:tgtEl>
+                                          <p:spTgt spid="20"/>
+                                        </p:tgtEl>
+                                        <p:attrNameLst>
+                                          <p:attrName>ppt_y</p:attrName>
+                                        </p:attrNameLst>
+                                      </p:cBhvr>
+                                      <p:tavLst>
+                                        <p:tav tm="0">
+                                          <p:val>
+                                            <p:strVal val="#ppt_y+.1"/>
+                                          </p:val>
+                                        </p:tav>
+                                        <p:tav tm="100000">
+                                          <p:val>
+                                            <p:strVal val="#ppt_y"/>
+                                          </p:val>
+                                        </p:tav>
+                                      </p:tavLst>
+                                    </p:anim>
+                                  </p:childTnLst>
+                                </p:cTn>
+                              </p:par>
+                              <p:par>
+                                <p:cTn id="49" presetID="42" presetClass="entr" presetSubtype="0" fill="hold" nodeType="withEffect">
+                                  <p:stCondLst>
+                                    <p:cond delay="0"/>
+                                  </p:stCondLst>
+                                  <p:childTnLst>
+                                    <p:set>
+                                      <p:cBhvr>
+                                        <p:cTn id="50" dur="1" fill="hold">
+                                          <p:stCondLst>
+                                            <p:cond delay="0"/>
+                                          </p:stCondLst>
+                                        </p:cTn>
+                                        <p:tgtEl>
+                                          <p:spTgt spid="18"/>
+                                        </p:tgtEl>
+                                        <p:attrNameLst>
+                                          <p:attrName>style.visibility</p:attrName>
+                                        </p:attrNameLst>
+                                      </p:cBhvr>
+                                      <p:to>
+                                        <p:strVal val="visible"/>
+                                      </p:to>
+                                    </p:set>
+                                    <p:animEffect transition="in" filter="fade">
+                                      <p:cBhvr>
+                                        <p:cTn id="51" dur="1000"/>
+                                        <p:tgtEl>
+                                          <p:spTgt spid="18"/>
+                                        </p:tgtEl>
+                                      </p:cBhvr>
+                                    </p:animEffect>
+                                    <p:anim calcmode="lin" valueType="num">
+                                      <p:cBhvr>
+                                        <p:cTn id="52" dur="1000" fill="hold"/>
+                                        <p:tgtEl>
+                                          <p:spTgt spid="18"/>
+                                        </p:tgtEl>
+                                        <p:attrNameLst>
+                                          <p:attrName>ppt_x</p:attrName>
+                                        </p:attrNameLst>
+                                      </p:cBhvr>
+                                      <p:tavLst>
+                                        <p:tav tm="0">
+                                          <p:val>
+                                            <p:strVal val="#ppt_x"/>
+                                          </p:val>
+                                        </p:tav>
+                                        <p:tav tm="100000">
+                                          <p:val>
+                                            <p:strVal val="#ppt_x"/>
+                                          </p:val>
+                                        </p:tav>
+                                      </p:tavLst>
+                                    </p:anim>
+                                    <p:anim calcmode="lin" valueType="num">
+                                      <p:cBhvr>
+                                        <p:cTn id="53" dur="1000" fill="hold"/>
+                                        <p:tgtEl>
+                                          <p:spTgt spid="18"/>
+                                        </p:tgtEl>
+                                        <p:attrNameLst>
+                                          <p:attrName>ppt_y</p:attrName>
+                                        </p:attrNameLst>
+                                      </p:cBhvr>
+                                      <p:tavLst>
+                                        <p:tav tm="0">
+                                          <p:val>
+                                            <p:strVal val="#ppt_y+.1"/>
+                                          </p:val>
+                                        </p:tav>
+                                        <p:tav tm="100000">
+                                          <p:val>
+                                            <p:strVal val="#ppt_y"/>
+                                          </p:val>
+                                        </p:tav>
+                                      </p:tavLst>
+                                    </p:anim>
+                                  </p:childTnLst>
+                                </p:cTn>
+                              </p:par>
+                            </p:childTnLst>
+                          </p:cTn>
+                        </p:par>
+                      </p:childTnLst>
+                    </p:cTn>
+                  </p:par>
+                </p:childTnLst>
+              </p:cTn>
+              <p:prevCondLst>
+                <p:cond evt="onPrev" delay="0">
+                  <p:tgtEl>
+                    <p:sldTgt/>
+                  </p:tgtEl>
+                </p:cond>
+              </p:prevCondLst>
+              <p:nextCondLst>
+                <p:cond evt="onNext" delay="0">
+                  <p:tgtEl>
+                    <p:sldTgt/>
+                  </p:tgtEl>
+                </p:cond>
+              </p:nextCondLst>
+            </p:seq>
+          </p:childTnLst>
+        </p:cTn>
+      </p:par>
+    </p:tnLst>
+    <p:bldLst>
+      <p:bldP spid="5" grpId="0"/>
+      <p:bldP spid="6" grpId="0"/>
+      <p:bldP spid="20" grpId="0"/>
+      <p:bldP spid="24" grpId="0"/>
+      <p:bldP spid="26" grpId="0"/>
+      <p:bldP spid="30" grpId="0"/>
+    </p:bldLst>
+  </p:timing>
 </p:sld>
 </file>
 

</xml_diff>